<commit_message>
docs: refresh readmes and presentation
</commit_message>
<xml_diff>
--- a/Presentation/FutureMe_Project_Presentation.pptx
+++ b/Presentation/FutureMe_Project_Presentation.pptx
@@ -2,27 +2,27 @@
 <file path=ppt/presentation.xml><?xml version="1.0" encoding="utf-8"?>
 <p:presentation xmlns:p="http://schemas.openxmlformats.org/presentationml/2006/main">
   <p:sldMasterIdLst>
-    <p:sldMasterId xmlns:r="http://schemas.openxmlformats.org/officeDocument/2006/relationships" id="2147483648" r:id="Rd65914bf24a248be"/>
+    <p:sldMasterId xmlns:r="http://schemas.openxmlformats.org/officeDocument/2006/relationships" id="2147483648" r:id="R7094ddbbe93a4f5a"/>
   </p:sldMasterIdLst>
   <p:notesMasterIdLst>
-    <p:notesMasterId xmlns:r="http://schemas.openxmlformats.org/officeDocument/2006/relationships" r:id="R682807080c874123"/>
+    <p:notesMasterId xmlns:r="http://schemas.openxmlformats.org/officeDocument/2006/relationships" r:id="R8073e5e1d9cc4904"/>
   </p:notesMasterIdLst>
   <p:sldIdLst>
-    <p:sldId xmlns:r="http://schemas.openxmlformats.org/officeDocument/2006/relationships" id="256" r:id="R1bfdaa6deee44876"/>
-    <p:sldId xmlns:r="http://schemas.openxmlformats.org/officeDocument/2006/relationships" id="257" r:id="R1535b352722146de"/>
-    <p:sldId xmlns:r="http://schemas.openxmlformats.org/officeDocument/2006/relationships" id="258" r:id="R273a3ec498924cc8"/>
-    <p:sldId xmlns:r="http://schemas.openxmlformats.org/officeDocument/2006/relationships" id="259" r:id="Reb367167c6704d1d"/>
-    <p:sldId xmlns:r="http://schemas.openxmlformats.org/officeDocument/2006/relationships" id="260" r:id="Rccfdcbd245854cc2"/>
-    <p:sldId xmlns:r="http://schemas.openxmlformats.org/officeDocument/2006/relationships" id="261" r:id="R31829015e7384da6"/>
-    <p:sldId xmlns:r="http://schemas.openxmlformats.org/officeDocument/2006/relationships" id="262" r:id="R98fb1791878b4cb9"/>
-    <p:sldId xmlns:r="http://schemas.openxmlformats.org/officeDocument/2006/relationships" id="263" r:id="Rcf05e42704a7413f"/>
-    <p:sldId xmlns:r="http://schemas.openxmlformats.org/officeDocument/2006/relationships" id="264" r:id="R5d1d3f4657ee47f2"/>
-    <p:sldId xmlns:r="http://schemas.openxmlformats.org/officeDocument/2006/relationships" id="265" r:id="Rf2a4bb56356949e1"/>
-    <p:sldId xmlns:r="http://schemas.openxmlformats.org/officeDocument/2006/relationships" id="266" r:id="Rf7f308c04a45496a"/>
-    <p:sldId xmlns:r="http://schemas.openxmlformats.org/officeDocument/2006/relationships" id="267" r:id="R670a9c2b53b04fdb"/>
-    <p:sldId xmlns:r="http://schemas.openxmlformats.org/officeDocument/2006/relationships" id="268" r:id="R483bc21060f542ec"/>
-    <p:sldId xmlns:r="http://schemas.openxmlformats.org/officeDocument/2006/relationships" id="269" r:id="Rd8f0832dacd9435f"/>
-    <p:sldId xmlns:r="http://schemas.openxmlformats.org/officeDocument/2006/relationships" id="270" r:id="Red0f7d45d767452f"/>
+    <p:sldId xmlns:r="http://schemas.openxmlformats.org/officeDocument/2006/relationships" id="256" r:id="Rff8adb23ee2b4f63"/>
+    <p:sldId xmlns:r="http://schemas.openxmlformats.org/officeDocument/2006/relationships" id="257" r:id="Rbf47c7534741407e"/>
+    <p:sldId xmlns:r="http://schemas.openxmlformats.org/officeDocument/2006/relationships" id="258" r:id="R1f5bd94ec06c4aeb"/>
+    <p:sldId xmlns:r="http://schemas.openxmlformats.org/officeDocument/2006/relationships" id="259" r:id="R76cf64df602e4bfd"/>
+    <p:sldId xmlns:r="http://schemas.openxmlformats.org/officeDocument/2006/relationships" id="260" r:id="R2404a7faeefe4801"/>
+    <p:sldId xmlns:r="http://schemas.openxmlformats.org/officeDocument/2006/relationships" id="261" r:id="Rf615e8877c854422"/>
+    <p:sldId xmlns:r="http://schemas.openxmlformats.org/officeDocument/2006/relationships" id="262" r:id="R21f6784c81a0478a"/>
+    <p:sldId xmlns:r="http://schemas.openxmlformats.org/officeDocument/2006/relationships" id="263" r:id="R9799b24dcebf4bfe"/>
+    <p:sldId xmlns:r="http://schemas.openxmlformats.org/officeDocument/2006/relationships" id="264" r:id="R57bfba2ad1a54080"/>
+    <p:sldId xmlns:r="http://schemas.openxmlformats.org/officeDocument/2006/relationships" id="265" r:id="Re459bddfd2974021"/>
+    <p:sldId xmlns:r="http://schemas.openxmlformats.org/officeDocument/2006/relationships" id="266" r:id="R073d63f588754895"/>
+    <p:sldId xmlns:r="http://schemas.openxmlformats.org/officeDocument/2006/relationships" id="267" r:id="Rc03cee49b4074ca2"/>
+    <p:sldId xmlns:r="http://schemas.openxmlformats.org/officeDocument/2006/relationships" id="268" r:id="R572aa0e1d6e546f8"/>
+    <p:sldId xmlns:r="http://schemas.openxmlformats.org/officeDocument/2006/relationships" id="269" r:id="R74fadf0998174441"/>
+    <p:sldId xmlns:r="http://schemas.openxmlformats.org/officeDocument/2006/relationships" id="270" r:id="Rbb8be573a95843b4"/>
   </p:sldIdLst>
   <p:sldSz cx="12191695" cy="6858000"/>
   <p:notesSz cx="6858000" cy="9144000"/>
@@ -477,7 +477,31 @@
         <p:txBody>
           <a:bodyPr xmlns:a="http://schemas.openxmlformats.org/drawingml/2006/main"/>
           <a:lstStyle xmlns:a="http://schemas.openxmlformats.org/drawingml/2006/main"/>
-          <a:p xmlns:a="http://schemas.openxmlformats.org/drawingml/2006/main"/>
+          <a:p xmlns:a="http://schemas.openxmlformats.org/drawingml/2006/main">
+            <a:r>
+              <a:t>Opening: FutureMe helps a learner choose the next experiment, not a permanent identity.</a:t>
+            </a:r>
+          </a:p>
+          <a:p xmlns:a="http://schemas.openxmlformats.org/drawingml/2006/main">
+            <a:r>
+              <a:t>[Sources]</a:t>
+            </a:r>
+          </a:p>
+          <a:p xmlns:a="http://schemas.openxmlformats.org/drawingml/2006/main">
+            <a:r>
+              <a:t>- README.md — current product boundary and status</a:t>
+            </a:r>
+          </a:p>
+          <a:p xmlns:a="http://schemas.openxmlformats.org/drawingml/2006/main">
+            <a:r>
+              <a:t>- 03_WebApp/Pre_Present/READMEEN.md — implemented learner journey</a:t>
+            </a:r>
+          </a:p>
+          <a:p xmlns:a="http://schemas.openxmlformats.org/drawingml/2006/main">
+            <a:r>
+              <a:t>[/Sources]</a:t>
+            </a:r>
+          </a:p>
         </p:txBody>
       </p:sp>
       <p:sp>
@@ -543,7 +567,41 @@
         <p:txBody>
           <a:bodyPr xmlns:a="http://schemas.openxmlformats.org/drawingml/2006/main"/>
           <a:lstStyle xmlns:a="http://schemas.openxmlformats.org/drawingml/2006/main"/>
-          <a:p xmlns:a="http://schemas.openxmlformats.org/drawingml/2006/main"/>
+          <a:p xmlns:a="http://schemas.openxmlformats.org/drawingml/2006/main">
+            <a:r>
+              <a:t>The 90-item and 1,000-item banks are future research inputs. Neither is imported by the live interview.</a:t>
+            </a:r>
+          </a:p>
+          <a:p xmlns:a="http://schemas.openxmlformats.org/drawingml/2006/main">
+            <a:r>
+              <a:t>[Sources]</a:t>
+            </a:r>
+          </a:p>
+          <a:p xmlns:a="http://schemas.openxmlformats.org/drawingml/2006/main">
+            <a:r>
+              <a:t>- 01_Research/Adaptive_Questionnaire/README.md — 90-item design boundary</a:t>
+            </a:r>
+          </a:p>
+          <a:p xmlns:a="http://schemas.openxmlformats.org/drawingml/2006/main">
+            <a:r>
+              <a:t>- 03_WebApp/Pre_Present/data/question_bank_1000.json — restored research bank</a:t>
+            </a:r>
+          </a:p>
+          <a:p xmlns:a="http://schemas.openxmlformats.org/drawingml/2006/main">
+            <a:r>
+              <a:t>- 03_WebApp/Pre_Present/scripts/validate-future-question-bank.mjs — structural validation</a:t>
+            </a:r>
+          </a:p>
+          <a:p xmlns:a="http://schemas.openxmlformats.org/drawingml/2006/main">
+            <a:r>
+              <a:t>- 03_WebApp/Pre_Present/docs/05-system-architecture.md — current/planned architecture boundary</a:t>
+            </a:r>
+          </a:p>
+          <a:p xmlns:a="http://schemas.openxmlformats.org/drawingml/2006/main">
+            <a:r>
+              <a:t>[/Sources]</a:t>
+            </a:r>
+          </a:p>
         </p:txBody>
       </p:sp>
       <p:sp>
@@ -609,7 +667,31 @@
         <p:txBody>
           <a:bodyPr xmlns:a="http://schemas.openxmlformats.org/drawingml/2006/main"/>
           <a:lstStyle xmlns:a="http://schemas.openxmlformats.org/drawingml/2006/main"/>
-          <a:p xmlns:a="http://schemas.openxmlformats.org/drawingml/2006/main"/>
+          <a:p xmlns:a="http://schemas.openxmlformats.org/drawingml/2006/main">
+            <a:r>
+              <a:t>Eligibility, scoring, refusal, ties and ordering are deterministic. The fixed weights are design judgement.</a:t>
+            </a:r>
+          </a:p>
+          <a:p xmlns:a="http://schemas.openxmlformats.org/drawingml/2006/main">
+            <a:r>
+              <a:t>[Sources]</a:t>
+            </a:r>
+          </a:p>
+          <a:p xmlns:a="http://schemas.openxmlformats.org/drawingml/2006/main">
+            <a:r>
+              <a:t>- 03_WebApp/Pre_Present/lib/decision-engine — current implementation</a:t>
+            </a:r>
+          </a:p>
+          <a:p xmlns:a="http://schemas.openxmlformats.org/drawingml/2006/main">
+            <a:r>
+              <a:t>- 03_WebApp/Pre_Present/docs/04-ai-system.md — scoring and AI boundary</a:t>
+            </a:r>
+          </a:p>
+          <a:p xmlns:a="http://schemas.openxmlformats.org/drawingml/2006/main">
+            <a:r>
+              <a:t>[/Sources]</a:t>
+            </a:r>
+          </a:p>
         </p:txBody>
       </p:sp>
       <p:sp>
@@ -675,7 +757,41 @@
         <p:txBody>
           <a:bodyPr xmlns:a="http://schemas.openxmlformats.org/drawingml/2006/main"/>
           <a:lstStyle xmlns:a="http://schemas.openxmlformats.org/drawingml/2006/main"/>
-          <a:p xmlns:a="http://schemas.openxmlformats.org/drawingml/2006/main"/>
+          <a:p xmlns:a="http://schemas.openxmlformats.org/drawingml/2006/main">
+            <a:r>
+              <a:t>Screenshots were captured from the current app and retained at their inherited crop and placement.</a:t>
+            </a:r>
+          </a:p>
+          <a:p xmlns:a="http://schemas.openxmlformats.org/drawingml/2006/main">
+            <a:r>
+              <a:t>[Sources]</a:t>
+            </a:r>
+          </a:p>
+          <a:p xmlns:a="http://schemas.openxmlformats.org/drawingml/2006/main">
+            <a:r>
+              <a:t>- 03_WebApp/Pre_Present/assets/screenshots/app/interview-2026-08-09.png — Reflect screen</a:t>
+            </a:r>
+          </a:p>
+          <a:p xmlns:a="http://schemas.openxmlformats.org/drawingml/2006/main">
+            <a:r>
+              <a:t>- 03_WebApp/Pre_Present/assets/screenshots/app/routes-2026-08-09.png — Explore screen</a:t>
+            </a:r>
+          </a:p>
+          <a:p xmlns:a="http://schemas.openxmlformats.org/drawingml/2006/main">
+            <a:r>
+              <a:t>- 03_WebApp/Pre_Present/assets/screenshots/app/plan-2026-08-09.png — Act screen</a:t>
+            </a:r>
+          </a:p>
+          <a:p xmlns:a="http://schemas.openxmlformats.org/drawingml/2006/main">
+            <a:r>
+              <a:t>- npm test, 11 Aug 2026 — 26 files and 529 tests passed</a:t>
+            </a:r>
+          </a:p>
+          <a:p xmlns:a="http://schemas.openxmlformats.org/drawingml/2006/main">
+            <a:r>
+              <a:t>[/Sources]</a:t>
+            </a:r>
+          </a:p>
         </p:txBody>
       </p:sp>
       <p:sp>
@@ -741,7 +857,31 @@
         <p:txBody>
           <a:bodyPr xmlns:a="http://schemas.openxmlformats.org/drawingml/2006/main"/>
           <a:lstStyle xmlns:a="http://schemas.openxmlformats.org/drawingml/2006/main"/>
-          <a:p xmlns:a="http://schemas.openxmlformats.org/drawingml/2006/main"/>
+          <a:p xmlns:a="http://schemas.openxmlformats.org/drawingml/2006/main">
+            <a:r>
+              <a:t>FutureMe continues after the score by making evidence, uncertainty and a reversible action visible.</a:t>
+            </a:r>
+          </a:p>
+          <a:p xmlns:a="http://schemas.openxmlformats.org/drawingml/2006/main">
+            <a:r>
+              <a:t>[Sources]</a:t>
+            </a:r>
+          </a:p>
+          <a:p xmlns:a="http://schemas.openxmlformats.org/drawingml/2006/main">
+            <a:r>
+              <a:t>- 03_WebApp/Pre_Present/docs/03-user-experience.md — evidence-loop UX</a:t>
+            </a:r>
+          </a:p>
+          <a:p xmlns:a="http://schemas.openxmlformats.org/drawingml/2006/main">
+            <a:r>
+              <a:t>- 03_WebApp/Pre_Present/READMEEN.md — implemented comparison and plan</a:t>
+            </a:r>
+          </a:p>
+          <a:p xmlns:a="http://schemas.openxmlformats.org/drawingml/2006/main">
+            <a:r>
+              <a:t>[/Sources]</a:t>
+            </a:r>
+          </a:p>
         </p:txBody>
       </p:sp>
       <p:sp>
@@ -807,7 +947,36 @@
         <p:txBody>
           <a:bodyPr xmlns:a="http://schemas.openxmlformats.org/drawingml/2006/main"/>
           <a:lstStyle xmlns:a="http://schemas.openxmlformats.org/drawingml/2006/main"/>
-          <a:p xmlns:a="http://schemas.openxmlformats.org/drawingml/2006/main"/>
+          <a:p xmlns:a="http://schemas.openxmlformats.org/drawingml/2006/main">
+            <a:r>
+              <a:t>Passing code and synthetic-pipeline checks does not establish reliability, validity, fairness or effectiveness.</a:t>
+            </a:r>
+          </a:p>
+          <a:p xmlns:a="http://schemas.openxmlformats.org/drawingml/2006/main">
+            <a:r>
+              <a:t>[Sources]</a:t>
+            </a:r>
+          </a:p>
+          <a:p xmlns:a="http://schemas.openxmlformats.org/drawingml/2006/main">
+            <a:r>
+              <a:t>- 03_WebApp/Pre_Present/docs/validation-plan.md — validation sequence</a:t>
+            </a:r>
+          </a:p>
+          <a:p xmlns:a="http://schemas.openxmlformats.org/drawingml/2006/main">
+            <a:r>
+              <a:t>- 03_WebApp/Pre_Present/docs/pilot-protocol.md — proposed pilot gates</a:t>
+            </a:r>
+          </a:p>
+          <a:p xmlns:a="http://schemas.openxmlformats.org/drawingml/2006/main">
+            <a:r>
+              <a:t>- 01_Research/Adaptive_Questionnaire/sim/README.md — limits of synthetic respondents</a:t>
+            </a:r>
+          </a:p>
+          <a:p xmlns:a="http://schemas.openxmlformats.org/drawingml/2006/main">
+            <a:r>
+              <a:t>[/Sources]</a:t>
+            </a:r>
+          </a:p>
         </p:txBody>
       </p:sp>
       <p:sp>
@@ -873,7 +1042,36 @@
         <p:txBody>
           <a:bodyPr xmlns:a="http://schemas.openxmlformats.org/drawingml/2006/main"/>
           <a:lstStyle xmlns:a="http://schemas.openxmlformats.org/drawingml/2006/main"/>
-          <a:p xmlns:a="http://schemas.openxmlformats.org/drawingml/2006/main"/>
+          <a:p xmlns:a="http://schemas.openxmlformats.org/drawingml/2006/main">
+            <a:r>
+              <a:t>Do not present school, platform or cloud partnerships as confirmed until an agreement exists.</a:t>
+            </a:r>
+          </a:p>
+          <a:p xmlns:a="http://schemas.openxmlformats.org/drawingml/2006/main">
+            <a:r>
+              <a:t>[Sources]</a:t>
+            </a:r>
+          </a:p>
+          <a:p xmlns:a="http://schemas.openxmlformats.org/drawingml/2006/main">
+            <a:r>
+              <a:t>- README.md — current status and repository boundary</a:t>
+            </a:r>
+          </a:p>
+          <a:p xmlns:a="http://schemas.openxmlformats.org/drawingml/2006/main">
+            <a:r>
+              <a:t>- 03_WebApp/Pre_Present/docs/07-roadmap.md — staged roadmap</a:t>
+            </a:r>
+          </a:p>
+          <a:p xmlns:a="http://schemas.openxmlformats.org/drawingml/2006/main">
+            <a:r>
+              <a:t>- 01_Research/Data/REFERENCES.md — source registry</a:t>
+            </a:r>
+          </a:p>
+          <a:p xmlns:a="http://schemas.openxmlformats.org/drawingml/2006/main">
+            <a:r>
+              <a:t>[/Sources]</a:t>
+            </a:r>
+          </a:p>
         </p:txBody>
       </p:sp>
       <p:sp>
@@ -939,7 +1137,31 @@
         <p:txBody>
           <a:bodyPr xmlns:a="http://schemas.openxmlformats.org/drawingml/2006/main"/>
           <a:lstStyle xmlns:a="http://schemas.openxmlformats.org/drawingml/2006/main"/>
-          <a:p xmlns:a="http://schemas.openxmlformats.org/drawingml/2006/main"/>
+          <a:p xmlns:a="http://schemas.openxmlformats.org/drawingml/2006/main">
+            <a:r>
+              <a:t>The choice-point examples are context, not evidence that FutureMe improves outcomes.</a:t>
+            </a:r>
+          </a:p>
+          <a:p xmlns:a="http://schemas.openxmlformats.org/drawingml/2006/main">
+            <a:r>
+              <a:t>[Sources]</a:t>
+            </a:r>
+          </a:p>
+          <a:p xmlns:a="http://schemas.openxmlformats.org/drawingml/2006/main">
+            <a:r>
+              <a:t>- 03_WebApp/Pre_Present/docs/02-research-and-evidence.md — Thai education and mismatch evidence</a:t>
+            </a:r>
+          </a:p>
+          <a:p xmlns:a="http://schemas.openxmlformats.org/drawingml/2006/main">
+            <a:r>
+              <a:t>- 01_Research/Data/SOURCE_AUDIT.md — claim-status audit</a:t>
+            </a:r>
+          </a:p>
+          <a:p xmlns:a="http://schemas.openxmlformats.org/drawingml/2006/main">
+            <a:r>
+              <a:t>[/Sources]</a:t>
+            </a:r>
+          </a:p>
         </p:txBody>
       </p:sp>
       <p:sp>
@@ -1005,7 +1227,36 @@
         <p:txBody>
           <a:bodyPr xmlns:a="http://schemas.openxmlformats.org/drawingml/2006/main"/>
           <a:lstStyle xmlns:a="http://schemas.openxmlformats.org/drawingml/2006/main"/>
-          <a:p xmlns:a="http://schemas.openxmlformats.org/drawingml/2006/main"/>
+          <a:p xmlns:a="http://schemas.openxmlformats.org/drawingml/2006/main">
+            <a:r>
+              <a:t>Do not combine the percentages causally; their scopes and denominators differ.</a:t>
+            </a:r>
+          </a:p>
+          <a:p xmlns:a="http://schemas.openxmlformats.org/drawingml/2006/main">
+            <a:r>
+              <a:t>[Sources]</a:t>
+            </a:r>
+          </a:p>
+          <a:p xmlns:a="http://schemas.openxmlformats.org/drawingml/2006/main">
+            <a:r>
+              <a:t>- https://tdri.or.th/2025/09/thailand-human-capital-development/ — 56% and 27% public context</a:t>
+            </a:r>
+          </a:p>
+          <a:p xmlns:a="http://schemas.openxmlformats.org/drawingml/2006/main">
+            <a:r>
+              <a:t>- https://www.weforum.org/publications/the-future-of-jobs-report-2025/in-full/3-skills-outlook/ — 39% core-skills outlook</a:t>
+            </a:r>
+          </a:p>
+          <a:p xmlns:a="http://schemas.openxmlformats.org/drawingml/2006/main">
+            <a:r>
+              <a:t>- 01_Research/Data/SOURCE_AUDIT.md — interpretation limits</a:t>
+            </a:r>
+          </a:p>
+          <a:p xmlns:a="http://schemas.openxmlformats.org/drawingml/2006/main">
+            <a:r>
+              <a:t>[/Sources]</a:t>
+            </a:r>
+          </a:p>
         </p:txBody>
       </p:sp>
       <p:sp>
@@ -1071,7 +1322,36 @@
         <p:txBody>
           <a:bodyPr xmlns:a="http://schemas.openxmlformats.org/drawingml/2006/main"/>
           <a:lstStyle xmlns:a="http://schemas.openxmlformats.org/drawingml/2006/main"/>
-          <a:p xmlns:a="http://schemas.openxmlformats.org/drawingml/2006/main"/>
+          <a:p xmlns:a="http://schemas.openxmlformats.org/drawingml/2006/main">
+            <a:r>
+              <a:t>This is the current demo-data flow. Unknown values remain unknown instead of being inferred.</a:t>
+            </a:r>
+          </a:p>
+          <a:p xmlns:a="http://schemas.openxmlformats.org/drawingml/2006/main">
+            <a:r>
+              <a:t>[Sources]</a:t>
+            </a:r>
+          </a:p>
+          <a:p xmlns:a="http://schemas.openxmlformats.org/drawingml/2006/main">
+            <a:r>
+              <a:t>- 01_Research/Geography_and_Access/README.md — pipeline, counts and limitations</a:t>
+            </a:r>
+          </a:p>
+          <a:p xmlns:a="http://schemas.openxmlformats.org/drawingml/2006/main">
+            <a:r>
+              <a:t>- 01_Research/Geography_and_Access/PROVENANCE.json — dates, licences and full checksums</a:t>
+            </a:r>
+          </a:p>
+          <a:p xmlns:a="http://schemas.openxmlformats.org/drawingml/2006/main">
+            <a:r>
+              <a:t>- 03_WebApp/Pre_Present/scripts/validate-research-data.mjs — integrity checks</a:t>
+            </a:r>
+          </a:p>
+          <a:p xmlns:a="http://schemas.openxmlformats.org/drawingml/2006/main">
+            <a:r>
+              <a:t>[/Sources]</a:t>
+            </a:r>
+          </a:p>
         </p:txBody>
       </p:sp>
       <p:sp>
@@ -1137,7 +1417,31 @@
         <p:txBody>
           <a:bodyPr xmlns:a="http://schemas.openxmlformats.org/drawingml/2006/main"/>
           <a:lstStyle xmlns:a="http://schemas.openxmlformats.org/drawingml/2006/main"/>
-          <a:p xmlns:a="http://schemas.openxmlformats.org/drawingml/2006/main"/>
+          <a:p xmlns:a="http://schemas.openxmlformats.org/drawingml/2006/main">
+            <a:r>
+              <a:t>The route hypotheses are deliberately reversible.</a:t>
+            </a:r>
+          </a:p>
+          <a:p xmlns:a="http://schemas.openxmlformats.org/drawingml/2006/main">
+            <a:r>
+              <a:t>[Sources]</a:t>
+            </a:r>
+          </a:p>
+          <a:p xmlns:a="http://schemas.openxmlformats.org/drawingml/2006/main">
+            <a:r>
+              <a:t>- 03_WebApp/Pre_Present/docs/01-project-overview.md — product thesis</a:t>
+            </a:r>
+          </a:p>
+          <a:p xmlns:a="http://schemas.openxmlformats.org/drawingml/2006/main">
+            <a:r>
+              <a:t>- 03_WebApp/Pre_Present/docs/03-user-experience.md — evidence-loop design</a:t>
+            </a:r>
+          </a:p>
+          <a:p xmlns:a="http://schemas.openxmlformats.org/drawingml/2006/main">
+            <a:r>
+              <a:t>[/Sources]</a:t>
+            </a:r>
+          </a:p>
         </p:txBody>
       </p:sp>
       <p:sp>
@@ -1203,7 +1507,31 @@
         <p:txBody>
           <a:bodyPr xmlns:a="http://schemas.openxmlformats.org/drawingml/2006/main"/>
           <a:lstStyle xmlns:a="http://schemas.openxmlformats.org/drawingml/2006/main"/>
-          <a:p xmlns:a="http://schemas.openxmlformats.org/drawingml/2006/main"/>
+          <a:p xmlns:a="http://schemas.openxmlformats.org/drawingml/2006/main">
+            <a:r>
+              <a:t>RIASEC structures reflection; it does not make this project-specific instrument validated.</a:t>
+            </a:r>
+          </a:p>
+          <a:p xmlns:a="http://schemas.openxmlformats.org/drawingml/2006/main">
+            <a:r>
+              <a:t>[Sources]</a:t>
+            </a:r>
+          </a:p>
+          <a:p xmlns:a="http://schemas.openxmlformats.org/drawingml/2006/main">
+            <a:r>
+              <a:t>- 03_WebApp/Pre_Present/docs/questionnaire-methodology.md — construct and item provenance</a:t>
+            </a:r>
+          </a:p>
+          <a:p xmlns:a="http://schemas.openxmlformats.org/drawingml/2006/main">
+            <a:r>
+              <a:t>- 01_Research/Adaptive_Questionnaire/README.md — research-only adaptive design</a:t>
+            </a:r>
+          </a:p>
+          <a:p xmlns:a="http://schemas.openxmlformats.org/drawingml/2006/main">
+            <a:r>
+              <a:t>[/Sources]</a:t>
+            </a:r>
+          </a:p>
         </p:txBody>
       </p:sp>
       <p:sp>
@@ -1269,7 +1597,31 @@
         <p:txBody>
           <a:bodyPr xmlns:a="http://schemas.openxmlformats.org/drawingml/2006/main"/>
           <a:lstStyle xmlns:a="http://schemas.openxmlformats.org/drawingml/2006/main"/>
-          <a:p xmlns:a="http://schemas.openxmlformats.org/drawingml/2006/main"/>
+          <a:p xmlns:a="http://schemas.openxmlformats.org/drawingml/2006/main">
+            <a:r>
+              <a:t>These rules are product principles derived from the source audit and safeguarding boundary.</a:t>
+            </a:r>
+          </a:p>
+          <a:p xmlns:a="http://schemas.openxmlformats.org/drawingml/2006/main">
+            <a:r>
+              <a:t>[Sources]</a:t>
+            </a:r>
+          </a:p>
+          <a:p xmlns:a="http://schemas.openxmlformats.org/drawingml/2006/main">
+            <a:r>
+              <a:t>- 03_WebApp/Pre_Present/docs/08-privacy-and-data.md — privacy boundary</a:t>
+            </a:r>
+          </a:p>
+          <a:p xmlns:a="http://schemas.openxmlformats.org/drawingml/2006/main">
+            <a:r>
+              <a:t>- 03_WebApp/Pre_Present/docs/09-source-review.md — provenance and freshness</a:t>
+            </a:r>
+          </a:p>
+          <a:p xmlns:a="http://schemas.openxmlformats.org/drawingml/2006/main">
+            <a:r>
+              <a:t>[/Sources]</a:t>
+            </a:r>
+          </a:p>
         </p:txBody>
       </p:sp>
       <p:sp>
@@ -1335,7 +1687,31 @@
         <p:txBody>
           <a:bodyPr xmlns:a="http://schemas.openxmlformats.org/drawingml/2006/main"/>
           <a:lstStyle xmlns:a="http://schemas.openxmlformats.org/drawingml/2006/main"/>
-          <a:p xmlns:a="http://schemas.openxmlformats.org/drawingml/2006/main"/>
+          <a:p xmlns:a="http://schemas.openxmlformats.org/drawingml/2006/main">
+            <a:r>
+              <a:t>The first answer only changes order: all 30 live interest items are still asked and scoring is unchanged.</a:t>
+            </a:r>
+          </a:p>
+          <a:p xmlns:a="http://schemas.openxmlformats.org/drawingml/2006/main">
+            <a:r>
+              <a:t>[Sources]</a:t>
+            </a:r>
+          </a:p>
+          <a:p xmlns:a="http://schemas.openxmlformats.org/drawingml/2006/main">
+            <a:r>
+              <a:t>- 03_WebApp/Pre_Present/lib/adaptive-engine.ts — branch plan</a:t>
+            </a:r>
+          </a:p>
+          <a:p xmlns:a="http://schemas.openxmlformats.org/drawingml/2006/main">
+            <a:r>
+              <a:t>- 03_WebApp/Pre_Present/tests/unit/adaptive-engine.test.ts — deterministic branch tests</a:t>
+            </a:r>
+          </a:p>
+          <a:p xmlns:a="http://schemas.openxmlformats.org/drawingml/2006/main">
+            <a:r>
+              <a:t>[/Sources]</a:t>
+            </a:r>
+          </a:p>
         </p:txBody>
       </p:sp>
       <p:sp>
@@ -1401,7 +1777,31 @@
         <p:txBody>
           <a:bodyPr xmlns:a="http://schemas.openxmlformats.org/drawingml/2006/main"/>
           <a:lstStyle xmlns:a="http://schemas.openxmlformats.org/drawingml/2006/main"/>
-          <a:p xmlns:a="http://schemas.openxmlformats.org/drawingml/2006/main"/>
+          <a:p xmlns:a="http://schemas.openxmlformats.org/drawingml/2006/main">
+            <a:r>
+              <a:t>The learner can review answers, override a suggested mission, compare again and delete local state.</a:t>
+            </a:r>
+          </a:p>
+          <a:p xmlns:a="http://schemas.openxmlformats.org/drawingml/2006/main">
+            <a:r>
+              <a:t>[Sources]</a:t>
+            </a:r>
+          </a:p>
+          <a:p xmlns:a="http://schemas.openxmlformats.org/drawingml/2006/main">
+            <a:r>
+              <a:t>- 03_WebApp/Pre_Present/READMEEN.md — journey and control surfaces</a:t>
+            </a:r>
+          </a:p>
+          <a:p xmlns:a="http://schemas.openxmlformats.org/drawingml/2006/main">
+            <a:r>
+              <a:t>- 03_WebApp/Pre_Present/e2e/journey.spec.ts — implemented browser journey</a:t>
+            </a:r>
+          </a:p>
+          <a:p xmlns:a="http://schemas.openxmlformats.org/drawingml/2006/main">
+            <a:r>
+              <a:t>[/Sources]</a:t>
+            </a:r>
+          </a:p>
         </p:txBody>
       </p:sp>
       <p:sp>
@@ -4426,17 +4826,17 @@
   </p:cSld>
   <p:clrMap bg1="lt1" tx1="dk1" bg2="lt2" tx2="dk2" accent1="accent1" accent2="accent2" accent3="accent3" accent4="accent4" accent5="accent5" accent6="accent6" hlink="hlink" folHlink="folHlink"/>
   <p:sldLayoutIdLst>
-    <p:sldLayoutId xmlns:r="http://schemas.openxmlformats.org/officeDocument/2006/relationships" id="2147483649" r:id="R1b7977e4311a49e5"/>
-    <p:sldLayoutId xmlns:r="http://schemas.openxmlformats.org/officeDocument/2006/relationships" id="2147483650" r:id="R432d972114234bde"/>
-    <p:sldLayoutId xmlns:r="http://schemas.openxmlformats.org/officeDocument/2006/relationships" id="2147483651" r:id="R5385420762c9404a"/>
-    <p:sldLayoutId xmlns:r="http://schemas.openxmlformats.org/officeDocument/2006/relationships" id="2147483652" r:id="R6f214d798f574937"/>
-    <p:sldLayoutId xmlns:r="http://schemas.openxmlformats.org/officeDocument/2006/relationships" id="2147483653" r:id="R1a8150c2809148d8"/>
-    <p:sldLayoutId xmlns:r="http://schemas.openxmlformats.org/officeDocument/2006/relationships" id="2147483654" r:id="R4ed2fd32ab69404e"/>
-    <p:sldLayoutId xmlns:r="http://schemas.openxmlformats.org/officeDocument/2006/relationships" id="2147483655" r:id="R5f4a77428f914482"/>
-    <p:sldLayoutId xmlns:r="http://schemas.openxmlformats.org/officeDocument/2006/relationships" id="2147483656" r:id="Rf27b8f5bd38b492b"/>
-    <p:sldLayoutId xmlns:r="http://schemas.openxmlformats.org/officeDocument/2006/relationships" id="2147483657" r:id="R3dfcb54fe61c4033"/>
-    <p:sldLayoutId xmlns:r="http://schemas.openxmlformats.org/officeDocument/2006/relationships" id="2147483658" r:id="R456fb62baebd47fe"/>
-    <p:sldLayoutId xmlns:r="http://schemas.openxmlformats.org/officeDocument/2006/relationships" id="2147483659" r:id="R66e60b6ee3014cc9"/>
+    <p:sldLayoutId xmlns:r="http://schemas.openxmlformats.org/officeDocument/2006/relationships" id="2147483649" r:id="R94bf5650d3074799"/>
+    <p:sldLayoutId xmlns:r="http://schemas.openxmlformats.org/officeDocument/2006/relationships" id="2147483650" r:id="Rec2c95d0933e4c3b"/>
+    <p:sldLayoutId xmlns:r="http://schemas.openxmlformats.org/officeDocument/2006/relationships" id="2147483651" r:id="Rc023e9f76a1d47c3"/>
+    <p:sldLayoutId xmlns:r="http://schemas.openxmlformats.org/officeDocument/2006/relationships" id="2147483652" r:id="Rbe16bf8eb50448e0"/>
+    <p:sldLayoutId xmlns:r="http://schemas.openxmlformats.org/officeDocument/2006/relationships" id="2147483653" r:id="R8ebfa86cf7bf456a"/>
+    <p:sldLayoutId xmlns:r="http://schemas.openxmlformats.org/officeDocument/2006/relationships" id="2147483654" r:id="R0b7458e33865422a"/>
+    <p:sldLayoutId xmlns:r="http://schemas.openxmlformats.org/officeDocument/2006/relationships" id="2147483655" r:id="Rb7154f35fe4b430c"/>
+    <p:sldLayoutId xmlns:r="http://schemas.openxmlformats.org/officeDocument/2006/relationships" id="2147483656" r:id="R78d1d581111e4993"/>
+    <p:sldLayoutId xmlns:r="http://schemas.openxmlformats.org/officeDocument/2006/relationships" id="2147483657" r:id="Ref0675b363fb40cc"/>
+    <p:sldLayoutId xmlns:r="http://schemas.openxmlformats.org/officeDocument/2006/relationships" id="2147483658" r:id="Rd246e52a31454014"/>
+    <p:sldLayoutId xmlns:r="http://schemas.openxmlformats.org/officeDocument/2006/relationships" id="2147483659" r:id="Rdbfe202c2ac54a08"/>
   </p:sldLayoutIdLst>
   <p:txStyles>
     <p:titleStyle>
@@ -4986,7 +5386,7 @@
           <p:nvPr/>
         </p:nvPicPr>
         <p:blipFill>
-          <a:blip xmlns:r="http://schemas.openxmlformats.org/officeDocument/2006/relationships" xmlns:a="http://schemas.openxmlformats.org/drawingml/2006/main" r:embed="R9e04637625664912"/>
+          <a:blip xmlns:r="http://schemas.openxmlformats.org/officeDocument/2006/relationships" xmlns:a="http://schemas.openxmlformats.org/drawingml/2006/main" r:embed="Ra0c3ee52b3834d73"/>
           <a:stretch xmlns:a="http://schemas.openxmlformats.org/drawingml/2006/main">
             <a:fillRect l="0" t="0" r="0" b="0"/>
           </a:stretch>
@@ -5052,7 +5452,7 @@
                 <a:ea typeface="Aptos"/>
                 <a:cs typeface="Aptos"/>
               </a:rPr>
-              <a:t>JUMP THAILAND HACKATHON 2026 · PROJECT CASE STUDY</a:t>
+              <a:t>JUMP THAILAND HACKATHON 2026 · UPDATED PROJECT CASE STUDY</a:t>
             </a:r>
           </a:p>
         </p:txBody>
@@ -5306,7 +5706,7 @@
                 <a:ea typeface="Aptos"/>
                 <a:cs typeface="Aptos"/>
               </a:rPr>
-              <a:t>A decision-support prototype for Thai secondary and vocational students.</a:t>
+              <a:t>A runnable decision-support prototype for Thai secondary and vocational students.</a:t>
             </a:r>
           </a:p>
         </p:txBody>
@@ -5529,7 +5929,7 @@
                 <a:ea typeface="Aptos"/>
                 <a:cs typeface="Aptos"/>
               </a:rPr>
-              <a:t>Research synthesis · Product strategy · UX · AI architecture · Validation</a:t>
+              <a:t>Research · Data lineage · Product · Decision logic · Validation</a:t>
             </a:r>
           </a:p>
         </p:txBody>
@@ -6344,7 +6744,7 @@
           <p:nvPr/>
         </p:nvPicPr>
         <p:blipFill>
-          <a:blip xmlns:r="http://schemas.openxmlformats.org/officeDocument/2006/relationships" xmlns:a="http://schemas.openxmlformats.org/drawingml/2006/main" r:embed="R1ac22e49ba804f9c"/>
+          <a:blip xmlns:r="http://schemas.openxmlformats.org/officeDocument/2006/relationships" xmlns:a="http://schemas.openxmlformats.org/drawingml/2006/main" r:embed="R55ed13ab81fa40b6"/>
           <a:stretch xmlns:a="http://schemas.openxmlformats.org/drawingml/2006/main">
             <a:fillRect l="0" t="0" r="0" b="0"/>
           </a:stretch>
@@ -6466,7 +6866,7 @@
                 <a:ea typeface="Aptos"/>
                 <a:cs typeface="Aptos"/>
               </a:rPr>
-              <a:t>AI supports the conversation—not the decision</a:t>
+              <a:t>Rules decide. AI explains. Research stays gated.</a:t>
             </a:r>
           </a:p>
         </p:txBody>
@@ -6522,7 +6922,7 @@
                 <a:ea typeface="Aptos"/>
                 <a:cs typeface="Aptos"/>
               </a:rPr>
-              <a:t>Current capabilities and future architecture are deliberately separated.</a:t>
+              <a:t>The live decision path, future research inputs and production plan remain separate.</a:t>
             </a:r>
           </a:p>
         </p:txBody>
@@ -6592,7 +6992,7 @@
           <p:nvPr/>
         </p:nvPicPr>
         <p:blipFill>
-          <a:blip xmlns:r="http://schemas.openxmlformats.org/officeDocument/2006/relationships" xmlns:a="http://schemas.openxmlformats.org/drawingml/2006/main" r:embed="R5a955d12d62d4812"/>
+          <a:blip xmlns:r="http://schemas.openxmlformats.org/officeDocument/2006/relationships" xmlns:a="http://schemas.openxmlformats.org/drawingml/2006/main" r:embed="R2fe800335fc44cf2"/>
           <a:stretch xmlns:a="http://schemas.openxmlformats.org/drawingml/2006/main">
             <a:fillRect l="0" t="0" r="0" b="0"/>
           </a:stretch>
@@ -6658,7 +7058,7 @@
                 <a:ea typeface="Aptos"/>
                 <a:cs typeface="Aptos"/>
               </a:rPr>
-              <a:t>FutureMe AI · Project case study · July 2026</a:t>
+              <a:t>FutureMe AI · Project case study · August 2026</a:t>
             </a:r>
           </a:p>
         </p:txBody>
@@ -6844,7 +7244,7 @@
         <p:spPr>
           <a:xfrm xmlns:a="http://schemas.openxmlformats.org/drawingml/2006/main">
             <a:off x="960120" y="2185416"/>
-            <a:ext cx="3108960" cy="384048"/>
+            <a:ext cx="3108960" cy="441960"/>
           </a:xfrm>
           <a:prstGeom xmlns:a="http://schemas.openxmlformats.org/drawingml/2006/main" prst="rect">
             <a:avLst/>
@@ -6878,7 +7278,32 @@
                 <a:ea typeface="Aptos"/>
                 <a:cs typeface="Aptos"/>
               </a:rPr>
-              <a:t>Learner input</a:t>
+              <a:t>30 live items</a:t>
+            </a:r>
+          </a:p>
+          <a:p xmlns:a="http://schemas.openxmlformats.org/drawingml/2006/main">
+            <a:pPr algn="ctr">
+              <a:lnSpc>
+                <a:spcPct val="100000"/>
+              </a:lnSpc>
+              <a:spcBef>
+                <a:spcPts val="0"/>
+              </a:spcBef>
+              <a:spcAft>
+                <a:spcPts val="0"/>
+              </a:spcAft>
+              <a:buNone/>
+            </a:pPr>
+            <a:r>
+              <a:rPr sz="1450" b="1" i="0">
+                <a:solidFill>
+                  <a:srgbClr val="F5F5FA"/>
+                </a:solidFill>
+                <a:latin typeface="Aptos"/>
+                <a:ea typeface="Aptos"/>
+                <a:cs typeface="Aptos"/>
+              </a:rPr>
+              <a:t>+ 5 context prompts</a:t>
             </a:r>
           </a:p>
         </p:txBody>
@@ -7011,7 +7436,7 @@
         <p:spPr>
           <a:xfrm xmlns:a="http://schemas.openxmlformats.org/drawingml/2006/main">
             <a:off x="960120" y="3264408"/>
-            <a:ext cx="3108960" cy="384048"/>
+            <a:ext cx="3108960" cy="441960"/>
           </a:xfrm>
           <a:prstGeom xmlns:a="http://schemas.openxmlformats.org/drawingml/2006/main" prst="rect">
             <a:avLst/>
@@ -7045,8 +7470,32 @@
                 <a:ea typeface="Aptos"/>
                 <a:cs typeface="Aptos"/>
               </a:rPr>
-              <a:t>Deterministic
-TypeScript rules</a:t>
+              <a:t>First-answer ordering</a:t>
+            </a:r>
+          </a:p>
+          <a:p xmlns:a="http://schemas.openxmlformats.org/drawingml/2006/main">
+            <a:pPr algn="ctr">
+              <a:lnSpc>
+                <a:spcPct val="100000"/>
+              </a:lnSpc>
+              <a:spcBef>
+                <a:spcPts val="0"/>
+              </a:spcBef>
+              <a:spcAft>
+                <a:spcPts val="0"/>
+              </a:spcAft>
+              <a:buNone/>
+            </a:pPr>
+            <a:r>
+              <a:rPr sz="1450" b="1" i="0">
+                <a:solidFill>
+                  <a:srgbClr val="F5F5FA"/>
+                </a:solidFill>
+                <a:latin typeface="Aptos"/>
+                <a:ea typeface="Aptos"/>
+                <a:cs typeface="Aptos"/>
+              </a:rPr>
+              <a:t>+ deterministic rules</a:t>
             </a:r>
           </a:p>
         </p:txBody>
@@ -7179,7 +7628,7 @@
         <p:spPr>
           <a:xfrm xmlns:a="http://schemas.openxmlformats.org/drawingml/2006/main">
             <a:off x="960120" y="4343400"/>
-            <a:ext cx="3108960" cy="384048"/>
+            <a:ext cx="3108960" cy="441960"/>
           </a:xfrm>
           <a:prstGeom xmlns:a="http://schemas.openxmlformats.org/drawingml/2006/main" prst="rect">
             <a:avLst/>
@@ -7214,6 +7663,31 @@
                 <a:cs typeface="Aptos"/>
               </a:rPr>
               <a:t>0–3 routes</a:t>
+            </a:r>
+          </a:p>
+          <a:p xmlns:a="http://schemas.openxmlformats.org/drawingml/2006/main">
+            <a:pPr algn="ctr">
+              <a:lnSpc>
+                <a:spcPct val="100000"/>
+              </a:lnSpc>
+              <a:spcBef>
+                <a:spcPts val="0"/>
+              </a:spcBef>
+              <a:spcAft>
+                <a:spcPts val="0"/>
+              </a:spcAft>
+              <a:buNone/>
+            </a:pPr>
+            <a:r>
+              <a:rPr sz="1450" b="1" i="0">
+                <a:solidFill>
+                  <a:srgbClr val="07070D"/>
+                </a:solidFill>
+                <a:latin typeface="Aptos"/>
+                <a:ea typeface="Aptos"/>
+                <a:cs typeface="Aptos"/>
+              </a:rPr>
+              <a:t>+ 30-day plan</a:t>
             </a:r>
           </a:p>
         </p:txBody>
@@ -7324,8 +7798,32 @@
                 <a:ea typeface="Aptos"/>
                 <a:cs typeface="Aptos"/>
               </a:rPr>
-              <a:t>Optional LLM: bounded chat + rewording
-Off by default · no assessment answers</a:t>
+              <a:t>Optional LLM: bounded chat + rewording</a:t>
+            </a:r>
+          </a:p>
+          <a:p xmlns:a="http://schemas.openxmlformats.org/drawingml/2006/main">
+            <a:pPr algn="ctr">
+              <a:lnSpc>
+                <a:spcPct val="100000"/>
+              </a:lnSpc>
+              <a:spcBef>
+                <a:spcPts val="0"/>
+              </a:spcBef>
+              <a:spcAft>
+                <a:spcPts val="0"/>
+              </a:spcAft>
+              <a:buNone/>
+            </a:pPr>
+            <a:r>
+              <a:rPr sz="1100" b="0" i="0">
+                <a:solidFill>
+                  <a:srgbClr val="A8A8BE"/>
+                </a:solidFill>
+                <a:latin typeface="Aptos"/>
+                <a:ea typeface="Aptos"/>
+                <a:cs typeface="Aptos"/>
+              </a:rPr>
+              <a:t>Outside scoring · offline fallback</a:t>
             </a:r>
           </a:p>
         </p:txBody>
@@ -7480,7 +7978,7 @@
                 <a:ea typeface="Aptos"/>
                 <a:cs typeface="Aptos"/>
               </a:rPr>
-              <a:t>FUTURE · PLANNED</a:t>
+              <a:t>RESEARCH / FUTURE</a:t>
             </a:r>
           </a:p>
         </p:txBody>
@@ -7557,7 +8055,7 @@
         <p:spPr>
           <a:xfrm xmlns:a="http://schemas.openxmlformats.org/drawingml/2006/main">
             <a:off x="5138928" y="2313432"/>
-            <a:ext cx="1426464" cy="493776"/>
+            <a:ext cx="1426464" cy="525780"/>
           </a:xfrm>
           <a:prstGeom xmlns:a="http://schemas.openxmlformats.org/drawingml/2006/main" prst="rect">
             <a:avLst/>
@@ -7591,7 +8089,32 @@
                 <a:ea typeface="Aptos"/>
                 <a:cs typeface="Aptos"/>
               </a:rPr>
-              <a:t>Adaptive Thai conversation</a:t>
+              <a:t>90-item adaptive design</a:t>
+            </a:r>
+          </a:p>
+          <a:p xmlns:a="http://schemas.openxmlformats.org/drawingml/2006/main">
+            <a:pPr algn="ctr">
+              <a:lnSpc>
+                <a:spcPct val="100000"/>
+              </a:lnSpc>
+              <a:spcBef>
+                <a:spcPts val="0"/>
+              </a:spcBef>
+              <a:spcAft>
+                <a:spcPts val="0"/>
+              </a:spcAft>
+              <a:buNone/>
+            </a:pPr>
+            <a:r>
+              <a:rPr sz="1150" b="1" i="0">
+                <a:solidFill>
+                  <a:srgbClr val="F5F5FA"/>
+                </a:solidFill>
+                <a:latin typeface="Aptos"/>
+                <a:ea typeface="Aptos"/>
+                <a:cs typeface="Aptos"/>
+              </a:rPr>
+              <a:t>not live</a:t>
             </a:r>
           </a:p>
         </p:txBody>
@@ -7724,7 +8247,7 @@
         <p:spPr>
           <a:xfrm xmlns:a="http://schemas.openxmlformats.org/drawingml/2006/main">
             <a:off x="7013448" y="2313432"/>
-            <a:ext cx="1426464" cy="493776"/>
+            <a:ext cx="1426464" cy="525780"/>
           </a:xfrm>
           <a:prstGeom xmlns:a="http://schemas.openxmlformats.org/drawingml/2006/main" prst="rect">
             <a:avLst/>
@@ -7758,7 +8281,32 @@
                 <a:ea typeface="Aptos"/>
                 <a:cs typeface="Aptos"/>
               </a:rPr>
-              <a:t>Structured profile extraction</a:t>
+              <a:t>1,000-item bilingual bank</a:t>
+            </a:r>
+          </a:p>
+          <a:p xmlns:a="http://schemas.openxmlformats.org/drawingml/2006/main">
+            <a:pPr algn="ctr">
+              <a:lnSpc>
+                <a:spcPct val="100000"/>
+              </a:lnSpc>
+              <a:spcBef>
+                <a:spcPts val="0"/>
+              </a:spcBef>
+              <a:spcAft>
+                <a:spcPts val="0"/>
+              </a:spcAft>
+              <a:buNone/>
+            </a:pPr>
+            <a:r>
+              <a:rPr sz="1150" b="1" i="0">
+                <a:solidFill>
+                  <a:srgbClr val="F5F5FA"/>
+                </a:solidFill>
+                <a:latin typeface="Aptos"/>
+                <a:ea typeface="Aptos"/>
+                <a:cs typeface="Aptos"/>
+              </a:rPr>
+              <a:t>structurally checked</a:t>
             </a:r>
           </a:p>
         </p:txBody>
@@ -7891,7 +8439,7 @@
         <p:spPr>
           <a:xfrm xmlns:a="http://schemas.openxmlformats.org/drawingml/2006/main">
             <a:off x="8887967" y="2313432"/>
-            <a:ext cx="1426464" cy="493776"/>
+            <a:ext cx="1426464" cy="525780"/>
           </a:xfrm>
           <a:prstGeom xmlns:a="http://schemas.openxmlformats.org/drawingml/2006/main" prst="rect">
             <a:avLst/>
@@ -7925,7 +8473,32 @@
                 <a:ea typeface="Aptos"/>
                 <a:cs typeface="Aptos"/>
               </a:rPr>
-              <a:t>Rule engine</a:t>
+              <a:t>Expert + student review</a:t>
+            </a:r>
+          </a:p>
+          <a:p xmlns:a="http://schemas.openxmlformats.org/drawingml/2006/main">
+            <a:pPr algn="ctr">
+              <a:lnSpc>
+                <a:spcPct val="100000"/>
+              </a:lnSpc>
+              <a:spcBef>
+                <a:spcPts val="0"/>
+              </a:spcBef>
+              <a:spcAft>
+                <a:spcPts val="0"/>
+              </a:spcAft>
+              <a:buNone/>
+            </a:pPr>
+            <a:r>
+              <a:rPr sz="1150" b="1" i="0">
+                <a:solidFill>
+                  <a:srgbClr val="F5F5FA"/>
+                </a:solidFill>
+                <a:latin typeface="Aptos"/>
+                <a:ea typeface="Aptos"/>
+                <a:cs typeface="Aptos"/>
+              </a:rPr>
+              <a:t>before import</a:t>
             </a:r>
           </a:p>
         </p:txBody>
@@ -8534,29 +9107,7 @@
                 <a:ea typeface="Aptos"/>
                 <a:cs typeface="Aptos"/>
               </a:rPr>
-              <a:t>Rules decide. </a:t>
-            </a:r>
-            <a:r>
-              <a:rPr sz="1600" b="1" i="0">
-                <a:solidFill>
-                  <a:srgbClr val="FFD37A"/>
-                </a:solidFill>
-                <a:latin typeface="Aptos"/>
-                <a:ea typeface="Aptos"/>
-                <a:cs typeface="Aptos"/>
-              </a:rPr>
-              <a:t>Retrieval grounds. </a:t>
-            </a:r>
-            <a:r>
-              <a:rPr sz="1600" b="1" i="0">
-                <a:solidFill>
-                  <a:srgbClr val="F5F5FA"/>
-                </a:solidFill>
-                <a:latin typeface="Aptos"/>
-                <a:ea typeface="Aptos"/>
-                <a:cs typeface="Aptos"/>
-              </a:rPr>
-              <a:t>AI explains.</a:t>
+              <a:t>Rules decide. Validated data grounds. AI explains.</a:t>
             </a:r>
           </a:p>
         </p:txBody>
@@ -8612,7 +9163,7 @@
                 <a:ea typeface="Aptos"/>
                 <a:cs typeface="Aptos"/>
               </a:rPr>
-              <a:t>Sources: current code + planned RAG architecture; Qdrant/AIS/NDLP are not implemented</a:t>
+              <a:t>Sources: current code + research banks; production RAG and cloud services are not implemented</a:t>
             </a:r>
           </a:p>
         </p:txBody>
@@ -8648,7 +9199,7 @@
           <p:nvPr/>
         </p:nvPicPr>
         <p:blipFill>
-          <a:blip xmlns:r="http://schemas.openxmlformats.org/officeDocument/2006/relationships" xmlns:a="http://schemas.openxmlformats.org/drawingml/2006/main" r:embed="Rc1fa03e0cdf9478e"/>
+          <a:blip xmlns:r="http://schemas.openxmlformats.org/officeDocument/2006/relationships" xmlns:a="http://schemas.openxmlformats.org/drawingml/2006/main" r:embed="Re778bba3671f4321"/>
           <a:stretch xmlns:a="http://schemas.openxmlformats.org/drawingml/2006/main">
             <a:fillRect l="0" t="0" r="0" b="0"/>
           </a:stretch>
@@ -8896,7 +9447,7 @@
           <p:nvPr/>
         </p:nvPicPr>
         <p:blipFill>
-          <a:blip xmlns:r="http://schemas.openxmlformats.org/officeDocument/2006/relationships" xmlns:a="http://schemas.openxmlformats.org/drawingml/2006/main" r:embed="R96b817d208e34f21"/>
+          <a:blip xmlns:r="http://schemas.openxmlformats.org/officeDocument/2006/relationships" xmlns:a="http://schemas.openxmlformats.org/drawingml/2006/main" r:embed="Rb2cb558f6ac348d3"/>
           <a:stretch xmlns:a="http://schemas.openxmlformats.org/drawingml/2006/main">
             <a:fillRect l="0" t="0" r="0" b="0"/>
           </a:stretch>
@@ -8962,7 +9513,7 @@
                 <a:ea typeface="Aptos"/>
                 <a:cs typeface="Aptos"/>
               </a:rPr>
-              <a:t>FutureMe AI · Project case study · July 2026</a:t>
+              <a:t>FutureMe AI · Project case study · August 2026</a:t>
             </a:r>
           </a:p>
         </p:txBody>
@@ -9073,8 +9624,32 @@
                 <a:ea typeface="Aptos"/>
                 <a:cs typeface="Aptos"/>
               </a:rPr>
-              <a:t>30 items
-+ context</a:t>
+              <a:t>30 live items</a:t>
+            </a:r>
+          </a:p>
+          <a:p xmlns:a="http://schemas.openxmlformats.org/drawingml/2006/main">
+            <a:pPr algn="ctr">
+              <a:lnSpc>
+                <a:spcPct val="100000"/>
+              </a:lnSpc>
+              <a:spcBef>
+                <a:spcPts val="0"/>
+              </a:spcBef>
+              <a:spcAft>
+                <a:spcPts val="0"/>
+              </a:spcAft>
+              <a:buNone/>
+            </a:pPr>
+            <a:r>
+              <a:rPr sz="1250" b="1" i="0">
+                <a:solidFill>
+                  <a:srgbClr val="F5F5FA"/>
+                </a:solidFill>
+                <a:latin typeface="Aptos"/>
+                <a:ea typeface="Aptos"/>
+                <a:cs typeface="Aptos"/>
+              </a:rPr>
+              <a:t>+ context</a:t>
             </a:r>
           </a:p>
         </p:txBody>
@@ -11239,7 +11814,7 @@
                 <a:ea typeface="Aptos"/>
                 <a:cs typeface="Aptos"/>
               </a:rPr>
-              <a:t>Interest fit and learning-environment affinity both derive from the interview profile; mission evidence is the independent signal.</a:t>
+              <a:t>Live scoring uses 30 items. The 1,000-item bank is structurally checked and research-only.</a:t>
             </a:r>
           </a:p>
         </p:txBody>
@@ -11295,7 +11870,7 @@
                 <a:ea typeface="Aptos"/>
                 <a:cs typeface="Aptos"/>
               </a:rPr>
-              <a:t>Source: lib/decision-engine (current working prototype)</a:t>
+              <a:t>Source: adaptive-engine + decision-engine + future-bank validator (current prototype)</a:t>
             </a:r>
           </a:p>
         </p:txBody>
@@ -11331,7 +11906,7 @@
           <p:nvPr/>
         </p:nvPicPr>
         <p:blipFill>
-          <a:blip xmlns:r="http://schemas.openxmlformats.org/officeDocument/2006/relationships" xmlns:a="http://schemas.openxmlformats.org/drawingml/2006/main" r:embed="Rca8b0af9719c4c78"/>
+          <a:blip xmlns:r="http://schemas.openxmlformats.org/officeDocument/2006/relationships" xmlns:a="http://schemas.openxmlformats.org/drawingml/2006/main" r:embed="R2dbbc139a1e64ae9"/>
           <a:stretch xmlns:a="http://schemas.openxmlformats.org/drawingml/2006/main">
             <a:fillRect l="0" t="0" r="0" b="0"/>
           </a:stretch>
@@ -11453,7 +12028,7 @@
                 <a:ea typeface="Aptos"/>
                 <a:cs typeface="Aptos"/>
               </a:rPr>
-              <a:t>A complete prototype already runs end to end</a:t>
+              <a:t>The latest prototype runs end to end</a:t>
             </a:r>
           </a:p>
         </p:txBody>
@@ -11509,7 +12084,7 @@
                 <a:ea typeface="Aptos"/>
                 <a:cs typeface="Aptos"/>
               </a:rPr>
-              <a:t>These are screenshots from the implemented app—not concept mockups.</a:t>
+              <a:t>Current app screenshots—not concept mockups. Mascot motion is on by default with a persisted system opt-out.</a:t>
             </a:r>
           </a:p>
         </p:txBody>
@@ -11579,7 +12154,7 @@
           <p:nvPr/>
         </p:nvPicPr>
         <p:blipFill>
-          <a:blip xmlns:r="http://schemas.openxmlformats.org/officeDocument/2006/relationships" xmlns:a="http://schemas.openxmlformats.org/drawingml/2006/main" r:embed="Rc38a518bd7f2408f"/>
+          <a:blip xmlns:r="http://schemas.openxmlformats.org/officeDocument/2006/relationships" xmlns:a="http://schemas.openxmlformats.org/drawingml/2006/main" r:embed="Rebb65c8338444226"/>
           <a:stretch xmlns:a="http://schemas.openxmlformats.org/drawingml/2006/main">
             <a:fillRect l="0" t="0" r="0" b="0"/>
           </a:stretch>
@@ -11645,7 +12220,7 @@
                 <a:ea typeface="Aptos"/>
                 <a:cs typeface="Aptos"/>
               </a:rPr>
-              <a:t>FutureMe AI · Project case study · July 2026</a:t>
+              <a:t>FutureMe AI · Project case study · August 2026</a:t>
             </a:r>
           </a:p>
         </p:txBody>
@@ -11714,7 +12289,7 @@
           <p:nvPr/>
         </p:nvPicPr>
         <p:blipFill>
-          <a:blip xmlns:r="http://schemas.openxmlformats.org/officeDocument/2006/relationships" xmlns:a="http://schemas.openxmlformats.org/drawingml/2006/main" r:embed="R93b290f8ccff43fc"/>
+          <a:blip xmlns:r="http://schemas.openxmlformats.org/officeDocument/2006/relationships" xmlns:a="http://schemas.openxmlformats.org/drawingml/2006/main" r:embed="R0655af96176a4e1c"/>
           <a:srcRect xmlns:a="http://schemas.openxmlformats.org/drawingml/2006/main" l="11145" t="0" r="11145" b="0"/>
           <a:stretch xmlns:a="http://schemas.openxmlformats.org/drawingml/2006/main">
             <a:fillRect l="0" t="0" r="0" b="0"/>
@@ -11961,7 +12536,7 @@
           <p:nvPr/>
         </p:nvPicPr>
         <p:blipFill>
-          <a:blip xmlns:r="http://schemas.openxmlformats.org/officeDocument/2006/relationships" xmlns:a="http://schemas.openxmlformats.org/drawingml/2006/main" r:embed="Rc7a3d6e346cf4f64"/>
+          <a:blip xmlns:r="http://schemas.openxmlformats.org/officeDocument/2006/relationships" xmlns:a="http://schemas.openxmlformats.org/drawingml/2006/main" r:embed="Rf7ac22d923e24cfd"/>
           <a:srcRect xmlns:a="http://schemas.openxmlformats.org/drawingml/2006/main" l="0" t="0" r="0" b="29182"/>
           <a:stretch xmlns:a="http://schemas.openxmlformats.org/drawingml/2006/main">
             <a:fillRect l="0" t="0" r="0" b="0"/>
@@ -12208,7 +12783,7 @@
           <p:nvPr/>
         </p:nvPicPr>
         <p:blipFill>
-          <a:blip xmlns:r="http://schemas.openxmlformats.org/officeDocument/2006/relationships" xmlns:a="http://schemas.openxmlformats.org/drawingml/2006/main" r:embed="R601505f1092a4668"/>
+          <a:blip xmlns:r="http://schemas.openxmlformats.org/officeDocument/2006/relationships" xmlns:a="http://schemas.openxmlformats.org/drawingml/2006/main" r:embed="Rbccda1dc30364acc"/>
           <a:srcRect xmlns:a="http://schemas.openxmlformats.org/drawingml/2006/main" l="0" t="0" r="0" b="36198"/>
           <a:stretch xmlns:a="http://schemas.openxmlformats.org/drawingml/2006/main">
             <a:fillRect l="0" t="0" r="0" b="0"/>
@@ -12941,7 +13516,7 @@
                 <a:ea typeface="Aptos"/>
                 <a:cs typeface="Aptos"/>
               </a:rPr>
-              <a:t>522 TESTS</a:t>
+              <a:t>529 TESTS</a:t>
             </a:r>
           </a:p>
         </p:txBody>
@@ -13164,7 +13739,7 @@
                 <a:ea typeface="Aptos"/>
                 <a:cs typeface="Aptos"/>
               </a:rPr>
-              <a:t>Verification rerun 11 Aug 2026: 522 Vitest tests + 94 Playwright journeys passed</a:t>
+              <a:t>Verification rerun 11 Aug 2026: 529 Vitest tests and all 94 Playwright browser journeys passed.</a:t>
             </a:r>
           </a:p>
         </p:txBody>
@@ -13200,7 +13775,7 @@
           <p:nvPr/>
         </p:nvPicPr>
         <p:blipFill>
-          <a:blip xmlns:r="http://schemas.openxmlformats.org/officeDocument/2006/relationships" xmlns:a="http://schemas.openxmlformats.org/drawingml/2006/main" r:embed="Rd52039e167d245b5"/>
+          <a:blip xmlns:r="http://schemas.openxmlformats.org/officeDocument/2006/relationships" xmlns:a="http://schemas.openxmlformats.org/drawingml/2006/main" r:embed="Re99cbcb5ef964fac"/>
           <a:stretch xmlns:a="http://schemas.openxmlformats.org/drawingml/2006/main">
             <a:fillRect l="0" t="0" r="0" b="0"/>
           </a:stretch>
@@ -13448,7 +14023,7 @@
           <p:nvPr/>
         </p:nvPicPr>
         <p:blipFill>
-          <a:blip xmlns:r="http://schemas.openxmlformats.org/officeDocument/2006/relationships" xmlns:a="http://schemas.openxmlformats.org/drawingml/2006/main" r:embed="Rb5f8cb872c6c4084"/>
+          <a:blip xmlns:r="http://schemas.openxmlformats.org/officeDocument/2006/relationships" xmlns:a="http://schemas.openxmlformats.org/drawingml/2006/main" r:embed="Rf7359f731b8e4952"/>
           <a:stretch xmlns:a="http://schemas.openxmlformats.org/drawingml/2006/main">
             <a:fillRect l="0" t="0" r="0" b="0"/>
           </a:stretch>
@@ -13514,7 +14089,7 @@
                 <a:ea typeface="Aptos"/>
                 <a:cs typeface="Aptos"/>
               </a:rPr>
-              <a:t>FutureMe AI · Project case study · July 2026</a:t>
+              <a:t>FutureMe AI · Project case study · August 2026</a:t>
             </a:r>
           </a:p>
         </p:txBody>
@@ -16482,7 +17057,7 @@
           <p:nvPr/>
         </p:nvPicPr>
         <p:blipFill>
-          <a:blip xmlns:r="http://schemas.openxmlformats.org/officeDocument/2006/relationships" xmlns:a="http://schemas.openxmlformats.org/drawingml/2006/main" r:embed="Rd87d61ea958d4a04"/>
+          <a:blip xmlns:r="http://schemas.openxmlformats.org/officeDocument/2006/relationships" xmlns:a="http://schemas.openxmlformats.org/drawingml/2006/main" r:embed="Rf2a9eb0e30334672"/>
           <a:stretch xmlns:a="http://schemas.openxmlformats.org/drawingml/2006/main">
             <a:fillRect l="0" t="0" r="0" b="0"/>
           </a:stretch>
@@ -16660,7 +17235,7 @@
                 <a:ea typeface="Aptos"/>
                 <a:cs typeface="Aptos"/>
               </a:rPr>
-              <a:t>The analysis pipeline is verified. The instrument is not.</a:t>
+              <a:t>Software and data pipelines are verified. The instrument and outcomes are not.</a:t>
             </a:r>
           </a:p>
         </p:txBody>
@@ -16730,7 +17305,7 @@
           <p:nvPr/>
         </p:nvPicPr>
         <p:blipFill>
-          <a:blip xmlns:r="http://schemas.openxmlformats.org/officeDocument/2006/relationships" xmlns:a="http://schemas.openxmlformats.org/drawingml/2006/main" r:embed="R1ba4f27fa8e249eb"/>
+          <a:blip xmlns:r="http://schemas.openxmlformats.org/officeDocument/2006/relationships" xmlns:a="http://schemas.openxmlformats.org/drawingml/2006/main" r:embed="Re04257d5809d4426"/>
           <a:stretch xmlns:a="http://schemas.openxmlformats.org/drawingml/2006/main">
             <a:fillRect l="0" t="0" r="0" b="0"/>
           </a:stretch>
@@ -16796,7 +17371,7 @@
                 <a:ea typeface="Aptos"/>
                 <a:cs typeface="Aptos"/>
               </a:rPr>
-              <a:t>FutureMe AI · Project case study · July 2026</a:t>
+              <a:t>FutureMe AI · Project case study · August 2026</a:t>
             </a:r>
           </a:p>
         </p:txBody>
@@ -16873,7 +17448,7 @@
         <p:spPr>
           <a:xfrm xmlns:a="http://schemas.openxmlformats.org/drawingml/2006/main">
             <a:off x="841248" y="1746504"/>
-            <a:ext cx="3346704" cy="256032"/>
+            <a:ext cx="3346704" cy="457200"/>
           </a:xfrm>
           <a:prstGeom xmlns:a="http://schemas.openxmlformats.org/drawingml/2006/main" prst="rect">
             <a:avLst/>
@@ -16904,29 +17479,7 @@
                 <a:ea typeface="Aptos"/>
                 <a:cs typeface="Aptos"/>
               </a:rPr>
-              <a:t>PIPELINE VERIFIED</a:t>
-            </a:r>
-            <a:r>
-              <a:rPr sz="1500" b="1" i="0">
-                <a:solidFill>
-                  <a:srgbClr val="A8A8BE"/>
-                </a:solidFill>
-                <a:latin typeface="Aptos"/>
-                <a:ea typeface="Aptos"/>
-                <a:cs typeface="Aptos"/>
-              </a:rPr>
-              <a:t>  ≠  </a:t>
-            </a:r>
-            <a:r>
-              <a:rPr sz="1500" b="1" i="0">
-                <a:solidFill>
-                  <a:srgbClr val="FFD37A"/>
-                </a:solidFill>
-                <a:latin typeface="Aptos"/>
-                <a:ea typeface="Aptos"/>
-                <a:cs typeface="Aptos"/>
-              </a:rPr>
-              <a:t>INSTRUMENT VALIDATED</a:t>
+              <a:t>PIPELINES VERIFIED  ≠  PEOPLE VALIDATED</a:t>
             </a:r>
           </a:p>
         </p:txBody>
@@ -19302,7 +19855,7 @@
                 <a:ea typeface="Aptos"/>
                 <a:cs typeface="Aptos"/>
               </a:rPr>
-              <a:t>No reliability, norms or validity results exist yet.</a:t>
+              <a:t>No reliability, validity, fairness or outcome evidence yet.</a:t>
             </a:r>
           </a:p>
         </p:txBody>
@@ -19394,7 +19947,7 @@
           <p:nvPr/>
         </p:nvPicPr>
         <p:blipFill>
-          <a:blip xmlns:r="http://schemas.openxmlformats.org/officeDocument/2006/relationships" xmlns:a="http://schemas.openxmlformats.org/drawingml/2006/main" r:embed="Rf99b40ac53a34a79"/>
+          <a:blip xmlns:r="http://schemas.openxmlformats.org/officeDocument/2006/relationships" xmlns:a="http://schemas.openxmlformats.org/drawingml/2006/main" r:embed="Rafcaea5393c64aff"/>
           <a:stretch xmlns:a="http://schemas.openxmlformats.org/drawingml/2006/main">
             <a:fillRect l="0" t="0" r="0" b="0"/>
           </a:stretch>
@@ -19572,7 +20125,7 @@
                 <a:ea typeface="Aptos"/>
                 <a:cs typeface="Aptos"/>
               </a:rPr>
-              <a:t>Every phase has a gate; partnerships stay exploratory until something is signed.</a:t>
+              <a:t>Current phase: validate with people, not just pipelines.</a:t>
             </a:r>
           </a:p>
         </p:txBody>
@@ -19642,7 +20195,7 @@
           <p:nvPr/>
         </p:nvPicPr>
         <p:blipFill>
-          <a:blip xmlns:r="http://schemas.openxmlformats.org/officeDocument/2006/relationships" xmlns:a="http://schemas.openxmlformats.org/drawingml/2006/main" r:embed="R0685bcb0d6e74a02"/>
+          <a:blip xmlns:r="http://schemas.openxmlformats.org/officeDocument/2006/relationships" xmlns:a="http://schemas.openxmlformats.org/drawingml/2006/main" r:embed="R3a86223977d84601"/>
           <a:stretch xmlns:a="http://schemas.openxmlformats.org/drawingml/2006/main">
             <a:fillRect l="0" t="0" r="0" b="0"/>
           </a:stretch>
@@ -19708,7 +20261,7 @@
                 <a:ea typeface="Aptos"/>
                 <a:cs typeface="Aptos"/>
               </a:rPr>
-              <a:t>FutureMe AI · Project case study · July 2026</a:t>
+              <a:t>FutureMe AI · Project case study · August 2026</a:t>
             </a:r>
           </a:p>
         </p:txBody>
@@ -20415,7 +20968,7 @@
                 <a:ea typeface="Aptos"/>
                 <a:cs typeface="Aptos"/>
               </a:rPr>
-              <a:t>NOW · NEXT</a:t>
+              <a:t>CURRENT · NEXT</a:t>
             </a:r>
           </a:p>
         </p:txBody>
@@ -20913,7 +21466,7 @@
                 <a:ea typeface="Aptos"/>
                 <a:cs typeface="Aptos"/>
               </a:rPr>
-              <a:t>Phase 3: adapt Thai translation · validate instrument + missions · licensed route data · bias + safety audit</a:t>
+              <a:t>Phase 3: Thai adaptation · expert and student review · instrument + mission pilot · licensed route data · bias + safety audit</a:t>
             </a:r>
           </a:p>
         </p:txBody>
@@ -21406,7 +21959,7 @@
                 <a:ea typeface="Aptos"/>
                 <a:cs typeface="Aptos"/>
               </a:rPr>
-              <a:t>Full source registry: 01_Research/Data/REFERENCES.md</a:t>
+              <a:t>Repository evidence: README files · validation plan · source audit · geography provenance</a:t>
             </a:r>
           </a:p>
         </p:txBody>
@@ -21442,7 +21995,7 @@
           <p:nvPr/>
         </p:nvPicPr>
         <p:blipFill>
-          <a:blip xmlns:r="http://schemas.openxmlformats.org/officeDocument/2006/relationships" xmlns:a="http://schemas.openxmlformats.org/drawingml/2006/main" r:embed="R02928d35330a4a8e"/>
+          <a:blip xmlns:r="http://schemas.openxmlformats.org/officeDocument/2006/relationships" xmlns:a="http://schemas.openxmlformats.org/drawingml/2006/main" r:embed="R95ff095bc2154875"/>
           <a:stretch xmlns:a="http://schemas.openxmlformats.org/drawingml/2006/main">
             <a:fillRect l="0" t="0" r="0" b="0"/>
           </a:stretch>
@@ -21690,7 +22243,7 @@
           <p:nvPr/>
         </p:nvPicPr>
         <p:blipFill>
-          <a:blip xmlns:r="http://schemas.openxmlformats.org/officeDocument/2006/relationships" xmlns:a="http://schemas.openxmlformats.org/drawingml/2006/main" r:embed="R3130a64c6d2c4486"/>
+          <a:blip xmlns:r="http://schemas.openxmlformats.org/officeDocument/2006/relationships" xmlns:a="http://schemas.openxmlformats.org/drawingml/2006/main" r:embed="Rd6affd6591d748e6"/>
           <a:stretch xmlns:a="http://schemas.openxmlformats.org/drawingml/2006/main">
             <a:fillRect l="0" t="0" r="0" b="0"/>
           </a:stretch>
@@ -21756,7 +22309,7 @@
                 <a:ea typeface="Aptos"/>
                 <a:cs typeface="Aptos"/>
               </a:rPr>
-              <a:t>FutureMe AI · Project case study · July 2026</a:t>
+              <a:t>FutureMe AI · Project case study · August 2026</a:t>
             </a:r>
           </a:p>
         </p:txBody>
@@ -23443,7 +23996,7 @@
           <p:nvPr/>
         </p:nvPicPr>
         <p:blipFill>
-          <a:blip xmlns:r="http://schemas.openxmlformats.org/officeDocument/2006/relationships" xmlns:a="http://schemas.openxmlformats.org/drawingml/2006/main" r:embed="R27c76cb26cc64ebc"/>
+          <a:blip xmlns:r="http://schemas.openxmlformats.org/officeDocument/2006/relationships" xmlns:a="http://schemas.openxmlformats.org/drawingml/2006/main" r:embed="R70037ce6ade24c8a"/>
           <a:stretch xmlns:a="http://schemas.openxmlformats.org/drawingml/2006/main">
             <a:fillRect l="0" t="0" r="0" b="0"/>
           </a:stretch>
@@ -23691,7 +24244,7 @@
           <p:nvPr/>
         </p:nvPicPr>
         <p:blipFill>
-          <a:blip xmlns:r="http://schemas.openxmlformats.org/officeDocument/2006/relationships" xmlns:a="http://schemas.openxmlformats.org/drawingml/2006/main" r:embed="R0035f820308f490e"/>
+          <a:blip xmlns:r="http://schemas.openxmlformats.org/officeDocument/2006/relationships" xmlns:a="http://schemas.openxmlformats.org/drawingml/2006/main" r:embed="R0e197ca1a8ca436e"/>
           <a:stretch xmlns:a="http://schemas.openxmlformats.org/drawingml/2006/main">
             <a:fillRect l="0" t="0" r="0" b="0"/>
           </a:stretch>
@@ -23757,7 +24310,7 @@
                 <a:ea typeface="Aptos"/>
                 <a:cs typeface="Aptos"/>
               </a:rPr>
-              <a:t>FutureMe AI · Project case study · July 2026</a:t>
+              <a:t>FutureMe AI · Project case study · August 2026</a:t>
             </a:r>
           </a:p>
         </p:txBody>
@@ -24852,7 +25405,7 @@
           <p:nvPr/>
         </p:nvPicPr>
         <p:blipFill>
-          <a:blip xmlns:r="http://schemas.openxmlformats.org/officeDocument/2006/relationships" xmlns:a="http://schemas.openxmlformats.org/drawingml/2006/main" r:embed="R131ecc95a4ff4d9e"/>
+          <a:blip xmlns:r="http://schemas.openxmlformats.org/officeDocument/2006/relationships" xmlns:a="http://schemas.openxmlformats.org/drawingml/2006/main" r:embed="R0e44b6b0efde4738"/>
           <a:stretch xmlns:a="http://schemas.openxmlformats.org/drawingml/2006/main">
             <a:fillRect l="0" t="0" r="0" b="0"/>
           </a:stretch>
@@ -24918,7 +25471,7 @@
                 <a:ea typeface="Aptos"/>
                 <a:cs typeface="Aptos"/>
               </a:rPr>
-              <a:t>CURRENT GAP</a:t>
+              <a:t>DATA PIPELINE</a:t>
             </a:r>
           </a:p>
         </p:txBody>
@@ -24974,7 +25527,7 @@
                 <a:ea typeface="Aptos"/>
                 <a:cs typeface="Aptos"/>
               </a:rPr>
-              <a:t>Information exists. Interpretation is fragmented.</a:t>
+              <a:t>The data pipeline keeps limits attached</a:t>
             </a:r>
           </a:p>
         </p:txBody>
@@ -25030,7 +25583,7 @@
                 <a:ea typeface="Aptos"/>
                 <a:cs typeface="Aptos"/>
               </a:rPr>
-              <a:t>The gap is not another list—it is a visible chain from self-knowledge to action.</a:t>
+              <a:t>Source dates, unknowns and integrity checks travel with every demo record.</a:t>
             </a:r>
           </a:p>
         </p:txBody>
@@ -25100,7 +25653,7 @@
           <p:nvPr/>
         </p:nvPicPr>
         <p:blipFill>
-          <a:blip xmlns:r="http://schemas.openxmlformats.org/officeDocument/2006/relationships" xmlns:a="http://schemas.openxmlformats.org/drawingml/2006/main" r:embed="R4a1aac2deed54a8c"/>
+          <a:blip xmlns:r="http://schemas.openxmlformats.org/officeDocument/2006/relationships" xmlns:a="http://schemas.openxmlformats.org/drawingml/2006/main" r:embed="Rc2c92fd4024a47a0"/>
           <a:stretch xmlns:a="http://schemas.openxmlformats.org/drawingml/2006/main">
             <a:fillRect l="0" t="0" r="0" b="0"/>
           </a:stretch>
@@ -25166,7 +25719,7 @@
                 <a:ea typeface="Aptos"/>
                 <a:cs typeface="Aptos"/>
               </a:rPr>
-              <a:t>FutureMe AI · Project case study · July 2026</a:t>
+              <a:t>FutureMe AI · Project case study · August 2026</a:t>
             </a:r>
           </a:p>
         </p:txBody>
@@ -25222,7 +25775,7 @@
                 <a:ea typeface="Aptos"/>
                 <a:cs typeface="Aptos"/>
               </a:rPr>
-              <a:t>SEARCH</a:t>
+              <a:t>SOURCE</a:t>
             </a:r>
           </a:p>
         </p:txBody>
@@ -25333,9 +25886,57 @@
                 <a:ea typeface="Aptos"/>
                 <a:cs typeface="Aptos"/>
               </a:rPr>
-              <a:t>School plans
-TCAS pages
-Career sites</a:t>
+              <a:t>Official registers</a:t>
+            </a:r>
+          </a:p>
+          <a:p xmlns:a="http://schemas.openxmlformats.org/drawingml/2006/main">
+            <a:pPr algn="ctr">
+              <a:lnSpc>
+                <a:spcPct val="100000"/>
+              </a:lnSpc>
+              <a:spcBef>
+                <a:spcPts val="0"/>
+              </a:spcBef>
+              <a:spcAft>
+                <a:spcPts val="0"/>
+              </a:spcAft>
+              <a:buNone/>
+            </a:pPr>
+            <a:r>
+              <a:rPr sz="1500" b="1" i="0">
+                <a:solidFill>
+                  <a:srgbClr val="F5F5FA"/>
+                </a:solidFill>
+                <a:latin typeface="Aptos"/>
+                <a:ea typeface="Aptos"/>
+                <a:cs typeface="Aptos"/>
+              </a:rPr>
+              <a:t>Audited research</a:t>
+            </a:r>
+          </a:p>
+          <a:p xmlns:a="http://schemas.openxmlformats.org/drawingml/2006/main">
+            <a:pPr algn="ctr">
+              <a:lnSpc>
+                <a:spcPct val="100000"/>
+              </a:lnSpc>
+              <a:spcBef>
+                <a:spcPts val="0"/>
+              </a:spcBef>
+              <a:spcAft>
+                <a:spcPts val="0"/>
+              </a:spcAft>
+              <a:buNone/>
+            </a:pPr>
+            <a:r>
+              <a:rPr sz="1500" b="1" i="0">
+                <a:solidFill>
+                  <a:srgbClr val="F5F5FA"/>
+                </a:solidFill>
+                <a:latin typeface="Aptos"/>
+                <a:ea typeface="Aptos"/>
+                <a:cs typeface="Aptos"/>
+              </a:rPr>
+              <a:t>Project items</a:t>
             </a:r>
           </a:p>
         </p:txBody>
@@ -25447,7 +26048,7 @@
                 <a:ea typeface="Aptos"/>
                 <a:cs typeface="Aptos"/>
               </a:rPr>
-              <a:t>TEST</a:t>
+              <a:t>TRANSFORM</a:t>
             </a:r>
           </a:p>
         </p:txBody>
@@ -25558,8 +26159,32 @@
                 <a:ea typeface="Aptos"/>
                 <a:cs typeface="Aptos"/>
               </a:rPr>
-              <a:t>Static interest
-questionnaire</a:t>
+              <a:t>Reproducible scripts</a:t>
+            </a:r>
+          </a:p>
+          <a:p xmlns:a="http://schemas.openxmlformats.org/drawingml/2006/main">
+            <a:pPr algn="ctr">
+              <a:lnSpc>
+                <a:spcPct val="100000"/>
+              </a:lnSpc>
+              <a:spcBef>
+                <a:spcPts val="0"/>
+              </a:spcBef>
+              <a:spcAft>
+                <a:spcPts val="0"/>
+              </a:spcAft>
+              <a:buNone/>
+            </a:pPr>
+            <a:r>
+              <a:rPr sz="1500" b="1" i="0">
+                <a:solidFill>
+                  <a:srgbClr val="F5F5FA"/>
+                </a:solidFill>
+                <a:latin typeface="Aptos"/>
+                <a:ea typeface="Aptos"/>
+                <a:cs typeface="Aptos"/>
+              </a:rPr>
+              <a:t>Typed JSON</a:t>
             </a:r>
           </a:p>
         </p:txBody>
@@ -25671,7 +26296,7 @@
                 <a:ea typeface="Aptos"/>
                 <a:cs typeface="Aptos"/>
               </a:rPr>
-              <a:t>RESULT</a:t>
+              <a:t>VALIDATE</a:t>
             </a:r>
           </a:p>
         </p:txBody>
@@ -25782,8 +26407,32 @@
                 <a:ea typeface="Aptos"/>
                 <a:cs typeface="Aptos"/>
               </a:rPr>
-              <a:t>Generic career
-or faculty list</a:t>
+              <a:t>Schema · counts</a:t>
+            </a:r>
+          </a:p>
+          <a:p xmlns:a="http://schemas.openxmlformats.org/drawingml/2006/main">
+            <a:pPr algn="ctr">
+              <a:lnSpc>
+                <a:spcPct val="100000"/>
+              </a:lnSpc>
+              <a:spcBef>
+                <a:spcPts val="0"/>
+              </a:spcBef>
+              <a:spcAft>
+                <a:spcPts val="0"/>
+              </a:spcAft>
+              <a:buNone/>
+            </a:pPr>
+            <a:r>
+              <a:rPr sz="1500" b="1" i="0">
+                <a:solidFill>
+                  <a:srgbClr val="F5F5FA"/>
+                </a:solidFill>
+                <a:latin typeface="Aptos"/>
+                <a:ea typeface="Aptos"/>
+                <a:cs typeface="Aptos"/>
+              </a:rPr>
+              <a:t>Hashes · cross-file</a:t>
             </a:r>
           </a:p>
         </p:txBody>
@@ -25895,7 +26544,7 @@
                 <a:ea typeface="Aptos"/>
                 <a:cs typeface="Aptos"/>
               </a:rPr>
-              <a:t>AFTER</a:t>
+              <a:t>SERVE</a:t>
             </a:r>
           </a:p>
         </p:txBody>
@@ -26006,8 +26655,32 @@
                 <a:ea typeface="Aptos"/>
                 <a:cs typeface="Aptos"/>
               </a:rPr>
-              <a:t>Still unsure
-what to try</a:t>
+              <a:t>Browser API</a:t>
+            </a:r>
+          </a:p>
+          <a:p xmlns:a="http://schemas.openxmlformats.org/drawingml/2006/main">
+            <a:pPr algn="ctr">
+              <a:lnSpc>
+                <a:spcPct val="100000"/>
+              </a:lnSpc>
+              <a:spcBef>
+                <a:spcPts val="0"/>
+              </a:spcBef>
+              <a:spcAft>
+                <a:spcPts val="0"/>
+              </a:spcAft>
+              <a:buNone/>
+            </a:pPr>
+            <a:r>
+              <a:rPr sz="1500" b="1" i="0">
+                <a:solidFill>
+                  <a:srgbClr val="F5F5FA"/>
+                </a:solidFill>
+                <a:latin typeface="Aptos"/>
+                <a:ea typeface="Aptos"/>
+                <a:cs typeface="Aptos"/>
+              </a:rPr>
+              <a:t>Warnings included</a:t>
             </a:r>
           </a:p>
         </p:txBody>
@@ -26063,7 +26736,7 @@
                 <a:ea typeface="Aptos"/>
                 <a:cs typeface="Aptos"/>
               </a:rPr>
-              <a:t>What is missing</a:t>
+              <a:t>Controls that stay visible</a:t>
             </a:r>
           </a:p>
         </p:txBody>
@@ -26229,7 +26902,7 @@
                 <a:ea typeface="Aptos"/>
                 <a:cs typeface="Aptos"/>
               </a:rPr>
-              <a:t>WHAT I SAID</a:t>
+              <a:t>PROVENANCE</a:t>
             </a:r>
           </a:p>
         </p:txBody>
@@ -26396,7 +27069,7 @@
                 <a:ea typeface="Aptos"/>
                 <a:cs typeface="Aptos"/>
               </a:rPr>
-              <a:t>WHAT I TRIED</a:t>
+              <a:t>CHECKSUMS</a:t>
             </a:r>
           </a:p>
         </p:txBody>
@@ -26563,7 +27236,7 @@
                 <a:ea typeface="Aptos"/>
                 <a:cs typeface="Aptos"/>
               </a:rPr>
-              <a:t>WHY THIS ROUTE</a:t>
+              <a:t>UNKNOWNS</a:t>
             </a:r>
           </a:p>
         </p:txBody>
@@ -26730,7 +27403,7 @@
                 <a:ea typeface="Aptos"/>
                 <a:cs typeface="Aptos"/>
               </a:rPr>
-              <a:t>WHAT TO DO NEXT</a:t>
+              <a:t>FRESHNESS</a:t>
             </a:r>
           </a:p>
         </p:txBody>
@@ -26786,7 +27459,7 @@
                 <a:ea typeface="Aptos"/>
                 <a:cs typeface="Aptos"/>
               </a:rPr>
-              <a:t>Admission criteria expire. Career-to-programme links are many-to-many. A trustworthy product must show scope, date and source.</a:t>
+              <a:t>1,961 institution options across 77 provinces; 207 coordinates and 987 websites remain explicitly unknown.</a:t>
             </a:r>
           </a:p>
         </p:txBody>
@@ -26842,7 +27515,7 @@
                 <a:ea typeface="Aptos"/>
                 <a:cs typeface="Aptos"/>
               </a:rPr>
-              <a:t>Sources: FutureMe Data/RAG_DATA_SPEC; curriculum and source-audit files</a:t>
+              <a:t>Sources: Geography PROVENANCE + check:data; integration review 11 Aug 2026</a:t>
             </a:r>
           </a:p>
         </p:txBody>
@@ -26878,7 +27551,7 @@
           <p:nvPr/>
         </p:nvPicPr>
         <p:blipFill>
-          <a:blip xmlns:r="http://schemas.openxmlformats.org/officeDocument/2006/relationships" xmlns:a="http://schemas.openxmlformats.org/drawingml/2006/main" r:embed="R611243bf86714bc5"/>
+          <a:blip xmlns:r="http://schemas.openxmlformats.org/officeDocument/2006/relationships" xmlns:a="http://schemas.openxmlformats.org/drawingml/2006/main" r:embed="R0f29ee9d7fd44ae2"/>
           <a:stretch xmlns:a="http://schemas.openxmlformats.org/drawingml/2006/main">
             <a:fillRect l="0" t="0" r="0" b="0"/>
           </a:stretch>
@@ -27126,7 +27799,7 @@
           <p:nvPr/>
         </p:nvPicPr>
         <p:blipFill>
-          <a:blip xmlns:r="http://schemas.openxmlformats.org/officeDocument/2006/relationships" xmlns:a="http://schemas.openxmlformats.org/drawingml/2006/main" r:embed="R378b2a52811c47ae"/>
+          <a:blip xmlns:r="http://schemas.openxmlformats.org/officeDocument/2006/relationships" xmlns:a="http://schemas.openxmlformats.org/drawingml/2006/main" r:embed="R02a26cded7ac4c12"/>
           <a:stretch xmlns:a="http://schemas.openxmlformats.org/drawingml/2006/main">
             <a:fillRect l="0" t="0" r="0" b="0"/>
           </a:stretch>
@@ -27192,7 +27865,7 @@
                 <a:ea typeface="Aptos"/>
                 <a:cs typeface="Aptos"/>
               </a:rPr>
-              <a:t>FutureMe AI · Project case study · July 2026</a:t>
+              <a:t>FutureMe AI · Project case study · August 2026</a:t>
             </a:r>
           </a:p>
         </p:txBody>
@@ -28804,7 +29477,7 @@
           <p:nvPr/>
         </p:nvPicPr>
         <p:blipFill>
-          <a:blip xmlns:r="http://schemas.openxmlformats.org/officeDocument/2006/relationships" xmlns:a="http://schemas.openxmlformats.org/drawingml/2006/main" r:embed="Rfc1f4af5ed504228"/>
+          <a:blip xmlns:r="http://schemas.openxmlformats.org/officeDocument/2006/relationships" xmlns:a="http://schemas.openxmlformats.org/drawingml/2006/main" r:embed="R44d21ec7e4724530"/>
           <a:stretch xmlns:a="http://schemas.openxmlformats.org/drawingml/2006/main">
             <a:fillRect l="0" t="0" r="0" b="0"/>
           </a:stretch>
@@ -29052,7 +29725,7 @@
           <p:nvPr/>
         </p:nvPicPr>
         <p:blipFill>
-          <a:blip xmlns:r="http://schemas.openxmlformats.org/officeDocument/2006/relationships" xmlns:a="http://schemas.openxmlformats.org/drawingml/2006/main" r:embed="Raa383a28288840af"/>
+          <a:blip xmlns:r="http://schemas.openxmlformats.org/officeDocument/2006/relationships" xmlns:a="http://schemas.openxmlformats.org/drawingml/2006/main" r:embed="R1ba025fc02684670"/>
           <a:stretch xmlns:a="http://schemas.openxmlformats.org/drawingml/2006/main">
             <a:fillRect l="0" t="0" r="0" b="0"/>
           </a:stretch>
@@ -29118,7 +29791,7 @@
                 <a:ea typeface="Aptos"/>
                 <a:cs typeface="Aptos"/>
               </a:rPr>
-              <a:t>FutureMe AI · Project case study · July 2026</a:t>
+              <a:t>FutureMe AI · Project case study · August 2026</a:t>
             </a:r>
           </a:p>
         </p:txBody>
@@ -31279,7 +31952,7 @@
                 <a:ea typeface="Aptos"/>
                 <a:cs typeface="Aptos"/>
               </a:rPr>
-              <a:t>The current 30-item instrument is research-informed—but has never been validated.</a:t>
+              <a:t>The live 30-item instrument and both future banks remain unvalidated for real learners.</a:t>
             </a:r>
           </a:p>
         </p:txBody>
@@ -31371,7 +32044,7 @@
           <p:nvPr/>
         </p:nvPicPr>
         <p:blipFill>
-          <a:blip xmlns:r="http://schemas.openxmlformats.org/officeDocument/2006/relationships" xmlns:a="http://schemas.openxmlformats.org/drawingml/2006/main" r:embed="R1bc7e23c182e49bc"/>
+          <a:blip xmlns:r="http://schemas.openxmlformats.org/officeDocument/2006/relationships" xmlns:a="http://schemas.openxmlformats.org/drawingml/2006/main" r:embed="R1305fed729d04c1f"/>
           <a:stretch xmlns:a="http://schemas.openxmlformats.org/drawingml/2006/main">
             <a:fillRect l="0" t="0" r="0" b="0"/>
           </a:stretch>
@@ -31619,7 +32292,7 @@
           <p:nvPr/>
         </p:nvPicPr>
         <p:blipFill>
-          <a:blip xmlns:r="http://schemas.openxmlformats.org/officeDocument/2006/relationships" xmlns:a="http://schemas.openxmlformats.org/drawingml/2006/main" r:embed="R83bb62cb639f4993"/>
+          <a:blip xmlns:r="http://schemas.openxmlformats.org/officeDocument/2006/relationships" xmlns:a="http://schemas.openxmlformats.org/drawingml/2006/main" r:embed="R5c2e5340f0e641bf"/>
           <a:stretch xmlns:a="http://schemas.openxmlformats.org/drawingml/2006/main">
             <a:fillRect l="0" t="0" r="0" b="0"/>
           </a:stretch>
@@ -31685,7 +32358,7 @@
                 <a:ea typeface="Aptos"/>
                 <a:cs typeface="Aptos"/>
               </a:rPr>
-              <a:t>FutureMe AI · Project case study · July 2026</a:t>
+              <a:t>FutureMe AI · Project case study · August 2026</a:t>
             </a:r>
           </a:p>
         </p:txBody>
@@ -33223,7 +33896,7 @@
           <p:nvPr/>
         </p:nvPicPr>
         <p:blipFill>
-          <a:blip xmlns:r="http://schemas.openxmlformats.org/officeDocument/2006/relationships" xmlns:a="http://schemas.openxmlformats.org/drawingml/2006/main" r:embed="Rf94c53b383f543a2"/>
+          <a:blip xmlns:r="http://schemas.openxmlformats.org/officeDocument/2006/relationships" xmlns:a="http://schemas.openxmlformats.org/drawingml/2006/main" r:embed="R82b9b79fd1104694"/>
           <a:stretch xmlns:a="http://schemas.openxmlformats.org/drawingml/2006/main">
             <a:fillRect l="0" t="0" r="0" b="0"/>
           </a:stretch>
@@ -33471,7 +34144,7 @@
           <p:nvPr/>
         </p:nvPicPr>
         <p:blipFill>
-          <a:blip xmlns:r="http://schemas.openxmlformats.org/officeDocument/2006/relationships" xmlns:a="http://schemas.openxmlformats.org/drawingml/2006/main" r:embed="R4475432bd30f4596"/>
+          <a:blip xmlns:r="http://schemas.openxmlformats.org/officeDocument/2006/relationships" xmlns:a="http://schemas.openxmlformats.org/drawingml/2006/main" r:embed="Rbcc86cf6082a4c31"/>
           <a:stretch xmlns:a="http://schemas.openxmlformats.org/drawingml/2006/main">
             <a:fillRect l="0" t="0" r="0" b="0"/>
           </a:stretch>
@@ -33537,7 +34210,7 @@
                 <a:ea typeface="Aptos"/>
                 <a:cs typeface="Aptos"/>
               </a:rPr>
-              <a:t>FutureMe AI · Project case study · July 2026</a:t>
+              <a:t>FutureMe AI · Project case study · August 2026</a:t>
             </a:r>
           </a:p>
         </p:txBody>
@@ -33758,8 +34431,32 @@
                 <a:ea typeface="Aptos"/>
                 <a:cs typeface="Aptos"/>
               </a:rPr>
-              <a:t>30-item
-interest profile</a:t>
+              <a:t>30 live items</a:t>
+            </a:r>
+          </a:p>
+          <a:p xmlns:a="http://schemas.openxmlformats.org/drawingml/2006/main">
+            <a:pPr algn="ctr">
+              <a:lnSpc>
+                <a:spcPct val="100000"/>
+              </a:lnSpc>
+              <a:spcBef>
+                <a:spcPts val="0"/>
+              </a:spcBef>
+              <a:spcAft>
+                <a:spcPts val="0"/>
+              </a:spcAft>
+              <a:buNone/>
+            </a:pPr>
+            <a:r>
+              <a:rPr sz="1400" b="1" i="0">
+                <a:solidFill>
+                  <a:srgbClr val="F5F5FA"/>
+                </a:solidFill>
+                <a:latin typeface="Aptos"/>
+                <a:ea typeface="Aptos"/>
+                <a:cs typeface="Aptos"/>
+              </a:rPr>
+              <a:t>+ first-answer follow-ups</a:t>
             </a:r>
           </a:p>
         </p:txBody>
@@ -35130,7 +35827,7 @@
           <p:nvPr/>
         </p:nvPicPr>
         <p:blipFill>
-          <a:blip xmlns:r="http://schemas.openxmlformats.org/officeDocument/2006/relationships" xmlns:a="http://schemas.openxmlformats.org/drawingml/2006/main" r:embed="R6fbf0239ad79472d"/>
+          <a:blip xmlns:r="http://schemas.openxmlformats.org/officeDocument/2006/relationships" xmlns:a="http://schemas.openxmlformats.org/drawingml/2006/main" r:embed="Ra2dcce338e7140d8"/>
           <a:stretch xmlns:a="http://schemas.openxmlformats.org/drawingml/2006/main">
             <a:fillRect l="0" t="0" r="0" b="0"/>
           </a:stretch>
@@ -35378,7 +36075,7 @@
           <p:nvPr/>
         </p:nvPicPr>
         <p:blipFill>
-          <a:blip xmlns:r="http://schemas.openxmlformats.org/officeDocument/2006/relationships" xmlns:a="http://schemas.openxmlformats.org/drawingml/2006/main" r:embed="R013b3fd75e91438a"/>
+          <a:blip xmlns:r="http://schemas.openxmlformats.org/officeDocument/2006/relationships" xmlns:a="http://schemas.openxmlformats.org/drawingml/2006/main" r:embed="R5204435e7950447a"/>
           <a:stretch xmlns:a="http://schemas.openxmlformats.org/drawingml/2006/main">
             <a:fillRect l="0" t="0" r="0" b="0"/>
           </a:stretch>
@@ -35444,7 +36141,7 @@
                 <a:ea typeface="Aptos"/>
                 <a:cs typeface="Aptos"/>
               </a:rPr>
-              <a:t>FutureMe AI · Project case study · July 2026</a:t>
+              <a:t>FutureMe AI · Project case study · August 2026</a:t>
             </a:r>
           </a:p>
         </p:txBody>
@@ -35652,8 +36349,32 @@
                 <a:ea typeface="Aptos"/>
                 <a:cs typeface="Aptos"/>
               </a:rPr>
-              <a:t>What activities
-draw me?</a:t>
+              <a:t>What do I like—</a:t>
+            </a:r>
+          </a:p>
+          <a:p xmlns:a="http://schemas.openxmlformats.org/drawingml/2006/main">
+            <a:pPr algn="ctr">
+              <a:lnSpc>
+                <a:spcPct val="100000"/>
+              </a:lnSpc>
+              <a:spcBef>
+                <a:spcPts val="0"/>
+              </a:spcBef>
+              <a:spcAft>
+                <a:spcPts val="0"/>
+              </a:spcAft>
+              <a:buNone/>
+            </a:pPr>
+            <a:r>
+              <a:rPr sz="1550" b="1" i="0">
+                <a:solidFill>
+                  <a:srgbClr val="F5F5FA"/>
+                </a:solidFill>
+                <a:latin typeface="Aptos"/>
+                <a:ea typeface="Aptos"/>
+                <a:cs typeface="Aptos"/>
+              </a:rPr>
+              <a:t>and what follows?</a:t>
             </a:r>
           </a:p>
         </p:txBody>
@@ -35764,8 +36485,32 @@
                 <a:ea typeface="Aptos"/>
                 <a:cs typeface="Aptos"/>
               </a:rPr>
-              <a:t>Provisional
-RIASEC vector</a:t>
+              <a:t>30 items; answer 1</a:t>
+            </a:r>
+          </a:p>
+          <a:p xmlns:a="http://schemas.openxmlformats.org/drawingml/2006/main">
+            <a:pPr algn="ctr">
+              <a:lnSpc>
+                <a:spcPct val="100000"/>
+              </a:lnSpc>
+              <a:spcBef>
+                <a:spcPts val="0"/>
+              </a:spcBef>
+              <a:spcAft>
+                <a:spcPts val="0"/>
+              </a:spcAft>
+              <a:buNone/>
+            </a:pPr>
+            <a:r>
+              <a:rPr sz="1150" b="0" i="0">
+                <a:solidFill>
+                  <a:srgbClr val="A8A8BE"/>
+                </a:solidFill>
+                <a:latin typeface="Aptos"/>
+                <a:ea typeface="Aptos"/>
+                <a:cs typeface="Aptos"/>
+              </a:rPr>
+              <a:t>reorders the next two</a:t>
             </a:r>
           </a:p>
         </p:txBody>

</xml_diff>

<commit_message>
release: validate and document FutureMe 0.2.0
</commit_message>
<xml_diff>
--- a/Presentation/FutureMe_Project_Presentation.pptx
+++ b/Presentation/FutureMe_Project_Presentation.pptx
@@ -2,27 +2,27 @@
 <file path=ppt/presentation.xml><?xml version="1.0" encoding="utf-8"?>
 <p:presentation xmlns:p="http://schemas.openxmlformats.org/presentationml/2006/main">
   <p:sldMasterIdLst>
-    <p:sldMasterId xmlns:r="http://schemas.openxmlformats.org/officeDocument/2006/relationships" id="2147483648" r:id="R7094ddbbe93a4f5a"/>
+    <p:sldMasterId xmlns:r="http://schemas.openxmlformats.org/officeDocument/2006/relationships" id="2147483648" r:id="R2beda2e2d67540e6"/>
   </p:sldMasterIdLst>
   <p:notesMasterIdLst>
-    <p:notesMasterId xmlns:r="http://schemas.openxmlformats.org/officeDocument/2006/relationships" r:id="R8073e5e1d9cc4904"/>
+    <p:notesMasterId xmlns:r="http://schemas.openxmlformats.org/officeDocument/2006/relationships" r:id="R97b91ab850f54e9c"/>
   </p:notesMasterIdLst>
   <p:sldIdLst>
-    <p:sldId xmlns:r="http://schemas.openxmlformats.org/officeDocument/2006/relationships" id="256" r:id="Rff8adb23ee2b4f63"/>
-    <p:sldId xmlns:r="http://schemas.openxmlformats.org/officeDocument/2006/relationships" id="257" r:id="Rbf47c7534741407e"/>
-    <p:sldId xmlns:r="http://schemas.openxmlformats.org/officeDocument/2006/relationships" id="258" r:id="R1f5bd94ec06c4aeb"/>
-    <p:sldId xmlns:r="http://schemas.openxmlformats.org/officeDocument/2006/relationships" id="259" r:id="R76cf64df602e4bfd"/>
-    <p:sldId xmlns:r="http://schemas.openxmlformats.org/officeDocument/2006/relationships" id="260" r:id="R2404a7faeefe4801"/>
-    <p:sldId xmlns:r="http://schemas.openxmlformats.org/officeDocument/2006/relationships" id="261" r:id="Rf615e8877c854422"/>
-    <p:sldId xmlns:r="http://schemas.openxmlformats.org/officeDocument/2006/relationships" id="262" r:id="R21f6784c81a0478a"/>
-    <p:sldId xmlns:r="http://schemas.openxmlformats.org/officeDocument/2006/relationships" id="263" r:id="R9799b24dcebf4bfe"/>
-    <p:sldId xmlns:r="http://schemas.openxmlformats.org/officeDocument/2006/relationships" id="264" r:id="R57bfba2ad1a54080"/>
-    <p:sldId xmlns:r="http://schemas.openxmlformats.org/officeDocument/2006/relationships" id="265" r:id="Re459bddfd2974021"/>
-    <p:sldId xmlns:r="http://schemas.openxmlformats.org/officeDocument/2006/relationships" id="266" r:id="R073d63f588754895"/>
-    <p:sldId xmlns:r="http://schemas.openxmlformats.org/officeDocument/2006/relationships" id="267" r:id="Rc03cee49b4074ca2"/>
-    <p:sldId xmlns:r="http://schemas.openxmlformats.org/officeDocument/2006/relationships" id="268" r:id="R572aa0e1d6e546f8"/>
-    <p:sldId xmlns:r="http://schemas.openxmlformats.org/officeDocument/2006/relationships" id="269" r:id="R74fadf0998174441"/>
-    <p:sldId xmlns:r="http://schemas.openxmlformats.org/officeDocument/2006/relationships" id="270" r:id="Rbb8be573a95843b4"/>
+    <p:sldId xmlns:r="http://schemas.openxmlformats.org/officeDocument/2006/relationships" id="256" r:id="Red065a5b95ea45b9"/>
+    <p:sldId xmlns:r="http://schemas.openxmlformats.org/officeDocument/2006/relationships" id="257" r:id="R63c67e71e44741bf"/>
+    <p:sldId xmlns:r="http://schemas.openxmlformats.org/officeDocument/2006/relationships" id="258" r:id="Rab6097b44e604512"/>
+    <p:sldId xmlns:r="http://schemas.openxmlformats.org/officeDocument/2006/relationships" id="259" r:id="R8f998eeb127b40d8"/>
+    <p:sldId xmlns:r="http://schemas.openxmlformats.org/officeDocument/2006/relationships" id="260" r:id="R49b2a7dfb7a646c2"/>
+    <p:sldId xmlns:r="http://schemas.openxmlformats.org/officeDocument/2006/relationships" id="261" r:id="R24f1eae5cd034441"/>
+    <p:sldId xmlns:r="http://schemas.openxmlformats.org/officeDocument/2006/relationships" id="262" r:id="Re9745b70a6464470"/>
+    <p:sldId xmlns:r="http://schemas.openxmlformats.org/officeDocument/2006/relationships" id="263" r:id="Rdf3287bd36984e60"/>
+    <p:sldId xmlns:r="http://schemas.openxmlformats.org/officeDocument/2006/relationships" id="264" r:id="R90e689b1fca2431f"/>
+    <p:sldId xmlns:r="http://schemas.openxmlformats.org/officeDocument/2006/relationships" id="265" r:id="R31faee0125894f7e"/>
+    <p:sldId xmlns:r="http://schemas.openxmlformats.org/officeDocument/2006/relationships" id="266" r:id="Rf9a8023a2f4f4dfd"/>
+    <p:sldId xmlns:r="http://schemas.openxmlformats.org/officeDocument/2006/relationships" id="267" r:id="R034c5a52de9845ff"/>
+    <p:sldId xmlns:r="http://schemas.openxmlformats.org/officeDocument/2006/relationships" id="268" r:id="Rbeecd9691de74aa5"/>
+    <p:sldId xmlns:r="http://schemas.openxmlformats.org/officeDocument/2006/relationships" id="269" r:id="Rfbe15e4c6e9d4ece"/>
+    <p:sldId xmlns:r="http://schemas.openxmlformats.org/officeDocument/2006/relationships" id="270" r:id="R1271a98057424998"/>
   </p:sldIdLst>
   <p:sldSz cx="12191695" cy="6858000"/>
   <p:notesSz cx="6858000" cy="9144000"/>
@@ -494,7 +494,7 @@
           </a:p>
           <a:p xmlns:a="http://schemas.openxmlformats.org/drawingml/2006/main">
             <a:r>
-              <a:t>- 03_WebApp/Pre_Present/READMEEN.md — implemented learner journey</a:t>
+              <a:t>- 03_WebApp/READMEEN.md — implemented learner journey</a:t>
             </a:r>
           </a:p>
           <a:p xmlns:a="http://schemas.openxmlformats.org/drawingml/2006/main">
@@ -584,17 +584,27 @@
           </a:p>
           <a:p xmlns:a="http://schemas.openxmlformats.org/drawingml/2006/main">
             <a:r>
-              <a:t>- 03_WebApp/Pre_Present/data/question_bank_1000.json — restored research bank</a:t>
-            </a:r>
-          </a:p>
-          <a:p xmlns:a="http://schemas.openxmlformats.org/drawingml/2006/main">
-            <a:r>
-              <a:t>- 03_WebApp/Pre_Present/scripts/validate-future-question-bank.mjs — structural validation</a:t>
-            </a:r>
-          </a:p>
-          <a:p xmlns:a="http://schemas.openxmlformats.org/drawingml/2006/main">
-            <a:r>
-              <a:t>- 03_WebApp/Pre_Present/docs/05-system-architecture.md — current/planned architecture boundary</a:t>
+              <a:t>- 03_WebApp/data/question_bank_1000.json — restored research bank</a:t>
+            </a:r>
+          </a:p>
+          <a:p xmlns:a="http://schemas.openxmlformats.org/drawingml/2006/main">
+            <a:r>
+              <a:t>- 03_WebApp/scripts/validate-future-question-bank.mjs — structural validation</a:t>
+            </a:r>
+          </a:p>
+          <a:p xmlns:a="http://schemas.openxmlformats.org/drawingml/2006/main">
+            <a:r>
+              <a:t>- 03_WebApp/docs/05-system-architecture.md — current/planned architecture boundary</a:t>
+            </a:r>
+          </a:p>
+          <a:p xmlns:a="http://schemas.openxmlformats.org/drawingml/2006/main">
+            <a:r>
+              <a:t>- 03_WebApp/data/release.json — component versions and implementation status</a:t>
+            </a:r>
+          </a:p>
+          <a:p xmlns:a="http://schemas.openxmlformats.org/drawingml/2006/main">
+            <a:r>
+              <a:t>- 03_WebApp/data/education-data-registry.json — held-out decision fields</a:t>
             </a:r>
           </a:p>
           <a:p xmlns:a="http://schemas.openxmlformats.org/drawingml/2006/main">
@@ -679,12 +689,12 @@
           </a:p>
           <a:p xmlns:a="http://schemas.openxmlformats.org/drawingml/2006/main">
             <a:r>
-              <a:t>- 03_WebApp/Pre_Present/lib/decision-engine — current implementation</a:t>
-            </a:r>
-          </a:p>
-          <a:p xmlns:a="http://schemas.openxmlformats.org/drawingml/2006/main">
-            <a:r>
-              <a:t>- 03_WebApp/Pre_Present/docs/04-ai-system.md — scoring and AI boundary</a:t>
+              <a:t>- 03_WebApp/lib/decision-engine — current implementation</a:t>
+            </a:r>
+          </a:p>
+          <a:p xmlns:a="http://schemas.openxmlformats.org/drawingml/2006/main">
+            <a:r>
+              <a:t>- 03_WebApp/docs/04-ai-system.md — scoring and AI boundary</a:t>
             </a:r>
           </a:p>
           <a:p xmlns:a="http://schemas.openxmlformats.org/drawingml/2006/main">
@@ -769,22 +779,27 @@
           </a:p>
           <a:p xmlns:a="http://schemas.openxmlformats.org/drawingml/2006/main">
             <a:r>
-              <a:t>- 03_WebApp/Pre_Present/assets/screenshots/app/interview-2026-08-09.png — Reflect screen</a:t>
-            </a:r>
-          </a:p>
-          <a:p xmlns:a="http://schemas.openxmlformats.org/drawingml/2006/main">
-            <a:r>
-              <a:t>- 03_WebApp/Pre_Present/assets/screenshots/app/routes-2026-08-09.png — Explore screen</a:t>
-            </a:r>
-          </a:p>
-          <a:p xmlns:a="http://schemas.openxmlformats.org/drawingml/2006/main">
-            <a:r>
-              <a:t>- 03_WebApp/Pre_Present/assets/screenshots/app/plan-2026-08-09.png — Act screen</a:t>
-            </a:r>
-          </a:p>
-          <a:p xmlns:a="http://schemas.openxmlformats.org/drawingml/2006/main">
-            <a:r>
-              <a:t>- npm test, 11 Aug 2026 — 26 files and 529 tests passed</a:t>
+              <a:t>- 03_WebApp/assets/screenshots/app/interview-2026-08-09.png — Reflect screen</a:t>
+            </a:r>
+          </a:p>
+          <a:p xmlns:a="http://schemas.openxmlformats.org/drawingml/2006/main">
+            <a:r>
+              <a:t>- 03_WebApp/assets/screenshots/app/routes-2026-08-09.png — Explore screen</a:t>
+            </a:r>
+          </a:p>
+          <a:p xmlns:a="http://schemas.openxmlformats.org/drawingml/2006/main">
+            <a:r>
+              <a:t>- 03_WebApp/assets/screenshots/app/plan-2026-08-09.png — Act screen</a:t>
+            </a:r>
+          </a:p>
+          <a:p xmlns:a="http://schemas.openxmlformats.org/drawingml/2006/main">
+            <a:r>
+              <a:t>- npm run verify, 11 Aug 2026 — 27 files and 533 tests plus production build passed</a:t>
+            </a:r>
+          </a:p>
+          <a:p xmlns:a="http://schemas.openxmlformats.org/drawingml/2006/main">
+            <a:r>
+              <a:t>- npm run test:e2e, 11 Aug 2026 — all 95 Playwright browser journeys passed</a:t>
             </a:r>
           </a:p>
           <a:p xmlns:a="http://schemas.openxmlformats.org/drawingml/2006/main">
@@ -869,12 +884,12 @@
           </a:p>
           <a:p xmlns:a="http://schemas.openxmlformats.org/drawingml/2006/main">
             <a:r>
-              <a:t>- 03_WebApp/Pre_Present/docs/03-user-experience.md — evidence-loop UX</a:t>
-            </a:r>
-          </a:p>
-          <a:p xmlns:a="http://schemas.openxmlformats.org/drawingml/2006/main">
-            <a:r>
-              <a:t>- 03_WebApp/Pre_Present/READMEEN.md — implemented comparison and plan</a:t>
+              <a:t>- 03_WebApp/docs/03-user-experience.md — evidence-loop UX</a:t>
+            </a:r>
+          </a:p>
+          <a:p xmlns:a="http://schemas.openxmlformats.org/drawingml/2006/main">
+            <a:r>
+              <a:t>- 03_WebApp/READMEEN.md — implemented comparison and plan</a:t>
             </a:r>
           </a:p>
           <a:p xmlns:a="http://schemas.openxmlformats.org/drawingml/2006/main">
@@ -959,12 +974,12 @@
           </a:p>
           <a:p xmlns:a="http://schemas.openxmlformats.org/drawingml/2006/main">
             <a:r>
-              <a:t>- 03_WebApp/Pre_Present/docs/validation-plan.md — validation sequence</a:t>
-            </a:r>
-          </a:p>
-          <a:p xmlns:a="http://schemas.openxmlformats.org/drawingml/2006/main">
-            <a:r>
-              <a:t>- 03_WebApp/Pre_Present/docs/pilot-protocol.md — proposed pilot gates</a:t>
+              <a:t>- 03_WebApp/docs/validation-plan.md — validation sequence</a:t>
+            </a:r>
+          </a:p>
+          <a:p xmlns:a="http://schemas.openxmlformats.org/drawingml/2006/main">
+            <a:r>
+              <a:t>- 03_WebApp/docs/pilot-protocol.md — proposed pilot gates</a:t>
             </a:r>
           </a:p>
           <a:p xmlns:a="http://schemas.openxmlformats.org/drawingml/2006/main">
@@ -1059,12 +1074,37 @@
           </a:p>
           <a:p xmlns:a="http://schemas.openxmlformats.org/drawingml/2006/main">
             <a:r>
-              <a:t>- 03_WebApp/Pre_Present/docs/07-roadmap.md — staged roadmap</a:t>
+              <a:t>- 03_WebApp/docs/07-roadmap.md — staged roadmap</a:t>
             </a:r>
           </a:p>
           <a:p xmlns:a="http://schemas.openxmlformats.org/drawingml/2006/main">
             <a:r>
               <a:t>- 01_Research/Data/REFERENCES.md — source registry</a:t>
+            </a:r>
+          </a:p>
+          <a:p xmlns:a="http://schemas.openxmlformats.org/drawingml/2006/main">
+            <a:r>
+              <a:t>- 03_WebApp/data/education-data-registry.json — current data coverage and source status</a:t>
+            </a:r>
+          </a:p>
+          <a:p xmlns:a="http://schemas.openxmlformats.org/drawingml/2006/main">
+            <a:r>
+              <a:t>- https://data.mhesi.go.th/dataset/dqe_11_01 — official programme dataset</a:t>
+            </a:r>
+          </a:p>
+          <a:p xmlns:a="http://schemas.openxmlformats.org/drawingml/2006/main">
+            <a:r>
+              <a:t>- https://ckan.vec.go.th/en/dataset/publicschool — official public vocational register</a:t>
+            </a:r>
+          </a:p>
+          <a:p xmlns:a="http://schemas.openxmlformats.org/drawingml/2006/main">
+            <a:r>
+              <a:t>- https://ckan.vec.go.th/en/dataset/privateschool — official private vocational register</a:t>
+            </a:r>
+          </a:p>
+          <a:p xmlns:a="http://schemas.openxmlformats.org/drawingml/2006/main">
+            <a:r>
+              <a:t>- https://www.mytcas.com/ — official TCAS70 portal; reference only</a:t>
             </a:r>
           </a:p>
           <a:p xmlns:a="http://schemas.openxmlformats.org/drawingml/2006/main">
@@ -1149,7 +1189,7 @@
           </a:p>
           <a:p xmlns:a="http://schemas.openxmlformats.org/drawingml/2006/main">
             <a:r>
-              <a:t>- 03_WebApp/Pre_Present/docs/02-research-and-evidence.md — Thai education and mismatch evidence</a:t>
+              <a:t>- 03_WebApp/docs/02-research-and-evidence.md — Thai education and mismatch evidence</a:t>
             </a:r>
           </a:p>
           <a:p xmlns:a="http://schemas.openxmlformats.org/drawingml/2006/main">
@@ -1344,7 +1384,12 @@
           </a:p>
           <a:p xmlns:a="http://schemas.openxmlformats.org/drawingml/2006/main">
             <a:r>
-              <a:t>- 03_WebApp/Pre_Present/scripts/validate-research-data.mjs — integrity checks</a:t>
+              <a:t>- 03_WebApp/scripts/validate-research-data.mjs — integrity checks</a:t>
+            </a:r>
+          </a:p>
+          <a:p xmlns:a="http://schemas.openxmlformats.org/drawingml/2006/main">
+            <a:r>
+              <a:t>- 03_WebApp/data/education-data-registry.json — coverage, status and decision-use boundary</a:t>
             </a:r>
           </a:p>
           <a:p xmlns:a="http://schemas.openxmlformats.org/drawingml/2006/main">
@@ -1429,12 +1474,12 @@
           </a:p>
           <a:p xmlns:a="http://schemas.openxmlformats.org/drawingml/2006/main">
             <a:r>
-              <a:t>- 03_WebApp/Pre_Present/docs/01-project-overview.md — product thesis</a:t>
-            </a:r>
-          </a:p>
-          <a:p xmlns:a="http://schemas.openxmlformats.org/drawingml/2006/main">
-            <a:r>
-              <a:t>- 03_WebApp/Pre_Present/docs/03-user-experience.md — evidence-loop design</a:t>
+              <a:t>- 03_WebApp/docs/01-project-overview.md — product thesis</a:t>
+            </a:r>
+          </a:p>
+          <a:p xmlns:a="http://schemas.openxmlformats.org/drawingml/2006/main">
+            <a:r>
+              <a:t>- 03_WebApp/docs/03-user-experience.md — evidence-loop design</a:t>
             </a:r>
           </a:p>
           <a:p xmlns:a="http://schemas.openxmlformats.org/drawingml/2006/main">
@@ -1519,7 +1564,7 @@
           </a:p>
           <a:p xmlns:a="http://schemas.openxmlformats.org/drawingml/2006/main">
             <a:r>
-              <a:t>- 03_WebApp/Pre_Present/docs/questionnaire-methodology.md — construct and item provenance</a:t>
+              <a:t>- 03_WebApp/docs/questionnaire-methodology.md — construct and item provenance</a:t>
             </a:r>
           </a:p>
           <a:p xmlns:a="http://schemas.openxmlformats.org/drawingml/2006/main">
@@ -1609,12 +1654,12 @@
           </a:p>
           <a:p xmlns:a="http://schemas.openxmlformats.org/drawingml/2006/main">
             <a:r>
-              <a:t>- 03_WebApp/Pre_Present/docs/08-privacy-and-data.md — privacy boundary</a:t>
-            </a:r>
-          </a:p>
-          <a:p xmlns:a="http://schemas.openxmlformats.org/drawingml/2006/main">
-            <a:r>
-              <a:t>- 03_WebApp/Pre_Present/docs/09-source-review.md — provenance and freshness</a:t>
+              <a:t>- 03_WebApp/docs/08-privacy-and-data.md — privacy boundary</a:t>
+            </a:r>
+          </a:p>
+          <a:p xmlns:a="http://schemas.openxmlformats.org/drawingml/2006/main">
+            <a:r>
+              <a:t>- 03_WebApp/docs/09-source-review.md — provenance and freshness</a:t>
             </a:r>
           </a:p>
           <a:p xmlns:a="http://schemas.openxmlformats.org/drawingml/2006/main">
@@ -1699,12 +1744,12 @@
           </a:p>
           <a:p xmlns:a="http://schemas.openxmlformats.org/drawingml/2006/main">
             <a:r>
-              <a:t>- 03_WebApp/Pre_Present/lib/adaptive-engine.ts — branch plan</a:t>
-            </a:r>
-          </a:p>
-          <a:p xmlns:a="http://schemas.openxmlformats.org/drawingml/2006/main">
-            <a:r>
-              <a:t>- 03_WebApp/Pre_Present/tests/unit/adaptive-engine.test.ts — deterministic branch tests</a:t>
+              <a:t>- 03_WebApp/lib/adaptive-engine.ts — branch plan</a:t>
+            </a:r>
+          </a:p>
+          <a:p xmlns:a="http://schemas.openxmlformats.org/drawingml/2006/main">
+            <a:r>
+              <a:t>- 03_WebApp/tests/unit/adaptive-engine.test.ts — deterministic branch tests</a:t>
             </a:r>
           </a:p>
           <a:p xmlns:a="http://schemas.openxmlformats.org/drawingml/2006/main">
@@ -1789,12 +1834,12 @@
           </a:p>
           <a:p xmlns:a="http://schemas.openxmlformats.org/drawingml/2006/main">
             <a:r>
-              <a:t>- 03_WebApp/Pre_Present/READMEEN.md — journey and control surfaces</a:t>
-            </a:r>
-          </a:p>
-          <a:p xmlns:a="http://schemas.openxmlformats.org/drawingml/2006/main">
-            <a:r>
-              <a:t>- 03_WebApp/Pre_Present/e2e/journey.spec.ts — implemented browser journey</a:t>
+              <a:t>- 03_WebApp/READMEEN.md — journey and control surfaces</a:t>
+            </a:r>
+          </a:p>
+          <a:p xmlns:a="http://schemas.openxmlformats.org/drawingml/2006/main">
+            <a:r>
+              <a:t>- 03_WebApp/e2e/journey.spec.ts — implemented browser journey</a:t>
             </a:r>
           </a:p>
           <a:p xmlns:a="http://schemas.openxmlformats.org/drawingml/2006/main">
@@ -4826,17 +4871,17 @@
   </p:cSld>
   <p:clrMap bg1="lt1" tx1="dk1" bg2="lt2" tx2="dk2" accent1="accent1" accent2="accent2" accent3="accent3" accent4="accent4" accent5="accent5" accent6="accent6" hlink="hlink" folHlink="folHlink"/>
   <p:sldLayoutIdLst>
-    <p:sldLayoutId xmlns:r="http://schemas.openxmlformats.org/officeDocument/2006/relationships" id="2147483649" r:id="R94bf5650d3074799"/>
-    <p:sldLayoutId xmlns:r="http://schemas.openxmlformats.org/officeDocument/2006/relationships" id="2147483650" r:id="Rec2c95d0933e4c3b"/>
-    <p:sldLayoutId xmlns:r="http://schemas.openxmlformats.org/officeDocument/2006/relationships" id="2147483651" r:id="Rc023e9f76a1d47c3"/>
-    <p:sldLayoutId xmlns:r="http://schemas.openxmlformats.org/officeDocument/2006/relationships" id="2147483652" r:id="Rbe16bf8eb50448e0"/>
-    <p:sldLayoutId xmlns:r="http://schemas.openxmlformats.org/officeDocument/2006/relationships" id="2147483653" r:id="R8ebfa86cf7bf456a"/>
-    <p:sldLayoutId xmlns:r="http://schemas.openxmlformats.org/officeDocument/2006/relationships" id="2147483654" r:id="R0b7458e33865422a"/>
-    <p:sldLayoutId xmlns:r="http://schemas.openxmlformats.org/officeDocument/2006/relationships" id="2147483655" r:id="Rb7154f35fe4b430c"/>
-    <p:sldLayoutId xmlns:r="http://schemas.openxmlformats.org/officeDocument/2006/relationships" id="2147483656" r:id="R78d1d581111e4993"/>
-    <p:sldLayoutId xmlns:r="http://schemas.openxmlformats.org/officeDocument/2006/relationships" id="2147483657" r:id="Ref0675b363fb40cc"/>
-    <p:sldLayoutId xmlns:r="http://schemas.openxmlformats.org/officeDocument/2006/relationships" id="2147483658" r:id="Rd246e52a31454014"/>
-    <p:sldLayoutId xmlns:r="http://schemas.openxmlformats.org/officeDocument/2006/relationships" id="2147483659" r:id="Rdbfe202c2ac54a08"/>
+    <p:sldLayoutId xmlns:r="http://schemas.openxmlformats.org/officeDocument/2006/relationships" id="2147483649" r:id="Rede2f437662f417d"/>
+    <p:sldLayoutId xmlns:r="http://schemas.openxmlformats.org/officeDocument/2006/relationships" id="2147483650" r:id="R496e7512c0274e03"/>
+    <p:sldLayoutId xmlns:r="http://schemas.openxmlformats.org/officeDocument/2006/relationships" id="2147483651" r:id="Rf855883def634e2c"/>
+    <p:sldLayoutId xmlns:r="http://schemas.openxmlformats.org/officeDocument/2006/relationships" id="2147483652" r:id="Re184e1d5b4a542b1"/>
+    <p:sldLayoutId xmlns:r="http://schemas.openxmlformats.org/officeDocument/2006/relationships" id="2147483653" r:id="R48fdf37dfe8943c8"/>
+    <p:sldLayoutId xmlns:r="http://schemas.openxmlformats.org/officeDocument/2006/relationships" id="2147483654" r:id="R48875c995d3c4d27"/>
+    <p:sldLayoutId xmlns:r="http://schemas.openxmlformats.org/officeDocument/2006/relationships" id="2147483655" r:id="R5f606265670c4c45"/>
+    <p:sldLayoutId xmlns:r="http://schemas.openxmlformats.org/officeDocument/2006/relationships" id="2147483656" r:id="Rd93ba9a09b6145eb"/>
+    <p:sldLayoutId xmlns:r="http://schemas.openxmlformats.org/officeDocument/2006/relationships" id="2147483657" r:id="Rb3f5b99376584f75"/>
+    <p:sldLayoutId xmlns:r="http://schemas.openxmlformats.org/officeDocument/2006/relationships" id="2147483658" r:id="R8a2ed28c6e7647d6"/>
+    <p:sldLayoutId xmlns:r="http://schemas.openxmlformats.org/officeDocument/2006/relationships" id="2147483659" r:id="R44ea5b50e9564afb"/>
   </p:sldLayoutIdLst>
   <p:txStyles>
     <p:titleStyle>
@@ -5386,7 +5431,7 @@
           <p:nvPr/>
         </p:nvPicPr>
         <p:blipFill>
-          <a:blip xmlns:r="http://schemas.openxmlformats.org/officeDocument/2006/relationships" xmlns:a="http://schemas.openxmlformats.org/drawingml/2006/main" r:embed="Ra0c3ee52b3834d73"/>
+          <a:blip xmlns:r="http://schemas.openxmlformats.org/officeDocument/2006/relationships" xmlns:a="http://schemas.openxmlformats.org/drawingml/2006/main" r:embed="R2159a86325e24e4e"/>
           <a:stretch xmlns:a="http://schemas.openxmlformats.org/drawingml/2006/main">
             <a:fillRect l="0" t="0" r="0" b="0"/>
           </a:stretch>
@@ -5452,7 +5497,7 @@
                 <a:ea typeface="Aptos"/>
                 <a:cs typeface="Aptos"/>
               </a:rPr>
-              <a:t>JUMP THAILAND HACKATHON 2026 · UPDATED PROJECT CASE STUDY</a:t>
+              <a:t>FUTUREME 0.2.0 · UPDATED PROJECT CASE STUDY</a:t>
             </a:r>
           </a:p>
         </p:txBody>
@@ -6744,7 +6789,7 @@
           <p:nvPr/>
         </p:nvPicPr>
         <p:blipFill>
-          <a:blip xmlns:r="http://schemas.openxmlformats.org/officeDocument/2006/relationships" xmlns:a="http://schemas.openxmlformats.org/drawingml/2006/main" r:embed="R55ed13ab81fa40b6"/>
+          <a:blip xmlns:r="http://schemas.openxmlformats.org/officeDocument/2006/relationships" xmlns:a="http://schemas.openxmlformats.org/drawingml/2006/main" r:embed="Rc5cd893d6f2b4fbf"/>
           <a:stretch xmlns:a="http://schemas.openxmlformats.org/drawingml/2006/main">
             <a:fillRect l="0" t="0" r="0" b="0"/>
           </a:stretch>
@@ -6992,7 +7037,7 @@
           <p:nvPr/>
         </p:nvPicPr>
         <p:blipFill>
-          <a:blip xmlns:r="http://schemas.openxmlformats.org/officeDocument/2006/relationships" xmlns:a="http://schemas.openxmlformats.org/drawingml/2006/main" r:embed="R2fe800335fc44cf2"/>
+          <a:blip xmlns:r="http://schemas.openxmlformats.org/officeDocument/2006/relationships" xmlns:a="http://schemas.openxmlformats.org/drawingml/2006/main" r:embed="Rbdea6614efcd4dd1"/>
           <a:stretch xmlns:a="http://schemas.openxmlformats.org/drawingml/2006/main">
             <a:fillRect l="0" t="0" r="0" b="0"/>
           </a:stretch>
@@ -7058,7 +7103,7 @@
                 <a:ea typeface="Aptos"/>
                 <a:cs typeface="Aptos"/>
               </a:rPr>
-              <a:t>FutureMe AI · Project case study · August 2026</a:t>
+              <a:t>FutureMe AI · Release 0.2.0 · August 2026</a:t>
             </a:r>
           </a:p>
         </p:txBody>
@@ -9163,7 +9208,7 @@
                 <a:ea typeface="Aptos"/>
                 <a:cs typeface="Aptos"/>
               </a:rPr>
-              <a:t>Sources: current code + research banks; production RAG and cloud services are not implemented</a:t>
+              <a:t>Sources: current code + release registry; Python backend and production RAG are not connected</a:t>
             </a:r>
           </a:p>
         </p:txBody>
@@ -9199,7 +9244,7 @@
           <p:nvPr/>
         </p:nvPicPr>
         <p:blipFill>
-          <a:blip xmlns:r="http://schemas.openxmlformats.org/officeDocument/2006/relationships" xmlns:a="http://schemas.openxmlformats.org/drawingml/2006/main" r:embed="Re778bba3671f4321"/>
+          <a:blip xmlns:r="http://schemas.openxmlformats.org/officeDocument/2006/relationships" xmlns:a="http://schemas.openxmlformats.org/drawingml/2006/main" r:embed="R97ae35dacb1c4622"/>
           <a:stretch xmlns:a="http://schemas.openxmlformats.org/drawingml/2006/main">
             <a:fillRect l="0" t="0" r="0" b="0"/>
           </a:stretch>
@@ -9447,7 +9492,7 @@
           <p:nvPr/>
         </p:nvPicPr>
         <p:blipFill>
-          <a:blip xmlns:r="http://schemas.openxmlformats.org/officeDocument/2006/relationships" xmlns:a="http://schemas.openxmlformats.org/drawingml/2006/main" r:embed="Rb2cb558f6ac348d3"/>
+          <a:blip xmlns:r="http://schemas.openxmlformats.org/officeDocument/2006/relationships" xmlns:a="http://schemas.openxmlformats.org/drawingml/2006/main" r:embed="R756b799059d9480d"/>
           <a:stretch xmlns:a="http://schemas.openxmlformats.org/drawingml/2006/main">
             <a:fillRect l="0" t="0" r="0" b="0"/>
           </a:stretch>
@@ -9513,7 +9558,7 @@
                 <a:ea typeface="Aptos"/>
                 <a:cs typeface="Aptos"/>
               </a:rPr>
-              <a:t>FutureMe AI · Project case study · August 2026</a:t>
+              <a:t>FutureMe AI · Release 0.2.0 · August 2026</a:t>
             </a:r>
           </a:p>
         </p:txBody>
@@ -11906,7 +11951,7 @@
           <p:nvPr/>
         </p:nvPicPr>
         <p:blipFill>
-          <a:blip xmlns:r="http://schemas.openxmlformats.org/officeDocument/2006/relationships" xmlns:a="http://schemas.openxmlformats.org/drawingml/2006/main" r:embed="R2dbbc139a1e64ae9"/>
+          <a:blip xmlns:r="http://schemas.openxmlformats.org/officeDocument/2006/relationships" xmlns:a="http://schemas.openxmlformats.org/drawingml/2006/main" r:embed="R2963257439994697"/>
           <a:stretch xmlns:a="http://schemas.openxmlformats.org/drawingml/2006/main">
             <a:fillRect l="0" t="0" r="0" b="0"/>
           </a:stretch>
@@ -12154,7 +12199,7 @@
           <p:nvPr/>
         </p:nvPicPr>
         <p:blipFill>
-          <a:blip xmlns:r="http://schemas.openxmlformats.org/officeDocument/2006/relationships" xmlns:a="http://schemas.openxmlformats.org/drawingml/2006/main" r:embed="Rebb65c8338444226"/>
+          <a:blip xmlns:r="http://schemas.openxmlformats.org/officeDocument/2006/relationships" xmlns:a="http://schemas.openxmlformats.org/drawingml/2006/main" r:embed="Rbba13e470d9d4d41"/>
           <a:stretch xmlns:a="http://schemas.openxmlformats.org/drawingml/2006/main">
             <a:fillRect l="0" t="0" r="0" b="0"/>
           </a:stretch>
@@ -12220,7 +12265,7 @@
                 <a:ea typeface="Aptos"/>
                 <a:cs typeface="Aptos"/>
               </a:rPr>
-              <a:t>FutureMe AI · Project case study · August 2026</a:t>
+              <a:t>FutureMe AI · Release 0.2.0 · August 2026</a:t>
             </a:r>
           </a:p>
         </p:txBody>
@@ -12289,7 +12334,7 @@
           <p:nvPr/>
         </p:nvPicPr>
         <p:blipFill>
-          <a:blip xmlns:r="http://schemas.openxmlformats.org/officeDocument/2006/relationships" xmlns:a="http://schemas.openxmlformats.org/drawingml/2006/main" r:embed="R0655af96176a4e1c"/>
+          <a:blip xmlns:r="http://schemas.openxmlformats.org/officeDocument/2006/relationships" xmlns:a="http://schemas.openxmlformats.org/drawingml/2006/main" r:embed="R898f3aefeb3d459f"/>
           <a:srcRect xmlns:a="http://schemas.openxmlformats.org/drawingml/2006/main" l="11145" t="0" r="11145" b="0"/>
           <a:stretch xmlns:a="http://schemas.openxmlformats.org/drawingml/2006/main">
             <a:fillRect l="0" t="0" r="0" b="0"/>
@@ -12536,7 +12581,7 @@
           <p:nvPr/>
         </p:nvPicPr>
         <p:blipFill>
-          <a:blip xmlns:r="http://schemas.openxmlformats.org/officeDocument/2006/relationships" xmlns:a="http://schemas.openxmlformats.org/drawingml/2006/main" r:embed="Rf7ac22d923e24cfd"/>
+          <a:blip xmlns:r="http://schemas.openxmlformats.org/officeDocument/2006/relationships" xmlns:a="http://schemas.openxmlformats.org/drawingml/2006/main" r:embed="R64ec4bc424614a1e"/>
           <a:srcRect xmlns:a="http://schemas.openxmlformats.org/drawingml/2006/main" l="0" t="0" r="0" b="29182"/>
           <a:stretch xmlns:a="http://schemas.openxmlformats.org/drawingml/2006/main">
             <a:fillRect l="0" t="0" r="0" b="0"/>
@@ -12783,7 +12828,7 @@
           <p:nvPr/>
         </p:nvPicPr>
         <p:blipFill>
-          <a:blip xmlns:r="http://schemas.openxmlformats.org/officeDocument/2006/relationships" xmlns:a="http://schemas.openxmlformats.org/drawingml/2006/main" r:embed="Rbccda1dc30364acc"/>
+          <a:blip xmlns:r="http://schemas.openxmlformats.org/officeDocument/2006/relationships" xmlns:a="http://schemas.openxmlformats.org/drawingml/2006/main" r:embed="R3a4a71f7de824c43"/>
           <a:srcRect xmlns:a="http://schemas.openxmlformats.org/drawingml/2006/main" l="0" t="0" r="0" b="36198"/>
           <a:stretch xmlns:a="http://schemas.openxmlformats.org/drawingml/2006/main">
             <a:fillRect l="0" t="0" r="0" b="0"/>
@@ -13516,7 +13561,7 @@
                 <a:ea typeface="Aptos"/>
                 <a:cs typeface="Aptos"/>
               </a:rPr>
-              <a:t>529 TESTS</a:t>
+              <a:t>533 TESTS</a:t>
             </a:r>
           </a:p>
         </p:txBody>
@@ -13627,7 +13672,7 @@
                 <a:ea typeface="Aptos"/>
                 <a:cs typeface="Aptos"/>
               </a:rPr>
-              <a:t>94 E2E</a:t>
+              <a:t>95 E2E</a:t>
             </a:r>
           </a:p>
         </p:txBody>
@@ -13739,7 +13784,7 @@
                 <a:ea typeface="Aptos"/>
                 <a:cs typeface="Aptos"/>
               </a:rPr>
-              <a:t>Verification rerun 11 Aug 2026: 529 Vitest tests and all 94 Playwright browser journeys passed.</a:t>
+              <a:t>Verification rerun 11 Aug 2026: 533 Vitest tests and all 95 Playwright browser journeys passed.</a:t>
             </a:r>
           </a:p>
         </p:txBody>
@@ -13775,7 +13820,7 @@
           <p:nvPr/>
         </p:nvPicPr>
         <p:blipFill>
-          <a:blip xmlns:r="http://schemas.openxmlformats.org/officeDocument/2006/relationships" xmlns:a="http://schemas.openxmlformats.org/drawingml/2006/main" r:embed="Re99cbcb5ef964fac"/>
+          <a:blip xmlns:r="http://schemas.openxmlformats.org/officeDocument/2006/relationships" xmlns:a="http://schemas.openxmlformats.org/drawingml/2006/main" r:embed="R5e25f872a97d4964"/>
           <a:stretch xmlns:a="http://schemas.openxmlformats.org/drawingml/2006/main">
             <a:fillRect l="0" t="0" r="0" b="0"/>
           </a:stretch>
@@ -14023,7 +14068,7 @@
           <p:nvPr/>
         </p:nvPicPr>
         <p:blipFill>
-          <a:blip xmlns:r="http://schemas.openxmlformats.org/officeDocument/2006/relationships" xmlns:a="http://schemas.openxmlformats.org/drawingml/2006/main" r:embed="Rf7359f731b8e4952"/>
+          <a:blip xmlns:r="http://schemas.openxmlformats.org/officeDocument/2006/relationships" xmlns:a="http://schemas.openxmlformats.org/drawingml/2006/main" r:embed="R3a537c7caf5945ca"/>
           <a:stretch xmlns:a="http://schemas.openxmlformats.org/drawingml/2006/main">
             <a:fillRect l="0" t="0" r="0" b="0"/>
           </a:stretch>
@@ -14089,7 +14134,7 @@
                 <a:ea typeface="Aptos"/>
                 <a:cs typeface="Aptos"/>
               </a:rPr>
-              <a:t>FutureMe AI · Project case study · August 2026</a:t>
+              <a:t>FutureMe AI · Release 0.2.0 · August 2026</a:t>
             </a:r>
           </a:p>
         </p:txBody>
@@ -17057,7 +17102,7 @@
           <p:nvPr/>
         </p:nvPicPr>
         <p:blipFill>
-          <a:blip xmlns:r="http://schemas.openxmlformats.org/officeDocument/2006/relationships" xmlns:a="http://schemas.openxmlformats.org/drawingml/2006/main" r:embed="Rf2a9eb0e30334672"/>
+          <a:blip xmlns:r="http://schemas.openxmlformats.org/officeDocument/2006/relationships" xmlns:a="http://schemas.openxmlformats.org/drawingml/2006/main" r:embed="R456d58d9eeb942cf"/>
           <a:stretch xmlns:a="http://schemas.openxmlformats.org/drawingml/2006/main">
             <a:fillRect l="0" t="0" r="0" b="0"/>
           </a:stretch>
@@ -17305,7 +17350,7 @@
           <p:nvPr/>
         </p:nvPicPr>
         <p:blipFill>
-          <a:blip xmlns:r="http://schemas.openxmlformats.org/officeDocument/2006/relationships" xmlns:a="http://schemas.openxmlformats.org/drawingml/2006/main" r:embed="Re04257d5809d4426"/>
+          <a:blip xmlns:r="http://schemas.openxmlformats.org/officeDocument/2006/relationships" xmlns:a="http://schemas.openxmlformats.org/drawingml/2006/main" r:embed="R0336f6acbfdb4e74"/>
           <a:stretch xmlns:a="http://schemas.openxmlformats.org/drawingml/2006/main">
             <a:fillRect l="0" t="0" r="0" b="0"/>
           </a:stretch>
@@ -17371,7 +17416,7 @@
                 <a:ea typeface="Aptos"/>
                 <a:cs typeface="Aptos"/>
               </a:rPr>
-              <a:t>FutureMe AI · Project case study · August 2026</a:t>
+              <a:t>FutureMe AI · Release 0.2.0 · August 2026</a:t>
             </a:r>
           </a:p>
         </p:txBody>
@@ -19947,7 +19992,7 @@
           <p:nvPr/>
         </p:nvPicPr>
         <p:blipFill>
-          <a:blip xmlns:r="http://schemas.openxmlformats.org/officeDocument/2006/relationships" xmlns:a="http://schemas.openxmlformats.org/drawingml/2006/main" r:embed="Rafcaea5393c64aff"/>
+          <a:blip xmlns:r="http://schemas.openxmlformats.org/officeDocument/2006/relationships" xmlns:a="http://schemas.openxmlformats.org/drawingml/2006/main" r:embed="Rde26da6585144561"/>
           <a:stretch xmlns:a="http://schemas.openxmlformats.org/drawingml/2006/main">
             <a:fillRect l="0" t="0" r="0" b="0"/>
           </a:stretch>
@@ -20195,7 +20240,7 @@
           <p:nvPr/>
         </p:nvPicPr>
         <p:blipFill>
-          <a:blip xmlns:r="http://schemas.openxmlformats.org/officeDocument/2006/relationships" xmlns:a="http://schemas.openxmlformats.org/drawingml/2006/main" r:embed="R3a86223977d84601"/>
+          <a:blip xmlns:r="http://schemas.openxmlformats.org/officeDocument/2006/relationships" xmlns:a="http://schemas.openxmlformats.org/drawingml/2006/main" r:embed="Ra085d482f0274594"/>
           <a:stretch xmlns:a="http://schemas.openxmlformats.org/drawingml/2006/main">
             <a:fillRect l="0" t="0" r="0" b="0"/>
           </a:stretch>
@@ -20261,7 +20306,7 @@
                 <a:ea typeface="Aptos"/>
                 <a:cs typeface="Aptos"/>
               </a:rPr>
-              <a:t>FutureMe AI · Project case study · August 2026</a:t>
+              <a:t>FutureMe AI · Release 0.2.0 · August 2026</a:t>
             </a:r>
           </a:p>
         </p:txBody>
@@ -21466,7 +21511,7 @@
                 <a:ea typeface="Aptos"/>
                 <a:cs typeface="Aptos"/>
               </a:rPr>
-              <a:t>Phase 3: Thai adaptation · expert and student review · instrument + mission pilot · licensed route data · bias + safety audit</a:t>
+              <a:t>Phase 3: expert + student review · questionnaire + mission pilot · licensed dynamic data · bias, privacy + safety audit</a:t>
             </a:r>
           </a:p>
         </p:txBody>
@@ -21959,7 +22004,7 @@
                 <a:ea typeface="Aptos"/>
                 <a:cs typeface="Aptos"/>
               </a:rPr>
-              <a:t>Repository evidence: README files · validation plan · source audit · geography provenance</a:t>
+              <a:t>Repository evidence: release registry · source audit · data coverage · validation plan</a:t>
             </a:r>
           </a:p>
         </p:txBody>
@@ -21995,7 +22040,7 @@
           <p:nvPr/>
         </p:nvPicPr>
         <p:blipFill>
-          <a:blip xmlns:r="http://schemas.openxmlformats.org/officeDocument/2006/relationships" xmlns:a="http://schemas.openxmlformats.org/drawingml/2006/main" r:embed="R95ff095bc2154875"/>
+          <a:blip xmlns:r="http://schemas.openxmlformats.org/officeDocument/2006/relationships" xmlns:a="http://schemas.openxmlformats.org/drawingml/2006/main" r:embed="Rfe96adb62628406a"/>
           <a:stretch xmlns:a="http://schemas.openxmlformats.org/drawingml/2006/main">
             <a:fillRect l="0" t="0" r="0" b="0"/>
           </a:stretch>
@@ -22243,7 +22288,7 @@
           <p:nvPr/>
         </p:nvPicPr>
         <p:blipFill>
-          <a:blip xmlns:r="http://schemas.openxmlformats.org/officeDocument/2006/relationships" xmlns:a="http://schemas.openxmlformats.org/drawingml/2006/main" r:embed="Rd6affd6591d748e6"/>
+          <a:blip xmlns:r="http://schemas.openxmlformats.org/officeDocument/2006/relationships" xmlns:a="http://schemas.openxmlformats.org/drawingml/2006/main" r:embed="R27a95bd3dcee4b1f"/>
           <a:stretch xmlns:a="http://schemas.openxmlformats.org/drawingml/2006/main">
             <a:fillRect l="0" t="0" r="0" b="0"/>
           </a:stretch>
@@ -22309,7 +22354,7 @@
                 <a:ea typeface="Aptos"/>
                 <a:cs typeface="Aptos"/>
               </a:rPr>
-              <a:t>FutureMe AI · Project case study · August 2026</a:t>
+              <a:t>FutureMe AI · Release 0.2.0 · August 2026</a:t>
             </a:r>
           </a:p>
         </p:txBody>
@@ -23996,7 +24041,7 @@
           <p:nvPr/>
         </p:nvPicPr>
         <p:blipFill>
-          <a:blip xmlns:r="http://schemas.openxmlformats.org/officeDocument/2006/relationships" xmlns:a="http://schemas.openxmlformats.org/drawingml/2006/main" r:embed="R70037ce6ade24c8a"/>
+          <a:blip xmlns:r="http://schemas.openxmlformats.org/officeDocument/2006/relationships" xmlns:a="http://schemas.openxmlformats.org/drawingml/2006/main" r:embed="R4d656fba090f42c8"/>
           <a:stretch xmlns:a="http://schemas.openxmlformats.org/drawingml/2006/main">
             <a:fillRect l="0" t="0" r="0" b="0"/>
           </a:stretch>
@@ -24244,7 +24289,7 @@
           <p:nvPr/>
         </p:nvPicPr>
         <p:blipFill>
-          <a:blip xmlns:r="http://schemas.openxmlformats.org/officeDocument/2006/relationships" xmlns:a="http://schemas.openxmlformats.org/drawingml/2006/main" r:embed="R0e197ca1a8ca436e"/>
+          <a:blip xmlns:r="http://schemas.openxmlformats.org/officeDocument/2006/relationships" xmlns:a="http://schemas.openxmlformats.org/drawingml/2006/main" r:embed="R79f6135f67e6443e"/>
           <a:stretch xmlns:a="http://schemas.openxmlformats.org/drawingml/2006/main">
             <a:fillRect l="0" t="0" r="0" b="0"/>
           </a:stretch>
@@ -24310,7 +24355,7 @@
                 <a:ea typeface="Aptos"/>
                 <a:cs typeface="Aptos"/>
               </a:rPr>
-              <a:t>FutureMe AI · Project case study · August 2026</a:t>
+              <a:t>FutureMe AI · Release 0.2.0 · August 2026</a:t>
             </a:r>
           </a:p>
         </p:txBody>
@@ -25405,7 +25450,7 @@
           <p:nvPr/>
         </p:nvPicPr>
         <p:blipFill>
-          <a:blip xmlns:r="http://schemas.openxmlformats.org/officeDocument/2006/relationships" xmlns:a="http://schemas.openxmlformats.org/drawingml/2006/main" r:embed="R0e44b6b0efde4738"/>
+          <a:blip xmlns:r="http://schemas.openxmlformats.org/officeDocument/2006/relationships" xmlns:a="http://schemas.openxmlformats.org/drawingml/2006/main" r:embed="Rab9eefa8f37f4fe3"/>
           <a:stretch xmlns:a="http://schemas.openxmlformats.org/drawingml/2006/main">
             <a:fillRect l="0" t="0" r="0" b="0"/>
           </a:stretch>
@@ -25653,7 +25698,7 @@
           <p:nvPr/>
         </p:nvPicPr>
         <p:blipFill>
-          <a:blip xmlns:r="http://schemas.openxmlformats.org/officeDocument/2006/relationships" xmlns:a="http://schemas.openxmlformats.org/drawingml/2006/main" r:embed="Rc2c92fd4024a47a0"/>
+          <a:blip xmlns:r="http://schemas.openxmlformats.org/officeDocument/2006/relationships" xmlns:a="http://schemas.openxmlformats.org/drawingml/2006/main" r:embed="Ra44780993c5d4702"/>
           <a:stretch xmlns:a="http://schemas.openxmlformats.org/drawingml/2006/main">
             <a:fillRect l="0" t="0" r="0" b="0"/>
           </a:stretch>
@@ -25719,7 +25764,7 @@
                 <a:ea typeface="Aptos"/>
                 <a:cs typeface="Aptos"/>
               </a:rPr>
-              <a:t>FutureMe AI · Project case study · August 2026</a:t>
+              <a:t>FutureMe AI · Release 0.2.0 · August 2026</a:t>
             </a:r>
           </a:p>
         </p:txBody>
@@ -27459,7 +27504,7 @@
                 <a:ea typeface="Aptos"/>
                 <a:cs typeface="Aptos"/>
               </a:rPr>
-              <a:t>1,961 institution options across 77 provinces; 207 coordinates and 987 websites remain explicitly unknown.</a:t>
+              <a:t>1,961 options / 1,375 institutions; 140 mapped. TCAS, fees, scholarships and living costs remain unavailable.</a:t>
             </a:r>
           </a:p>
         </p:txBody>
@@ -27515,7 +27560,7 @@
                 <a:ea typeface="Aptos"/>
                 <a:cs typeface="Aptos"/>
               </a:rPr>
-              <a:t>Sources: Geography PROVENANCE + check:data; integration review 11 Aug 2026</a:t>
+              <a:t>Sources: education-data-registry v0.2.0 + MHESI/OVEC; checked 11 Aug 2026</a:t>
             </a:r>
           </a:p>
         </p:txBody>
@@ -27551,7 +27596,7 @@
           <p:nvPr/>
         </p:nvPicPr>
         <p:blipFill>
-          <a:blip xmlns:r="http://schemas.openxmlformats.org/officeDocument/2006/relationships" xmlns:a="http://schemas.openxmlformats.org/drawingml/2006/main" r:embed="R0f29ee9d7fd44ae2"/>
+          <a:blip xmlns:r="http://schemas.openxmlformats.org/officeDocument/2006/relationships" xmlns:a="http://schemas.openxmlformats.org/drawingml/2006/main" r:embed="Rc69f8ffdf5ef4780"/>
           <a:stretch xmlns:a="http://schemas.openxmlformats.org/drawingml/2006/main">
             <a:fillRect l="0" t="0" r="0" b="0"/>
           </a:stretch>
@@ -27799,7 +27844,7 @@
           <p:nvPr/>
         </p:nvPicPr>
         <p:blipFill>
-          <a:blip xmlns:r="http://schemas.openxmlformats.org/officeDocument/2006/relationships" xmlns:a="http://schemas.openxmlformats.org/drawingml/2006/main" r:embed="R02a26cded7ac4c12"/>
+          <a:blip xmlns:r="http://schemas.openxmlformats.org/officeDocument/2006/relationships" xmlns:a="http://schemas.openxmlformats.org/drawingml/2006/main" r:embed="R3d3455f4f1f74b61"/>
           <a:stretch xmlns:a="http://schemas.openxmlformats.org/drawingml/2006/main">
             <a:fillRect l="0" t="0" r="0" b="0"/>
           </a:stretch>
@@ -27865,7 +27910,7 @@
                 <a:ea typeface="Aptos"/>
                 <a:cs typeface="Aptos"/>
               </a:rPr>
-              <a:t>FutureMe AI · Project case study · August 2026</a:t>
+              <a:t>FutureMe AI · Release 0.2.0 · August 2026</a:t>
             </a:r>
           </a:p>
         </p:txBody>
@@ -29477,7 +29522,7 @@
           <p:nvPr/>
         </p:nvPicPr>
         <p:blipFill>
-          <a:blip xmlns:r="http://schemas.openxmlformats.org/officeDocument/2006/relationships" xmlns:a="http://schemas.openxmlformats.org/drawingml/2006/main" r:embed="R44d21ec7e4724530"/>
+          <a:blip xmlns:r="http://schemas.openxmlformats.org/officeDocument/2006/relationships" xmlns:a="http://schemas.openxmlformats.org/drawingml/2006/main" r:embed="R42f202a08a824946"/>
           <a:stretch xmlns:a="http://schemas.openxmlformats.org/drawingml/2006/main">
             <a:fillRect l="0" t="0" r="0" b="0"/>
           </a:stretch>
@@ -29725,7 +29770,7 @@
           <p:nvPr/>
         </p:nvPicPr>
         <p:blipFill>
-          <a:blip xmlns:r="http://schemas.openxmlformats.org/officeDocument/2006/relationships" xmlns:a="http://schemas.openxmlformats.org/drawingml/2006/main" r:embed="R1ba025fc02684670"/>
+          <a:blip xmlns:r="http://schemas.openxmlformats.org/officeDocument/2006/relationships" xmlns:a="http://schemas.openxmlformats.org/drawingml/2006/main" r:embed="Rfb3e2a5132a34f68"/>
           <a:stretch xmlns:a="http://schemas.openxmlformats.org/drawingml/2006/main">
             <a:fillRect l="0" t="0" r="0" b="0"/>
           </a:stretch>
@@ -29791,7 +29836,7 @@
                 <a:ea typeface="Aptos"/>
                 <a:cs typeface="Aptos"/>
               </a:rPr>
-              <a:t>FutureMe AI · Project case study · August 2026</a:t>
+              <a:t>FutureMe AI · Release 0.2.0 · August 2026</a:t>
             </a:r>
           </a:p>
         </p:txBody>
@@ -32044,7 +32089,7 @@
           <p:nvPr/>
         </p:nvPicPr>
         <p:blipFill>
-          <a:blip xmlns:r="http://schemas.openxmlformats.org/officeDocument/2006/relationships" xmlns:a="http://schemas.openxmlformats.org/drawingml/2006/main" r:embed="R1305fed729d04c1f"/>
+          <a:blip xmlns:r="http://schemas.openxmlformats.org/officeDocument/2006/relationships" xmlns:a="http://schemas.openxmlformats.org/drawingml/2006/main" r:embed="R8bf7cac975d74094"/>
           <a:stretch xmlns:a="http://schemas.openxmlformats.org/drawingml/2006/main">
             <a:fillRect l="0" t="0" r="0" b="0"/>
           </a:stretch>
@@ -32292,7 +32337,7 @@
           <p:nvPr/>
         </p:nvPicPr>
         <p:blipFill>
-          <a:blip xmlns:r="http://schemas.openxmlformats.org/officeDocument/2006/relationships" xmlns:a="http://schemas.openxmlformats.org/drawingml/2006/main" r:embed="R5c2e5340f0e641bf"/>
+          <a:blip xmlns:r="http://schemas.openxmlformats.org/officeDocument/2006/relationships" xmlns:a="http://schemas.openxmlformats.org/drawingml/2006/main" r:embed="R8607380789184abf"/>
           <a:stretch xmlns:a="http://schemas.openxmlformats.org/drawingml/2006/main">
             <a:fillRect l="0" t="0" r="0" b="0"/>
           </a:stretch>
@@ -32358,7 +32403,7 @@
                 <a:ea typeface="Aptos"/>
                 <a:cs typeface="Aptos"/>
               </a:rPr>
-              <a:t>FutureMe AI · Project case study · August 2026</a:t>
+              <a:t>FutureMe AI · Release 0.2.0 · August 2026</a:t>
             </a:r>
           </a:p>
         </p:txBody>
@@ -33896,7 +33941,7 @@
           <p:nvPr/>
         </p:nvPicPr>
         <p:blipFill>
-          <a:blip xmlns:r="http://schemas.openxmlformats.org/officeDocument/2006/relationships" xmlns:a="http://schemas.openxmlformats.org/drawingml/2006/main" r:embed="R82b9b79fd1104694"/>
+          <a:blip xmlns:r="http://schemas.openxmlformats.org/officeDocument/2006/relationships" xmlns:a="http://schemas.openxmlformats.org/drawingml/2006/main" r:embed="Rb6c3d7cfed114a1c"/>
           <a:stretch xmlns:a="http://schemas.openxmlformats.org/drawingml/2006/main">
             <a:fillRect l="0" t="0" r="0" b="0"/>
           </a:stretch>
@@ -34144,7 +34189,7 @@
           <p:nvPr/>
         </p:nvPicPr>
         <p:blipFill>
-          <a:blip xmlns:r="http://schemas.openxmlformats.org/officeDocument/2006/relationships" xmlns:a="http://schemas.openxmlformats.org/drawingml/2006/main" r:embed="Rbcc86cf6082a4c31"/>
+          <a:blip xmlns:r="http://schemas.openxmlformats.org/officeDocument/2006/relationships" xmlns:a="http://schemas.openxmlformats.org/drawingml/2006/main" r:embed="R31e44e94921944a6"/>
           <a:stretch xmlns:a="http://schemas.openxmlformats.org/drawingml/2006/main">
             <a:fillRect l="0" t="0" r="0" b="0"/>
           </a:stretch>
@@ -34210,7 +34255,7 @@
                 <a:ea typeface="Aptos"/>
                 <a:cs typeface="Aptos"/>
               </a:rPr>
-              <a:t>FutureMe AI · Project case study · August 2026</a:t>
+              <a:t>FutureMe AI · Release 0.2.0 · August 2026</a:t>
             </a:r>
           </a:p>
         </p:txBody>
@@ -35827,7 +35872,7 @@
           <p:nvPr/>
         </p:nvPicPr>
         <p:blipFill>
-          <a:blip xmlns:r="http://schemas.openxmlformats.org/officeDocument/2006/relationships" xmlns:a="http://schemas.openxmlformats.org/drawingml/2006/main" r:embed="Ra2dcce338e7140d8"/>
+          <a:blip xmlns:r="http://schemas.openxmlformats.org/officeDocument/2006/relationships" xmlns:a="http://schemas.openxmlformats.org/drawingml/2006/main" r:embed="R16014cd9d93c4c9a"/>
           <a:stretch xmlns:a="http://schemas.openxmlformats.org/drawingml/2006/main">
             <a:fillRect l="0" t="0" r="0" b="0"/>
           </a:stretch>
@@ -36075,7 +36120,7 @@
           <p:nvPr/>
         </p:nvPicPr>
         <p:blipFill>
-          <a:blip xmlns:r="http://schemas.openxmlformats.org/officeDocument/2006/relationships" xmlns:a="http://schemas.openxmlformats.org/drawingml/2006/main" r:embed="R5204435e7950447a"/>
+          <a:blip xmlns:r="http://schemas.openxmlformats.org/officeDocument/2006/relationships" xmlns:a="http://schemas.openxmlformats.org/drawingml/2006/main" r:embed="Rdb44bd1cffd94b89"/>
           <a:stretch xmlns:a="http://schemas.openxmlformats.org/drawingml/2006/main">
             <a:fillRect l="0" t="0" r="0" b="0"/>
           </a:stretch>
@@ -36141,7 +36186,7 @@
                 <a:ea typeface="Aptos"/>
                 <a:cs typeface="Aptos"/>
               </a:rPr>
-              <a:t>FutureMe AI · Project case study · August 2026</a:t>
+              <a:t>FutureMe AI · Release 0.2.0 · August 2026</a:t>
             </a:r>
           </a:p>
         </p:txBody>

</xml_diff>

<commit_message>
docs: remove product version labels
</commit_message>
<xml_diff>
--- a/Presentation/FutureMe_Project_Presentation.pptx
+++ b/Presentation/FutureMe_Project_Presentation.pptx
@@ -2,27 +2,27 @@
 <file path=ppt/presentation.xml><?xml version="1.0" encoding="utf-8"?>
 <p:presentation xmlns:p="http://schemas.openxmlformats.org/presentationml/2006/main">
   <p:sldMasterIdLst>
-    <p:sldMasterId xmlns:r="http://schemas.openxmlformats.org/officeDocument/2006/relationships" id="2147483648" r:id="R2beda2e2d67540e6"/>
+    <p:sldMasterId xmlns:r="http://schemas.openxmlformats.org/officeDocument/2006/relationships" id="2147483648" r:id="R165cfdd6ed8745cd"/>
   </p:sldMasterIdLst>
   <p:notesMasterIdLst>
-    <p:notesMasterId xmlns:r="http://schemas.openxmlformats.org/officeDocument/2006/relationships" r:id="R97b91ab850f54e9c"/>
+    <p:notesMasterId xmlns:r="http://schemas.openxmlformats.org/officeDocument/2006/relationships" r:id="R65836f45d7164461"/>
   </p:notesMasterIdLst>
   <p:sldIdLst>
-    <p:sldId xmlns:r="http://schemas.openxmlformats.org/officeDocument/2006/relationships" id="256" r:id="Red065a5b95ea45b9"/>
-    <p:sldId xmlns:r="http://schemas.openxmlformats.org/officeDocument/2006/relationships" id="257" r:id="R63c67e71e44741bf"/>
-    <p:sldId xmlns:r="http://schemas.openxmlformats.org/officeDocument/2006/relationships" id="258" r:id="Rab6097b44e604512"/>
-    <p:sldId xmlns:r="http://schemas.openxmlformats.org/officeDocument/2006/relationships" id="259" r:id="R8f998eeb127b40d8"/>
-    <p:sldId xmlns:r="http://schemas.openxmlformats.org/officeDocument/2006/relationships" id="260" r:id="R49b2a7dfb7a646c2"/>
-    <p:sldId xmlns:r="http://schemas.openxmlformats.org/officeDocument/2006/relationships" id="261" r:id="R24f1eae5cd034441"/>
-    <p:sldId xmlns:r="http://schemas.openxmlformats.org/officeDocument/2006/relationships" id="262" r:id="Re9745b70a6464470"/>
-    <p:sldId xmlns:r="http://schemas.openxmlformats.org/officeDocument/2006/relationships" id="263" r:id="Rdf3287bd36984e60"/>
-    <p:sldId xmlns:r="http://schemas.openxmlformats.org/officeDocument/2006/relationships" id="264" r:id="R90e689b1fca2431f"/>
-    <p:sldId xmlns:r="http://schemas.openxmlformats.org/officeDocument/2006/relationships" id="265" r:id="R31faee0125894f7e"/>
-    <p:sldId xmlns:r="http://schemas.openxmlformats.org/officeDocument/2006/relationships" id="266" r:id="Rf9a8023a2f4f4dfd"/>
-    <p:sldId xmlns:r="http://schemas.openxmlformats.org/officeDocument/2006/relationships" id="267" r:id="R034c5a52de9845ff"/>
-    <p:sldId xmlns:r="http://schemas.openxmlformats.org/officeDocument/2006/relationships" id="268" r:id="Rbeecd9691de74aa5"/>
-    <p:sldId xmlns:r="http://schemas.openxmlformats.org/officeDocument/2006/relationships" id="269" r:id="Rfbe15e4c6e9d4ece"/>
-    <p:sldId xmlns:r="http://schemas.openxmlformats.org/officeDocument/2006/relationships" id="270" r:id="R1271a98057424998"/>
+    <p:sldId xmlns:r="http://schemas.openxmlformats.org/officeDocument/2006/relationships" id="256" r:id="R5d4d5814f7154119"/>
+    <p:sldId xmlns:r="http://schemas.openxmlformats.org/officeDocument/2006/relationships" id="257" r:id="R62187de224854672"/>
+    <p:sldId xmlns:r="http://schemas.openxmlformats.org/officeDocument/2006/relationships" id="258" r:id="Ra1711321199b42f6"/>
+    <p:sldId xmlns:r="http://schemas.openxmlformats.org/officeDocument/2006/relationships" id="259" r:id="Rf02dbf282d934e60"/>
+    <p:sldId xmlns:r="http://schemas.openxmlformats.org/officeDocument/2006/relationships" id="260" r:id="R2014d6b1cc044886"/>
+    <p:sldId xmlns:r="http://schemas.openxmlformats.org/officeDocument/2006/relationships" id="261" r:id="Ra5537d45ad5e4413"/>
+    <p:sldId xmlns:r="http://schemas.openxmlformats.org/officeDocument/2006/relationships" id="262" r:id="R603ff563b02b45fe"/>
+    <p:sldId xmlns:r="http://schemas.openxmlformats.org/officeDocument/2006/relationships" id="263" r:id="R0b16055e5ed840c3"/>
+    <p:sldId xmlns:r="http://schemas.openxmlformats.org/officeDocument/2006/relationships" id="264" r:id="Rd4e7a94fd2ff49f3"/>
+    <p:sldId xmlns:r="http://schemas.openxmlformats.org/officeDocument/2006/relationships" id="265" r:id="Ra4dd250ff6a94df6"/>
+    <p:sldId xmlns:r="http://schemas.openxmlformats.org/officeDocument/2006/relationships" id="266" r:id="Rc0aa83c24aac47bd"/>
+    <p:sldId xmlns:r="http://schemas.openxmlformats.org/officeDocument/2006/relationships" id="267" r:id="R0b29700508a54860"/>
+    <p:sldId xmlns:r="http://schemas.openxmlformats.org/officeDocument/2006/relationships" id="268" r:id="Rd3840cd35c8744d0"/>
+    <p:sldId xmlns:r="http://schemas.openxmlformats.org/officeDocument/2006/relationships" id="269" r:id="R611033bfb0ff4e0e"/>
+    <p:sldId xmlns:r="http://schemas.openxmlformats.org/officeDocument/2006/relationships" id="270" r:id="R41597c89de1147bb"/>
   </p:sldIdLst>
   <p:sldSz cx="12191695" cy="6858000"/>
   <p:notesSz cx="6858000" cy="9144000"/>
@@ -599,11 +599,6 @@
           </a:p>
           <a:p xmlns:a="http://schemas.openxmlformats.org/drawingml/2006/main">
             <a:r>
-              <a:t>- 03_WebApp/data/release.json — component versions and implementation status</a:t>
-            </a:r>
-          </a:p>
-          <a:p xmlns:a="http://schemas.openxmlformats.org/drawingml/2006/main">
-            <a:r>
               <a:t>- 03_WebApp/data/education-data-registry.json — held-out decision fields</a:t>
             </a:r>
           </a:p>
@@ -4871,17 +4866,17 @@
   </p:cSld>
   <p:clrMap bg1="lt1" tx1="dk1" bg2="lt2" tx2="dk2" accent1="accent1" accent2="accent2" accent3="accent3" accent4="accent4" accent5="accent5" accent6="accent6" hlink="hlink" folHlink="folHlink"/>
   <p:sldLayoutIdLst>
-    <p:sldLayoutId xmlns:r="http://schemas.openxmlformats.org/officeDocument/2006/relationships" id="2147483649" r:id="Rede2f437662f417d"/>
-    <p:sldLayoutId xmlns:r="http://schemas.openxmlformats.org/officeDocument/2006/relationships" id="2147483650" r:id="R496e7512c0274e03"/>
-    <p:sldLayoutId xmlns:r="http://schemas.openxmlformats.org/officeDocument/2006/relationships" id="2147483651" r:id="Rf855883def634e2c"/>
-    <p:sldLayoutId xmlns:r="http://schemas.openxmlformats.org/officeDocument/2006/relationships" id="2147483652" r:id="Re184e1d5b4a542b1"/>
-    <p:sldLayoutId xmlns:r="http://schemas.openxmlformats.org/officeDocument/2006/relationships" id="2147483653" r:id="R48fdf37dfe8943c8"/>
-    <p:sldLayoutId xmlns:r="http://schemas.openxmlformats.org/officeDocument/2006/relationships" id="2147483654" r:id="R48875c995d3c4d27"/>
-    <p:sldLayoutId xmlns:r="http://schemas.openxmlformats.org/officeDocument/2006/relationships" id="2147483655" r:id="R5f606265670c4c45"/>
-    <p:sldLayoutId xmlns:r="http://schemas.openxmlformats.org/officeDocument/2006/relationships" id="2147483656" r:id="Rd93ba9a09b6145eb"/>
-    <p:sldLayoutId xmlns:r="http://schemas.openxmlformats.org/officeDocument/2006/relationships" id="2147483657" r:id="Rb3f5b99376584f75"/>
-    <p:sldLayoutId xmlns:r="http://schemas.openxmlformats.org/officeDocument/2006/relationships" id="2147483658" r:id="R8a2ed28c6e7647d6"/>
-    <p:sldLayoutId xmlns:r="http://schemas.openxmlformats.org/officeDocument/2006/relationships" id="2147483659" r:id="R44ea5b50e9564afb"/>
+    <p:sldLayoutId xmlns:r="http://schemas.openxmlformats.org/officeDocument/2006/relationships" id="2147483649" r:id="R3a1752ec44d2498b"/>
+    <p:sldLayoutId xmlns:r="http://schemas.openxmlformats.org/officeDocument/2006/relationships" id="2147483650" r:id="R429f34ba017f4f12"/>
+    <p:sldLayoutId xmlns:r="http://schemas.openxmlformats.org/officeDocument/2006/relationships" id="2147483651" r:id="Rfd10f4e241154a56"/>
+    <p:sldLayoutId xmlns:r="http://schemas.openxmlformats.org/officeDocument/2006/relationships" id="2147483652" r:id="Ref2a31aa5e1d4fe0"/>
+    <p:sldLayoutId xmlns:r="http://schemas.openxmlformats.org/officeDocument/2006/relationships" id="2147483653" r:id="Re5606ada741e4a8a"/>
+    <p:sldLayoutId xmlns:r="http://schemas.openxmlformats.org/officeDocument/2006/relationships" id="2147483654" r:id="R5f7ab2a6d1c94aac"/>
+    <p:sldLayoutId xmlns:r="http://schemas.openxmlformats.org/officeDocument/2006/relationships" id="2147483655" r:id="Rd238413949614d4d"/>
+    <p:sldLayoutId xmlns:r="http://schemas.openxmlformats.org/officeDocument/2006/relationships" id="2147483656" r:id="R39a605d748684930"/>
+    <p:sldLayoutId xmlns:r="http://schemas.openxmlformats.org/officeDocument/2006/relationships" id="2147483657" r:id="R84555e7866d74d76"/>
+    <p:sldLayoutId xmlns:r="http://schemas.openxmlformats.org/officeDocument/2006/relationships" id="2147483658" r:id="R8398a5c37c1c4452"/>
+    <p:sldLayoutId xmlns:r="http://schemas.openxmlformats.org/officeDocument/2006/relationships" id="2147483659" r:id="R5fb7c26c43f947d5"/>
   </p:sldLayoutIdLst>
   <p:txStyles>
     <p:titleStyle>
@@ -5431,7 +5426,7 @@
           <p:nvPr/>
         </p:nvPicPr>
         <p:blipFill>
-          <a:blip xmlns:r="http://schemas.openxmlformats.org/officeDocument/2006/relationships" xmlns:a="http://schemas.openxmlformats.org/drawingml/2006/main" r:embed="R2159a86325e24e4e"/>
+          <a:blip xmlns:r="http://schemas.openxmlformats.org/officeDocument/2006/relationships" xmlns:a="http://schemas.openxmlformats.org/drawingml/2006/main" r:embed="R3e94a03e721a4965"/>
           <a:stretch xmlns:a="http://schemas.openxmlformats.org/drawingml/2006/main">
             <a:fillRect l="0" t="0" r="0" b="0"/>
           </a:stretch>
@@ -5497,7 +5492,7 @@
                 <a:ea typeface="Aptos"/>
                 <a:cs typeface="Aptos"/>
               </a:rPr>
-              <a:t>FUTUREME 0.2.0 · UPDATED PROJECT CASE STUDY</a:t>
+              <a:t>FUTUREME · UPDATED PROJECT CASE STUDY</a:t>
             </a:r>
           </a:p>
         </p:txBody>
@@ -6789,7 +6784,7 @@
           <p:nvPr/>
         </p:nvPicPr>
         <p:blipFill>
-          <a:blip xmlns:r="http://schemas.openxmlformats.org/officeDocument/2006/relationships" xmlns:a="http://schemas.openxmlformats.org/drawingml/2006/main" r:embed="Rc5cd893d6f2b4fbf"/>
+          <a:blip xmlns:r="http://schemas.openxmlformats.org/officeDocument/2006/relationships" xmlns:a="http://schemas.openxmlformats.org/drawingml/2006/main" r:embed="Rbd45abd65d1a444d"/>
           <a:stretch xmlns:a="http://schemas.openxmlformats.org/drawingml/2006/main">
             <a:fillRect l="0" t="0" r="0" b="0"/>
           </a:stretch>
@@ -7037,7 +7032,7 @@
           <p:nvPr/>
         </p:nvPicPr>
         <p:blipFill>
-          <a:blip xmlns:r="http://schemas.openxmlformats.org/officeDocument/2006/relationships" xmlns:a="http://schemas.openxmlformats.org/drawingml/2006/main" r:embed="Rbdea6614efcd4dd1"/>
+          <a:blip xmlns:r="http://schemas.openxmlformats.org/officeDocument/2006/relationships" xmlns:a="http://schemas.openxmlformats.org/drawingml/2006/main" r:embed="Rbfd20313d6514018"/>
           <a:stretch xmlns:a="http://schemas.openxmlformats.org/drawingml/2006/main">
             <a:fillRect l="0" t="0" r="0" b="0"/>
           </a:stretch>
@@ -7103,7 +7098,7 @@
                 <a:ea typeface="Aptos"/>
                 <a:cs typeface="Aptos"/>
               </a:rPr>
-              <a:t>FutureMe AI · Release 0.2.0 · August 2026</a:t>
+              <a:t>FutureMe AI · August 2026</a:t>
             </a:r>
           </a:p>
         </p:txBody>
@@ -9208,7 +9203,7 @@
                 <a:ea typeface="Aptos"/>
                 <a:cs typeface="Aptos"/>
               </a:rPr>
-              <a:t>Sources: current code + release registry; Python backend and production RAG are not connected</a:t>
+              <a:t>Sources: current code + education-data registry; Python backend and production RAG are not connected</a:t>
             </a:r>
           </a:p>
         </p:txBody>
@@ -9244,7 +9239,7 @@
           <p:nvPr/>
         </p:nvPicPr>
         <p:blipFill>
-          <a:blip xmlns:r="http://schemas.openxmlformats.org/officeDocument/2006/relationships" xmlns:a="http://schemas.openxmlformats.org/drawingml/2006/main" r:embed="R97ae35dacb1c4622"/>
+          <a:blip xmlns:r="http://schemas.openxmlformats.org/officeDocument/2006/relationships" xmlns:a="http://schemas.openxmlformats.org/drawingml/2006/main" r:embed="Rb3b93fcceb8a41e7"/>
           <a:stretch xmlns:a="http://schemas.openxmlformats.org/drawingml/2006/main">
             <a:fillRect l="0" t="0" r="0" b="0"/>
           </a:stretch>
@@ -9492,7 +9487,7 @@
           <p:nvPr/>
         </p:nvPicPr>
         <p:blipFill>
-          <a:blip xmlns:r="http://schemas.openxmlformats.org/officeDocument/2006/relationships" xmlns:a="http://schemas.openxmlformats.org/drawingml/2006/main" r:embed="R756b799059d9480d"/>
+          <a:blip xmlns:r="http://schemas.openxmlformats.org/officeDocument/2006/relationships" xmlns:a="http://schemas.openxmlformats.org/drawingml/2006/main" r:embed="Rbba585aec77b45ed"/>
           <a:stretch xmlns:a="http://schemas.openxmlformats.org/drawingml/2006/main">
             <a:fillRect l="0" t="0" r="0" b="0"/>
           </a:stretch>
@@ -9558,7 +9553,7 @@
                 <a:ea typeface="Aptos"/>
                 <a:cs typeface="Aptos"/>
               </a:rPr>
-              <a:t>FutureMe AI · Release 0.2.0 · August 2026</a:t>
+              <a:t>FutureMe AI · August 2026</a:t>
             </a:r>
           </a:p>
         </p:txBody>
@@ -11951,7 +11946,7 @@
           <p:nvPr/>
         </p:nvPicPr>
         <p:blipFill>
-          <a:blip xmlns:r="http://schemas.openxmlformats.org/officeDocument/2006/relationships" xmlns:a="http://schemas.openxmlformats.org/drawingml/2006/main" r:embed="R2963257439994697"/>
+          <a:blip xmlns:r="http://schemas.openxmlformats.org/officeDocument/2006/relationships" xmlns:a="http://schemas.openxmlformats.org/drawingml/2006/main" r:embed="Rf007178f49754c71"/>
           <a:stretch xmlns:a="http://schemas.openxmlformats.org/drawingml/2006/main">
             <a:fillRect l="0" t="0" r="0" b="0"/>
           </a:stretch>
@@ -12199,7 +12194,7 @@
           <p:nvPr/>
         </p:nvPicPr>
         <p:blipFill>
-          <a:blip xmlns:r="http://schemas.openxmlformats.org/officeDocument/2006/relationships" xmlns:a="http://schemas.openxmlformats.org/drawingml/2006/main" r:embed="Rbba13e470d9d4d41"/>
+          <a:blip xmlns:r="http://schemas.openxmlformats.org/officeDocument/2006/relationships" xmlns:a="http://schemas.openxmlformats.org/drawingml/2006/main" r:embed="R5c8b136a02f842ee"/>
           <a:stretch xmlns:a="http://schemas.openxmlformats.org/drawingml/2006/main">
             <a:fillRect l="0" t="0" r="0" b="0"/>
           </a:stretch>
@@ -12265,7 +12260,7 @@
                 <a:ea typeface="Aptos"/>
                 <a:cs typeface="Aptos"/>
               </a:rPr>
-              <a:t>FutureMe AI · Release 0.2.0 · August 2026</a:t>
+              <a:t>FutureMe AI · August 2026</a:t>
             </a:r>
           </a:p>
         </p:txBody>
@@ -12334,7 +12329,7 @@
           <p:nvPr/>
         </p:nvPicPr>
         <p:blipFill>
-          <a:blip xmlns:r="http://schemas.openxmlformats.org/officeDocument/2006/relationships" xmlns:a="http://schemas.openxmlformats.org/drawingml/2006/main" r:embed="R898f3aefeb3d459f"/>
+          <a:blip xmlns:r="http://schemas.openxmlformats.org/officeDocument/2006/relationships" xmlns:a="http://schemas.openxmlformats.org/drawingml/2006/main" r:embed="R778ebd56550441a8"/>
           <a:srcRect xmlns:a="http://schemas.openxmlformats.org/drawingml/2006/main" l="11145" t="0" r="11145" b="0"/>
           <a:stretch xmlns:a="http://schemas.openxmlformats.org/drawingml/2006/main">
             <a:fillRect l="0" t="0" r="0" b="0"/>
@@ -12581,7 +12576,7 @@
           <p:nvPr/>
         </p:nvPicPr>
         <p:blipFill>
-          <a:blip xmlns:r="http://schemas.openxmlformats.org/officeDocument/2006/relationships" xmlns:a="http://schemas.openxmlformats.org/drawingml/2006/main" r:embed="R64ec4bc424614a1e"/>
+          <a:blip xmlns:r="http://schemas.openxmlformats.org/officeDocument/2006/relationships" xmlns:a="http://schemas.openxmlformats.org/drawingml/2006/main" r:embed="R4c3c63ce8ec242b2"/>
           <a:srcRect xmlns:a="http://schemas.openxmlformats.org/drawingml/2006/main" l="0" t="0" r="0" b="29182"/>
           <a:stretch xmlns:a="http://schemas.openxmlformats.org/drawingml/2006/main">
             <a:fillRect l="0" t="0" r="0" b="0"/>
@@ -12828,7 +12823,7 @@
           <p:nvPr/>
         </p:nvPicPr>
         <p:blipFill>
-          <a:blip xmlns:r="http://schemas.openxmlformats.org/officeDocument/2006/relationships" xmlns:a="http://schemas.openxmlformats.org/drawingml/2006/main" r:embed="R3a4a71f7de824c43"/>
+          <a:blip xmlns:r="http://schemas.openxmlformats.org/officeDocument/2006/relationships" xmlns:a="http://schemas.openxmlformats.org/drawingml/2006/main" r:embed="R174aee8cd8e8460d"/>
           <a:srcRect xmlns:a="http://schemas.openxmlformats.org/drawingml/2006/main" l="0" t="0" r="0" b="36198"/>
           <a:stretch xmlns:a="http://schemas.openxmlformats.org/drawingml/2006/main">
             <a:fillRect l="0" t="0" r="0" b="0"/>
@@ -13820,7 +13815,7 @@
           <p:nvPr/>
         </p:nvPicPr>
         <p:blipFill>
-          <a:blip xmlns:r="http://schemas.openxmlformats.org/officeDocument/2006/relationships" xmlns:a="http://schemas.openxmlformats.org/drawingml/2006/main" r:embed="R5e25f872a97d4964"/>
+          <a:blip xmlns:r="http://schemas.openxmlformats.org/officeDocument/2006/relationships" xmlns:a="http://schemas.openxmlformats.org/drawingml/2006/main" r:embed="R0e4222e8bf75402e"/>
           <a:stretch xmlns:a="http://schemas.openxmlformats.org/drawingml/2006/main">
             <a:fillRect l="0" t="0" r="0" b="0"/>
           </a:stretch>
@@ -14068,7 +14063,7 @@
           <p:nvPr/>
         </p:nvPicPr>
         <p:blipFill>
-          <a:blip xmlns:r="http://schemas.openxmlformats.org/officeDocument/2006/relationships" xmlns:a="http://schemas.openxmlformats.org/drawingml/2006/main" r:embed="R3a537c7caf5945ca"/>
+          <a:blip xmlns:r="http://schemas.openxmlformats.org/officeDocument/2006/relationships" xmlns:a="http://schemas.openxmlformats.org/drawingml/2006/main" r:embed="R824ac60f794e4df3"/>
           <a:stretch xmlns:a="http://schemas.openxmlformats.org/drawingml/2006/main">
             <a:fillRect l="0" t="0" r="0" b="0"/>
           </a:stretch>
@@ -14134,7 +14129,7 @@
                 <a:ea typeface="Aptos"/>
                 <a:cs typeface="Aptos"/>
               </a:rPr>
-              <a:t>FutureMe AI · Release 0.2.0 · August 2026</a:t>
+              <a:t>FutureMe AI · August 2026</a:t>
             </a:r>
           </a:p>
         </p:txBody>
@@ -17102,7 +17097,7 @@
           <p:nvPr/>
         </p:nvPicPr>
         <p:blipFill>
-          <a:blip xmlns:r="http://schemas.openxmlformats.org/officeDocument/2006/relationships" xmlns:a="http://schemas.openxmlformats.org/drawingml/2006/main" r:embed="R456d58d9eeb942cf"/>
+          <a:blip xmlns:r="http://schemas.openxmlformats.org/officeDocument/2006/relationships" xmlns:a="http://schemas.openxmlformats.org/drawingml/2006/main" r:embed="Re4c55808318e439b"/>
           <a:stretch xmlns:a="http://schemas.openxmlformats.org/drawingml/2006/main">
             <a:fillRect l="0" t="0" r="0" b="0"/>
           </a:stretch>
@@ -17350,7 +17345,7 @@
           <p:nvPr/>
         </p:nvPicPr>
         <p:blipFill>
-          <a:blip xmlns:r="http://schemas.openxmlformats.org/officeDocument/2006/relationships" xmlns:a="http://schemas.openxmlformats.org/drawingml/2006/main" r:embed="R0336f6acbfdb4e74"/>
+          <a:blip xmlns:r="http://schemas.openxmlformats.org/officeDocument/2006/relationships" xmlns:a="http://schemas.openxmlformats.org/drawingml/2006/main" r:embed="R1df9b0bc342c4823"/>
           <a:stretch xmlns:a="http://schemas.openxmlformats.org/drawingml/2006/main">
             <a:fillRect l="0" t="0" r="0" b="0"/>
           </a:stretch>
@@ -17416,7 +17411,7 @@
                 <a:ea typeface="Aptos"/>
                 <a:cs typeface="Aptos"/>
               </a:rPr>
-              <a:t>FutureMe AI · Release 0.2.0 · August 2026</a:t>
+              <a:t>FutureMe AI · August 2026</a:t>
             </a:r>
           </a:p>
         </p:txBody>
@@ -19992,7 +19987,7 @@
           <p:nvPr/>
         </p:nvPicPr>
         <p:blipFill>
-          <a:blip xmlns:r="http://schemas.openxmlformats.org/officeDocument/2006/relationships" xmlns:a="http://schemas.openxmlformats.org/drawingml/2006/main" r:embed="Rde26da6585144561"/>
+          <a:blip xmlns:r="http://schemas.openxmlformats.org/officeDocument/2006/relationships" xmlns:a="http://schemas.openxmlformats.org/drawingml/2006/main" r:embed="R11d5ca33dc434830"/>
           <a:stretch xmlns:a="http://schemas.openxmlformats.org/drawingml/2006/main">
             <a:fillRect l="0" t="0" r="0" b="0"/>
           </a:stretch>
@@ -20240,7 +20235,7 @@
           <p:nvPr/>
         </p:nvPicPr>
         <p:blipFill>
-          <a:blip xmlns:r="http://schemas.openxmlformats.org/officeDocument/2006/relationships" xmlns:a="http://schemas.openxmlformats.org/drawingml/2006/main" r:embed="Ra085d482f0274594"/>
+          <a:blip xmlns:r="http://schemas.openxmlformats.org/officeDocument/2006/relationships" xmlns:a="http://schemas.openxmlformats.org/drawingml/2006/main" r:embed="R53f420fd02b84aea"/>
           <a:stretch xmlns:a="http://schemas.openxmlformats.org/drawingml/2006/main">
             <a:fillRect l="0" t="0" r="0" b="0"/>
           </a:stretch>
@@ -20306,7 +20301,7 @@
                 <a:ea typeface="Aptos"/>
                 <a:cs typeface="Aptos"/>
               </a:rPr>
-              <a:t>FutureMe AI · Release 0.2.0 · August 2026</a:t>
+              <a:t>FutureMe AI · August 2026</a:t>
             </a:r>
           </a:p>
         </p:txBody>
@@ -22004,7 +21999,7 @@
                 <a:ea typeface="Aptos"/>
                 <a:cs typeface="Aptos"/>
               </a:rPr>
-              <a:t>Repository evidence: release registry · source audit · data coverage · validation plan</a:t>
+              <a:t>Repository evidence: education-data registry · source audit · data coverage · validation plan</a:t>
             </a:r>
           </a:p>
         </p:txBody>
@@ -22040,7 +22035,7 @@
           <p:nvPr/>
         </p:nvPicPr>
         <p:blipFill>
-          <a:blip xmlns:r="http://schemas.openxmlformats.org/officeDocument/2006/relationships" xmlns:a="http://schemas.openxmlformats.org/drawingml/2006/main" r:embed="Rfe96adb62628406a"/>
+          <a:blip xmlns:r="http://schemas.openxmlformats.org/officeDocument/2006/relationships" xmlns:a="http://schemas.openxmlformats.org/drawingml/2006/main" r:embed="Rf20eb8080130403c"/>
           <a:stretch xmlns:a="http://schemas.openxmlformats.org/drawingml/2006/main">
             <a:fillRect l="0" t="0" r="0" b="0"/>
           </a:stretch>
@@ -22288,7 +22283,7 @@
           <p:nvPr/>
         </p:nvPicPr>
         <p:blipFill>
-          <a:blip xmlns:r="http://schemas.openxmlformats.org/officeDocument/2006/relationships" xmlns:a="http://schemas.openxmlformats.org/drawingml/2006/main" r:embed="R27a95bd3dcee4b1f"/>
+          <a:blip xmlns:r="http://schemas.openxmlformats.org/officeDocument/2006/relationships" xmlns:a="http://schemas.openxmlformats.org/drawingml/2006/main" r:embed="R4aa5744b40af4777"/>
           <a:stretch xmlns:a="http://schemas.openxmlformats.org/drawingml/2006/main">
             <a:fillRect l="0" t="0" r="0" b="0"/>
           </a:stretch>
@@ -22354,7 +22349,7 @@
                 <a:ea typeface="Aptos"/>
                 <a:cs typeface="Aptos"/>
               </a:rPr>
-              <a:t>FutureMe AI · Release 0.2.0 · August 2026</a:t>
+              <a:t>FutureMe AI · August 2026</a:t>
             </a:r>
           </a:p>
         </p:txBody>
@@ -24041,7 +24036,7 @@
           <p:nvPr/>
         </p:nvPicPr>
         <p:blipFill>
-          <a:blip xmlns:r="http://schemas.openxmlformats.org/officeDocument/2006/relationships" xmlns:a="http://schemas.openxmlformats.org/drawingml/2006/main" r:embed="R4d656fba090f42c8"/>
+          <a:blip xmlns:r="http://schemas.openxmlformats.org/officeDocument/2006/relationships" xmlns:a="http://schemas.openxmlformats.org/drawingml/2006/main" r:embed="Rfeccae614d184205"/>
           <a:stretch xmlns:a="http://schemas.openxmlformats.org/drawingml/2006/main">
             <a:fillRect l="0" t="0" r="0" b="0"/>
           </a:stretch>
@@ -24289,7 +24284,7 @@
           <p:nvPr/>
         </p:nvPicPr>
         <p:blipFill>
-          <a:blip xmlns:r="http://schemas.openxmlformats.org/officeDocument/2006/relationships" xmlns:a="http://schemas.openxmlformats.org/drawingml/2006/main" r:embed="R79f6135f67e6443e"/>
+          <a:blip xmlns:r="http://schemas.openxmlformats.org/officeDocument/2006/relationships" xmlns:a="http://schemas.openxmlformats.org/drawingml/2006/main" r:embed="R3ed6559832b24eb5"/>
           <a:stretch xmlns:a="http://schemas.openxmlformats.org/drawingml/2006/main">
             <a:fillRect l="0" t="0" r="0" b="0"/>
           </a:stretch>
@@ -24355,7 +24350,7 @@
                 <a:ea typeface="Aptos"/>
                 <a:cs typeface="Aptos"/>
               </a:rPr>
-              <a:t>FutureMe AI · Release 0.2.0 · August 2026</a:t>
+              <a:t>FutureMe AI · August 2026</a:t>
             </a:r>
           </a:p>
         </p:txBody>
@@ -25450,7 +25445,7 @@
           <p:nvPr/>
         </p:nvPicPr>
         <p:blipFill>
-          <a:blip xmlns:r="http://schemas.openxmlformats.org/officeDocument/2006/relationships" xmlns:a="http://schemas.openxmlformats.org/drawingml/2006/main" r:embed="Rab9eefa8f37f4fe3"/>
+          <a:blip xmlns:r="http://schemas.openxmlformats.org/officeDocument/2006/relationships" xmlns:a="http://schemas.openxmlformats.org/drawingml/2006/main" r:embed="R02bfde9516bf4495"/>
           <a:stretch xmlns:a="http://schemas.openxmlformats.org/drawingml/2006/main">
             <a:fillRect l="0" t="0" r="0" b="0"/>
           </a:stretch>
@@ -25698,7 +25693,7 @@
           <p:nvPr/>
         </p:nvPicPr>
         <p:blipFill>
-          <a:blip xmlns:r="http://schemas.openxmlformats.org/officeDocument/2006/relationships" xmlns:a="http://schemas.openxmlformats.org/drawingml/2006/main" r:embed="Ra44780993c5d4702"/>
+          <a:blip xmlns:r="http://schemas.openxmlformats.org/officeDocument/2006/relationships" xmlns:a="http://schemas.openxmlformats.org/drawingml/2006/main" r:embed="R3f53856623cf4abe"/>
           <a:stretch xmlns:a="http://schemas.openxmlformats.org/drawingml/2006/main">
             <a:fillRect l="0" t="0" r="0" b="0"/>
           </a:stretch>
@@ -25764,7 +25759,7 @@
                 <a:ea typeface="Aptos"/>
                 <a:cs typeface="Aptos"/>
               </a:rPr>
-              <a:t>FutureMe AI · Release 0.2.0 · August 2026</a:t>
+              <a:t>FutureMe AI · August 2026</a:t>
             </a:r>
           </a:p>
         </p:txBody>
@@ -27560,7 +27555,7 @@
                 <a:ea typeface="Aptos"/>
                 <a:cs typeface="Aptos"/>
               </a:rPr>
-              <a:t>Sources: education-data-registry v0.2.0 + MHESI/OVEC; checked 11 Aug 2026</a:t>
+              <a:t>Sources: education-data registry + MHESI/OVEC; checked 11 Aug 2026</a:t>
             </a:r>
           </a:p>
         </p:txBody>
@@ -27596,7 +27591,7 @@
           <p:nvPr/>
         </p:nvPicPr>
         <p:blipFill>
-          <a:blip xmlns:r="http://schemas.openxmlformats.org/officeDocument/2006/relationships" xmlns:a="http://schemas.openxmlformats.org/drawingml/2006/main" r:embed="Rc69f8ffdf5ef4780"/>
+          <a:blip xmlns:r="http://schemas.openxmlformats.org/officeDocument/2006/relationships" xmlns:a="http://schemas.openxmlformats.org/drawingml/2006/main" r:embed="R4ab2b85b88e14fcc"/>
           <a:stretch xmlns:a="http://schemas.openxmlformats.org/drawingml/2006/main">
             <a:fillRect l="0" t="0" r="0" b="0"/>
           </a:stretch>
@@ -27844,7 +27839,7 @@
           <p:nvPr/>
         </p:nvPicPr>
         <p:blipFill>
-          <a:blip xmlns:r="http://schemas.openxmlformats.org/officeDocument/2006/relationships" xmlns:a="http://schemas.openxmlformats.org/drawingml/2006/main" r:embed="R3d3455f4f1f74b61"/>
+          <a:blip xmlns:r="http://schemas.openxmlformats.org/officeDocument/2006/relationships" xmlns:a="http://schemas.openxmlformats.org/drawingml/2006/main" r:embed="Ra506c3dd1a8240ad"/>
           <a:stretch xmlns:a="http://schemas.openxmlformats.org/drawingml/2006/main">
             <a:fillRect l="0" t="0" r="0" b="0"/>
           </a:stretch>
@@ -27910,7 +27905,7 @@
                 <a:ea typeface="Aptos"/>
                 <a:cs typeface="Aptos"/>
               </a:rPr>
-              <a:t>FutureMe AI · Release 0.2.0 · August 2026</a:t>
+              <a:t>FutureMe AI · August 2026</a:t>
             </a:r>
           </a:p>
         </p:txBody>
@@ -29522,7 +29517,7 @@
           <p:nvPr/>
         </p:nvPicPr>
         <p:blipFill>
-          <a:blip xmlns:r="http://schemas.openxmlformats.org/officeDocument/2006/relationships" xmlns:a="http://schemas.openxmlformats.org/drawingml/2006/main" r:embed="R42f202a08a824946"/>
+          <a:blip xmlns:r="http://schemas.openxmlformats.org/officeDocument/2006/relationships" xmlns:a="http://schemas.openxmlformats.org/drawingml/2006/main" r:embed="R8faab83f2b524ff3"/>
           <a:stretch xmlns:a="http://schemas.openxmlformats.org/drawingml/2006/main">
             <a:fillRect l="0" t="0" r="0" b="0"/>
           </a:stretch>
@@ -29770,7 +29765,7 @@
           <p:nvPr/>
         </p:nvPicPr>
         <p:blipFill>
-          <a:blip xmlns:r="http://schemas.openxmlformats.org/officeDocument/2006/relationships" xmlns:a="http://schemas.openxmlformats.org/drawingml/2006/main" r:embed="Rfb3e2a5132a34f68"/>
+          <a:blip xmlns:r="http://schemas.openxmlformats.org/officeDocument/2006/relationships" xmlns:a="http://schemas.openxmlformats.org/drawingml/2006/main" r:embed="R5046bc238cd64d0a"/>
           <a:stretch xmlns:a="http://schemas.openxmlformats.org/drawingml/2006/main">
             <a:fillRect l="0" t="0" r="0" b="0"/>
           </a:stretch>
@@ -29836,7 +29831,7 @@
                 <a:ea typeface="Aptos"/>
                 <a:cs typeface="Aptos"/>
               </a:rPr>
-              <a:t>FutureMe AI · Release 0.2.0 · August 2026</a:t>
+              <a:t>FutureMe AI · August 2026</a:t>
             </a:r>
           </a:p>
         </p:txBody>
@@ -32089,7 +32084,7 @@
           <p:nvPr/>
         </p:nvPicPr>
         <p:blipFill>
-          <a:blip xmlns:r="http://schemas.openxmlformats.org/officeDocument/2006/relationships" xmlns:a="http://schemas.openxmlformats.org/drawingml/2006/main" r:embed="R8bf7cac975d74094"/>
+          <a:blip xmlns:r="http://schemas.openxmlformats.org/officeDocument/2006/relationships" xmlns:a="http://schemas.openxmlformats.org/drawingml/2006/main" r:embed="R24289b7863e24355"/>
           <a:stretch xmlns:a="http://schemas.openxmlformats.org/drawingml/2006/main">
             <a:fillRect l="0" t="0" r="0" b="0"/>
           </a:stretch>
@@ -32337,7 +32332,7 @@
           <p:nvPr/>
         </p:nvPicPr>
         <p:blipFill>
-          <a:blip xmlns:r="http://schemas.openxmlformats.org/officeDocument/2006/relationships" xmlns:a="http://schemas.openxmlformats.org/drawingml/2006/main" r:embed="R8607380789184abf"/>
+          <a:blip xmlns:r="http://schemas.openxmlformats.org/officeDocument/2006/relationships" xmlns:a="http://schemas.openxmlformats.org/drawingml/2006/main" r:embed="Rb784e054203d4bfb"/>
           <a:stretch xmlns:a="http://schemas.openxmlformats.org/drawingml/2006/main">
             <a:fillRect l="0" t="0" r="0" b="0"/>
           </a:stretch>
@@ -32403,7 +32398,7 @@
                 <a:ea typeface="Aptos"/>
                 <a:cs typeface="Aptos"/>
               </a:rPr>
-              <a:t>FutureMe AI · Release 0.2.0 · August 2026</a:t>
+              <a:t>FutureMe AI · August 2026</a:t>
             </a:r>
           </a:p>
         </p:txBody>
@@ -33941,7 +33936,7 @@
           <p:nvPr/>
         </p:nvPicPr>
         <p:blipFill>
-          <a:blip xmlns:r="http://schemas.openxmlformats.org/officeDocument/2006/relationships" xmlns:a="http://schemas.openxmlformats.org/drawingml/2006/main" r:embed="Rb6c3d7cfed114a1c"/>
+          <a:blip xmlns:r="http://schemas.openxmlformats.org/officeDocument/2006/relationships" xmlns:a="http://schemas.openxmlformats.org/drawingml/2006/main" r:embed="R80e861e327374885"/>
           <a:stretch xmlns:a="http://schemas.openxmlformats.org/drawingml/2006/main">
             <a:fillRect l="0" t="0" r="0" b="0"/>
           </a:stretch>
@@ -34189,7 +34184,7 @@
           <p:nvPr/>
         </p:nvPicPr>
         <p:blipFill>
-          <a:blip xmlns:r="http://schemas.openxmlformats.org/officeDocument/2006/relationships" xmlns:a="http://schemas.openxmlformats.org/drawingml/2006/main" r:embed="R31e44e94921944a6"/>
+          <a:blip xmlns:r="http://schemas.openxmlformats.org/officeDocument/2006/relationships" xmlns:a="http://schemas.openxmlformats.org/drawingml/2006/main" r:embed="R14c9927ab49448ce"/>
           <a:stretch xmlns:a="http://schemas.openxmlformats.org/drawingml/2006/main">
             <a:fillRect l="0" t="0" r="0" b="0"/>
           </a:stretch>
@@ -34255,7 +34250,7 @@
                 <a:ea typeface="Aptos"/>
                 <a:cs typeface="Aptos"/>
               </a:rPr>
-              <a:t>FutureMe AI · Release 0.2.0 · August 2026</a:t>
+              <a:t>FutureMe AI · August 2026</a:t>
             </a:r>
           </a:p>
         </p:txBody>
@@ -35872,7 +35867,7 @@
           <p:nvPr/>
         </p:nvPicPr>
         <p:blipFill>
-          <a:blip xmlns:r="http://schemas.openxmlformats.org/officeDocument/2006/relationships" xmlns:a="http://schemas.openxmlformats.org/drawingml/2006/main" r:embed="R16014cd9d93c4c9a"/>
+          <a:blip xmlns:r="http://schemas.openxmlformats.org/officeDocument/2006/relationships" xmlns:a="http://schemas.openxmlformats.org/drawingml/2006/main" r:embed="R830096a89e6b4c6b"/>
           <a:stretch xmlns:a="http://schemas.openxmlformats.org/drawingml/2006/main">
             <a:fillRect l="0" t="0" r="0" b="0"/>
           </a:stretch>
@@ -36120,7 +36115,7 @@
           <p:nvPr/>
         </p:nvPicPr>
         <p:blipFill>
-          <a:blip xmlns:r="http://schemas.openxmlformats.org/officeDocument/2006/relationships" xmlns:a="http://schemas.openxmlformats.org/drawingml/2006/main" r:embed="Rdb44bd1cffd94b89"/>
+          <a:blip xmlns:r="http://schemas.openxmlformats.org/officeDocument/2006/relationships" xmlns:a="http://schemas.openxmlformats.org/drawingml/2006/main" r:embed="R8b623cb5333346e5"/>
           <a:stretch xmlns:a="http://schemas.openxmlformats.org/drawingml/2006/main">
             <a:fillRect l="0" t="0" r="0" b="0"/>
           </a:stretch>
@@ -36186,7 +36181,7 @@
                 <a:ea typeface="Aptos"/>
                 <a:cs typeface="Aptos"/>
               </a:rPr>
-              <a:t>FutureMe AI · Release 0.2.0 · August 2026</a:t>
+              <a:t>FutureMe AI · August 2026</a:t>
             </a:r>
           </a:p>
         </p:txBody>

</xml_diff>